<commit_message>
Alignment Brigade replaced by the collective intelligence for execution discipline (Units 3-7, 9, 12)
</commit_message>
<xml_diff>
--- a/Unit decks/Unit 06 - Performance Management Setup.pptx
+++ b/Unit decks/Unit 06 - Performance Management Setup.pptx
@@ -1977,12 +1977,12 @@
           <a:p>
             <a:r>
               <a:rPr lang="en-US" dirty="0"/>
-              <a:t>3.1 — THE ALIGNMENT BRIGADE (Executive team as PM system)
-</a:t>
+              <a:t>3.1 — THE COLLECTIVE INTELLIGENCE FOR EXECUTION DISCIPLINE (Executive team as PM system)
+Every leader carries deep professional instincts about what “progress” looks like. </a:t>
             </a:r>
             <a:r>
               <a:rPr dirty="0"/>
-              <a:t>Every leader carries deep professional instincts about what “progress” looks like. </a:t>
+              <a:t/>
             </a:r>
             <a:endParaRPr lang="en-ZA" dirty="0"/>
           </a:p>
@@ -3383,7 +3383,7 @@
           <a:p>
             <a:r>
               <a:rPr lang="en-GB" dirty="0"/>
-              <a:t>Step 4 needs the group’s Enterprise OKRs. Each group confirms them in Unit 3, part 4.2, first.</a:t>
+              <a:t>Step 4 needs the group’s Enterprise OKRs. Each group confirms them in Unit 3, part 5.2, first.</a:t>
             </a:r>
           </a:p>
         </p:txBody>
@@ -12442,7 +12442,7 @@
                 <a:ea typeface="Calibri" pitchFamily="34" charset="-122"/>
                 <a:cs typeface="Calibri" pitchFamily="34" charset="-120"/>
               </a:rPr>
-              <a:t>3.1 · The Alignment Brigade</a:t>
+              <a:t>3.1 · The Collective Intelligence for Execution Discipline</a:t>
             </a:r>
             <a:endParaRPr lang="en-US" sz="2600" dirty="0"/>
           </a:p>
@@ -15953,6 +15953,2328 @@
 
 <file path=ppt/slides/slide24.xml><?xml version="1.0" encoding="utf-8"?>
 <p:sld xmlns:a="http://schemas.openxmlformats.org/drawingml/2006/main" xmlns:r="http://schemas.openxmlformats.org/officeDocument/2006/relationships" xmlns:p="http://schemas.openxmlformats.org/presentationml/2006/main">
+  <p:cSld name="Slide 26">
+    <p:bg>
+      <p:bgPr>
+        <a:solidFill>
+          <a:srgbClr val="FFFFFF"/>
+        </a:solidFill>
+        <a:effectLst/>
+      </p:bgPr>
+    </p:bg>
+    <p:spTree>
+      <p:nvGrpSpPr>
+        <p:cNvPr id="1" name=""/>
+        <p:cNvGrpSpPr/>
+        <p:nvPr/>
+      </p:nvGrpSpPr>
+      <p:grpSpPr>
+        <a:xfrm>
+          <a:off x="0" y="0"/>
+          <a:ext cx="0" cy="0"/>
+          <a:chOff x="0" y="0"/>
+          <a:chExt cx="0" cy="0"/>
+        </a:xfrm>
+      </p:grpSpPr>
+      <p:sp>
+        <p:nvSpPr>
+          <p:cNvPr id="2" name="Text 0"/>
+          <p:cNvSpPr txBox="1"/>
+          <p:nvPr/>
+        </p:nvSpPr>
+        <p:spPr>
+          <a:xfrm>
+            <a:off x="548640" y="411480"/>
+            <a:ext cx="11064240" cy="868680"/>
+          </a:xfrm>
+          <a:prstGeom prst="rect">
+            <a:avLst/>
+          </a:prstGeom>
+          <a:noFill/>
+          <a:ln/>
+        </p:spPr>
+        <p:txBody>
+          <a:bodyPr wrap="square" lIns="0" tIns="0" rIns="0" bIns="0" rtlCol="0" anchor="ctr"/>
+          <a:lstStyle/>
+          <a:p>
+            <a:pPr marL="0" indent="0">
+              <a:buNone/>
+            </a:pPr>
+            <a:r>
+              <a:rPr lang="en-US" sz="3600" b="1" dirty="0">
+                <a:solidFill>
+                  <a:srgbClr val="1A5C2C"/>
+                </a:solidFill>
+                <a:latin typeface="Cambria" pitchFamily="34" charset="0"/>
+                <a:ea typeface="Cambria" pitchFamily="34" charset="-122"/>
+                <a:cs typeface="Cambria" pitchFamily="34" charset="-120"/>
+              </a:rPr>
+              <a:t>Step 1 · Scoring Logic</a:t>
+            </a:r>
+            <a:endParaRPr lang="en-US" sz="3600" dirty="0"/>
+          </a:p>
+        </p:txBody>
+      </p:sp>
+      <p:sp>
+        <p:nvSpPr>
+          <p:cNvPr id="3" name="Shape 1"/>
+          <p:cNvSpPr/>
+          <p:nvPr/>
+        </p:nvSpPr>
+        <p:spPr>
+          <a:xfrm>
+            <a:off x="548640" y="1631061"/>
+            <a:ext cx="570738" cy="570738"/>
+          </a:xfrm>
+          <a:prstGeom prst="ellipse">
+            <a:avLst/>
+          </a:prstGeom>
+          <a:solidFill>
+            <a:srgbClr val="1A5C2C"/>
+          </a:solidFill>
+          <a:ln w="12700">
+            <a:solidFill>
+              <a:srgbClr val="1A5C2C"/>
+            </a:solidFill>
+            <a:prstDash val="solid"/>
+          </a:ln>
+        </p:spPr>
+        <p:txBody>
+          <a:bodyPr/>
+          <a:lstStyle/>
+          <a:p>
+            <a:endParaRPr lang="en-ZA"/>
+          </a:p>
+        </p:txBody>
+      </p:sp>
+      <p:pic>
+        <p:nvPicPr>
+          <p:cNvPr id="4" name="Image 0" descr="preencoded.png"/>
+          <p:cNvPicPr>
+            <a:picLocks noChangeAspect="1"/>
+          </p:cNvPicPr>
+          <p:nvPr/>
+        </p:nvPicPr>
+        <p:blipFill>
+          <a:blip r:embed="rId3"/>
+          <a:stretch>
+            <a:fillRect/>
+          </a:stretch>
+        </p:blipFill>
+        <p:spPr>
+          <a:xfrm>
+            <a:off x="691325" y="1773746"/>
+            <a:ext cx="285369" cy="285369"/>
+          </a:xfrm>
+          <a:prstGeom prst="rect">
+            <a:avLst/>
+          </a:prstGeom>
+        </p:spPr>
+      </p:pic>
+      <p:sp>
+        <p:nvSpPr>
+          <p:cNvPr id="5" name="Text 2"/>
+          <p:cNvSpPr txBox="1"/>
+          <p:nvPr/>
+        </p:nvSpPr>
+        <p:spPr>
+          <a:xfrm>
+            <a:off x="1439418" y="1508760"/>
+            <a:ext cx="10200894" cy="815340"/>
+          </a:xfrm>
+          <a:prstGeom prst="rect">
+            <a:avLst/>
+          </a:prstGeom>
+          <a:noFill/>
+          <a:ln/>
+        </p:spPr>
+        <p:txBody>
+          <a:bodyPr wrap="square" lIns="0" tIns="0" rIns="0" bIns="0" rtlCol="0" anchor="ctr"/>
+          <a:lstStyle/>
+          <a:p>
+            <a:pPr marL="0" indent="0">
+              <a:buNone/>
+            </a:pPr>
+            <a:r>
+              <a:rPr lang="en-US" sz="2400" b="1" dirty="0">
+                <a:solidFill>
+                  <a:srgbClr val="1A5C2C"/>
+                </a:solidFill>
+                <a:latin typeface="Cambria" pitchFamily="34" charset="0"/>
+                <a:ea typeface="Cambria" pitchFamily="34" charset="-122"/>
+                <a:cs typeface="Cambria" pitchFamily="34" charset="-120"/>
+              </a:rPr>
+              <a:t>1  </a:t>
+            </a:r>
+            <a:r>
+              <a:rPr lang="en-US" sz="2400" dirty="0">
+                <a:solidFill>
+                  <a:srgbClr val="1F2A22"/>
+                </a:solidFill>
+                <a:latin typeface="Calibri" pitchFamily="34" charset="0"/>
+                <a:ea typeface="Calibri" pitchFamily="34" charset="-122"/>
+                <a:cs typeface="Calibri" pitchFamily="34" charset="-120"/>
+              </a:rPr>
+              <a:t>Performance level that earns this rating</a:t>
+            </a:r>
+            <a:endParaRPr lang="en-US" sz="2400" dirty="0"/>
+          </a:p>
+        </p:txBody>
+      </p:sp>
+      <p:sp>
+        <p:nvSpPr>
+          <p:cNvPr id="6" name="Shape 3"/>
+          <p:cNvSpPr/>
+          <p:nvPr/>
+        </p:nvSpPr>
+        <p:spPr>
+          <a:xfrm>
+            <a:off x="548640" y="2446401"/>
+            <a:ext cx="570738" cy="570738"/>
+          </a:xfrm>
+          <a:prstGeom prst="ellipse">
+            <a:avLst/>
+          </a:prstGeom>
+          <a:solidFill>
+            <a:srgbClr val="1A5C2C"/>
+          </a:solidFill>
+          <a:ln w="12700">
+            <a:solidFill>
+              <a:srgbClr val="1A5C2C"/>
+            </a:solidFill>
+            <a:prstDash val="solid"/>
+          </a:ln>
+        </p:spPr>
+        <p:txBody>
+          <a:bodyPr/>
+          <a:lstStyle/>
+          <a:p>
+            <a:endParaRPr lang="en-ZA"/>
+          </a:p>
+        </p:txBody>
+      </p:sp>
+      <p:pic>
+        <p:nvPicPr>
+          <p:cNvPr id="7" name="Image 1" descr="preencoded.png"/>
+          <p:cNvPicPr>
+            <a:picLocks noChangeAspect="1"/>
+          </p:cNvPicPr>
+          <p:nvPr/>
+        </p:nvPicPr>
+        <p:blipFill>
+          <a:blip r:embed="rId4"/>
+          <a:stretch>
+            <a:fillRect/>
+          </a:stretch>
+        </p:blipFill>
+        <p:spPr>
+          <a:xfrm>
+            <a:off x="691325" y="2589085"/>
+            <a:ext cx="285369" cy="285369"/>
+          </a:xfrm>
+          <a:prstGeom prst="rect">
+            <a:avLst/>
+          </a:prstGeom>
+        </p:spPr>
+      </p:pic>
+      <p:sp>
+        <p:nvSpPr>
+          <p:cNvPr id="8" name="Text 4"/>
+          <p:cNvSpPr txBox="1"/>
+          <p:nvPr/>
+        </p:nvSpPr>
+        <p:spPr>
+          <a:xfrm>
+            <a:off x="1439418" y="2324100"/>
+            <a:ext cx="10200894" cy="815340"/>
+          </a:xfrm>
+          <a:prstGeom prst="rect">
+            <a:avLst/>
+          </a:prstGeom>
+          <a:noFill/>
+          <a:ln/>
+        </p:spPr>
+        <p:txBody>
+          <a:bodyPr wrap="square" lIns="0" tIns="0" rIns="0" bIns="0" rtlCol="0" anchor="ctr"/>
+          <a:lstStyle/>
+          <a:p>
+            <a:pPr marL="0" indent="0">
+              <a:buNone/>
+            </a:pPr>
+            <a:r>
+              <a:rPr lang="en-US" sz="2400" b="1" dirty="0">
+                <a:solidFill>
+                  <a:srgbClr val="1A5C2C"/>
+                </a:solidFill>
+                <a:latin typeface="Cambria" pitchFamily="34" charset="0"/>
+                <a:ea typeface="Cambria" pitchFamily="34" charset="-122"/>
+                <a:cs typeface="Cambria" pitchFamily="34" charset="-120"/>
+              </a:rPr>
+              <a:t>2  </a:t>
+            </a:r>
+            <a:r>
+              <a:rPr lang="en-US" sz="2400" dirty="0">
+                <a:solidFill>
+                  <a:srgbClr val="1F2A22"/>
+                </a:solidFill>
+                <a:latin typeface="Calibri" pitchFamily="34" charset="0"/>
+                <a:ea typeface="Calibri" pitchFamily="34" charset="-122"/>
+                <a:cs typeface="Calibri" pitchFamily="34" charset="-120"/>
+              </a:rPr>
+              <a:t>Evidence required to confirm it</a:t>
+            </a:r>
+            <a:endParaRPr lang="en-US" sz="2400" dirty="0"/>
+          </a:p>
+        </p:txBody>
+      </p:sp>
+      <p:sp>
+        <p:nvSpPr>
+          <p:cNvPr id="9" name="Shape 5"/>
+          <p:cNvSpPr/>
+          <p:nvPr/>
+        </p:nvSpPr>
+        <p:spPr>
+          <a:xfrm>
+            <a:off x="548640" y="3261741"/>
+            <a:ext cx="570738" cy="570738"/>
+          </a:xfrm>
+          <a:prstGeom prst="ellipse">
+            <a:avLst/>
+          </a:prstGeom>
+          <a:solidFill>
+            <a:srgbClr val="1A5C2C"/>
+          </a:solidFill>
+          <a:ln w="12700">
+            <a:solidFill>
+              <a:srgbClr val="1A5C2C"/>
+            </a:solidFill>
+            <a:prstDash val="solid"/>
+          </a:ln>
+        </p:spPr>
+        <p:txBody>
+          <a:bodyPr/>
+          <a:lstStyle/>
+          <a:p>
+            <a:endParaRPr lang="en-ZA"/>
+          </a:p>
+        </p:txBody>
+      </p:sp>
+      <p:pic>
+        <p:nvPicPr>
+          <p:cNvPr id="10" name="Image 2" descr="preencoded.png"/>
+          <p:cNvPicPr>
+            <a:picLocks noChangeAspect="1"/>
+          </p:cNvPicPr>
+          <p:nvPr/>
+        </p:nvPicPr>
+        <p:blipFill>
+          <a:blip r:embed="rId5"/>
+          <a:stretch>
+            <a:fillRect/>
+          </a:stretch>
+        </p:blipFill>
+        <p:spPr>
+          <a:xfrm>
+            <a:off x="691325" y="3404425"/>
+            <a:ext cx="285369" cy="285369"/>
+          </a:xfrm>
+          <a:prstGeom prst="rect">
+            <a:avLst/>
+          </a:prstGeom>
+        </p:spPr>
+      </p:pic>
+      <p:sp>
+        <p:nvSpPr>
+          <p:cNvPr id="11" name="Text 6"/>
+          <p:cNvSpPr txBox="1"/>
+          <p:nvPr/>
+        </p:nvSpPr>
+        <p:spPr>
+          <a:xfrm>
+            <a:off x="1439418" y="3139440"/>
+            <a:ext cx="10200894" cy="815340"/>
+          </a:xfrm>
+          <a:prstGeom prst="rect">
+            <a:avLst/>
+          </a:prstGeom>
+          <a:noFill/>
+          <a:ln/>
+        </p:spPr>
+        <p:txBody>
+          <a:bodyPr wrap="square" lIns="0" tIns="0" rIns="0" bIns="0" rtlCol="0" anchor="ctr"/>
+          <a:lstStyle/>
+          <a:p>
+            <a:pPr marL="0" indent="0">
+              <a:buNone/>
+            </a:pPr>
+            <a:r>
+              <a:rPr lang="en-US" sz="2400" b="1" dirty="0">
+                <a:solidFill>
+                  <a:srgbClr val="1A5C2C"/>
+                </a:solidFill>
+                <a:latin typeface="Cambria" pitchFamily="34" charset="0"/>
+                <a:ea typeface="Cambria" pitchFamily="34" charset="-122"/>
+                <a:cs typeface="Cambria" pitchFamily="34" charset="-120"/>
+              </a:rPr>
+              <a:t>3  </a:t>
+            </a:r>
+            <a:r>
+              <a:rPr lang="en-US" sz="2400" dirty="0">
+                <a:solidFill>
+                  <a:srgbClr val="1F2A22"/>
+                </a:solidFill>
+                <a:latin typeface="Calibri" pitchFamily="34" charset="0"/>
+                <a:ea typeface="Calibri" pitchFamily="34" charset="-122"/>
+                <a:cs typeface="Calibri" pitchFamily="34" charset="-120"/>
+              </a:rPr>
+              <a:t>Contextual factors that might legitimately affect a rating</a:t>
+            </a:r>
+            <a:endParaRPr lang="en-US" sz="2400" dirty="0"/>
+          </a:p>
+        </p:txBody>
+      </p:sp>
+      <p:sp>
+        <p:nvSpPr>
+          <p:cNvPr id="12" name="Shape 7"/>
+          <p:cNvSpPr/>
+          <p:nvPr/>
+        </p:nvSpPr>
+        <p:spPr>
+          <a:xfrm>
+            <a:off x="548640" y="4077081"/>
+            <a:ext cx="570738" cy="570738"/>
+          </a:xfrm>
+          <a:prstGeom prst="ellipse">
+            <a:avLst/>
+          </a:prstGeom>
+          <a:solidFill>
+            <a:srgbClr val="1A5C2C"/>
+          </a:solidFill>
+          <a:ln w="12700">
+            <a:solidFill>
+              <a:srgbClr val="1A5C2C"/>
+            </a:solidFill>
+            <a:prstDash val="solid"/>
+          </a:ln>
+        </p:spPr>
+        <p:txBody>
+          <a:bodyPr/>
+          <a:lstStyle/>
+          <a:p>
+            <a:endParaRPr lang="en-ZA"/>
+          </a:p>
+        </p:txBody>
+      </p:sp>
+      <p:pic>
+        <p:nvPicPr>
+          <p:cNvPr id="13" name="Image 3" descr="preencoded.png"/>
+          <p:cNvPicPr>
+            <a:picLocks noChangeAspect="1"/>
+          </p:cNvPicPr>
+          <p:nvPr/>
+        </p:nvPicPr>
+        <p:blipFill>
+          <a:blip r:embed="rId6"/>
+          <a:stretch>
+            <a:fillRect/>
+          </a:stretch>
+        </p:blipFill>
+        <p:spPr>
+          <a:xfrm>
+            <a:off x="691325" y="4219766"/>
+            <a:ext cx="285369" cy="285369"/>
+          </a:xfrm>
+          <a:prstGeom prst="rect">
+            <a:avLst/>
+          </a:prstGeom>
+        </p:spPr>
+      </p:pic>
+      <p:sp>
+        <p:nvSpPr>
+          <p:cNvPr id="14" name="Text 8"/>
+          <p:cNvSpPr txBox="1"/>
+          <p:nvPr/>
+        </p:nvSpPr>
+        <p:spPr>
+          <a:xfrm>
+            <a:off x="1439418" y="3954780"/>
+            <a:ext cx="10200894" cy="815340"/>
+          </a:xfrm>
+          <a:prstGeom prst="rect">
+            <a:avLst/>
+          </a:prstGeom>
+          <a:noFill/>
+          <a:ln/>
+        </p:spPr>
+        <p:txBody>
+          <a:bodyPr wrap="square" lIns="0" tIns="0" rIns="0" bIns="0" rtlCol="0" anchor="ctr"/>
+          <a:lstStyle/>
+          <a:p>
+            <a:pPr marL="0" indent="0">
+              <a:buNone/>
+            </a:pPr>
+            <a:r>
+              <a:rPr lang="en-US" sz="2400" b="1" dirty="0">
+                <a:solidFill>
+                  <a:srgbClr val="1A5C2C"/>
+                </a:solidFill>
+                <a:latin typeface="Cambria" pitchFamily="34" charset="0"/>
+                <a:ea typeface="Cambria" pitchFamily="34" charset="-122"/>
+                <a:cs typeface="Cambria" pitchFamily="34" charset="-120"/>
+              </a:rPr>
+              <a:t>4  </a:t>
+            </a:r>
+            <a:r>
+              <a:rPr lang="en-US" sz="2400" dirty="0">
+                <a:solidFill>
+                  <a:srgbClr val="1F2A22"/>
+                </a:solidFill>
+                <a:latin typeface="Calibri" pitchFamily="34" charset="0"/>
+                <a:ea typeface="Calibri" pitchFamily="34" charset="-122"/>
+                <a:cs typeface="Calibri" pitchFamily="34" charset="-120"/>
+              </a:rPr>
+              <a:t>Lines of sight of progress</a:t>
+            </a:r>
+            <a:endParaRPr lang="en-US" sz="2400" dirty="0"/>
+          </a:p>
+        </p:txBody>
+      </p:sp>
+      <p:sp>
+        <p:nvSpPr>
+          <p:cNvPr id="15" name="Shape 9"/>
+          <p:cNvSpPr/>
+          <p:nvPr/>
+        </p:nvSpPr>
+        <p:spPr>
+          <a:xfrm>
+            <a:off x="548640" y="4892421"/>
+            <a:ext cx="570738" cy="570738"/>
+          </a:xfrm>
+          <a:prstGeom prst="ellipse">
+            <a:avLst/>
+          </a:prstGeom>
+          <a:solidFill>
+            <a:srgbClr val="1A5C2C"/>
+          </a:solidFill>
+          <a:ln w="12700">
+            <a:solidFill>
+              <a:srgbClr val="1A5C2C"/>
+            </a:solidFill>
+            <a:prstDash val="solid"/>
+          </a:ln>
+        </p:spPr>
+        <p:txBody>
+          <a:bodyPr/>
+          <a:lstStyle/>
+          <a:p>
+            <a:endParaRPr lang="en-ZA"/>
+          </a:p>
+        </p:txBody>
+      </p:sp>
+      <p:pic>
+        <p:nvPicPr>
+          <p:cNvPr id="16" name="Image 4" descr="preencoded.png"/>
+          <p:cNvPicPr>
+            <a:picLocks noChangeAspect="1"/>
+          </p:cNvPicPr>
+          <p:nvPr/>
+        </p:nvPicPr>
+        <p:blipFill>
+          <a:blip r:embed="rId7"/>
+          <a:stretch>
+            <a:fillRect/>
+          </a:stretch>
+        </p:blipFill>
+        <p:spPr>
+          <a:xfrm>
+            <a:off x="691325" y="5035106"/>
+            <a:ext cx="285369" cy="285369"/>
+          </a:xfrm>
+          <a:prstGeom prst="rect">
+            <a:avLst/>
+          </a:prstGeom>
+        </p:spPr>
+      </p:pic>
+      <p:sp>
+        <p:nvSpPr>
+          <p:cNvPr id="17" name="Text 10"/>
+          <p:cNvSpPr txBox="1"/>
+          <p:nvPr/>
+        </p:nvSpPr>
+        <p:spPr>
+          <a:xfrm>
+            <a:off x="1439418" y="4770120"/>
+            <a:ext cx="10200894" cy="815340"/>
+          </a:xfrm>
+          <a:prstGeom prst="rect">
+            <a:avLst/>
+          </a:prstGeom>
+          <a:noFill/>
+          <a:ln/>
+        </p:spPr>
+        <p:txBody>
+          <a:bodyPr wrap="square" lIns="0" tIns="0" rIns="0" bIns="0" rtlCol="0" anchor="ctr"/>
+          <a:lstStyle/>
+          <a:p>
+            <a:pPr marL="0" indent="0">
+              <a:buNone/>
+            </a:pPr>
+            <a:r>
+              <a:rPr lang="en-US" sz="2400" b="1" dirty="0">
+                <a:solidFill>
+                  <a:srgbClr val="1A5C2C"/>
+                </a:solidFill>
+                <a:latin typeface="Cambria" pitchFamily="34" charset="0"/>
+                <a:ea typeface="Cambria" pitchFamily="34" charset="-122"/>
+                <a:cs typeface="Cambria" pitchFamily="34" charset="-120"/>
+              </a:rPr>
+              <a:t>5  </a:t>
+            </a:r>
+            <a:r>
+              <a:rPr lang="en-US" sz="2400" dirty="0">
+                <a:solidFill>
+                  <a:srgbClr val="1F2A22"/>
+                </a:solidFill>
+                <a:latin typeface="Calibri" pitchFamily="34" charset="0"/>
+                <a:ea typeface="Calibri" pitchFamily="34" charset="-122"/>
+                <a:cs typeface="Calibri" pitchFamily="34" charset="-120"/>
+              </a:rPr>
+              <a:t>Review cadence and why</a:t>
+            </a:r>
+            <a:endParaRPr lang="en-US" sz="2400" dirty="0"/>
+          </a:p>
+        </p:txBody>
+      </p:sp>
+      <p:sp>
+        <p:nvSpPr>
+          <p:cNvPr id="18" name="Shape 11"/>
+          <p:cNvSpPr/>
+          <p:nvPr/>
+        </p:nvSpPr>
+        <p:spPr>
+          <a:xfrm>
+            <a:off x="548640" y="5707761"/>
+            <a:ext cx="570738" cy="570738"/>
+          </a:xfrm>
+          <a:prstGeom prst="ellipse">
+            <a:avLst/>
+          </a:prstGeom>
+          <a:solidFill>
+            <a:srgbClr val="1A5C2C"/>
+          </a:solidFill>
+          <a:ln w="12700">
+            <a:solidFill>
+              <a:srgbClr val="1A5C2C"/>
+            </a:solidFill>
+            <a:prstDash val="solid"/>
+          </a:ln>
+        </p:spPr>
+        <p:txBody>
+          <a:bodyPr/>
+          <a:lstStyle/>
+          <a:p>
+            <a:endParaRPr lang="en-ZA"/>
+          </a:p>
+        </p:txBody>
+      </p:sp>
+      <p:pic>
+        <p:nvPicPr>
+          <p:cNvPr id="19" name="Image 5" descr="preencoded.png"/>
+          <p:cNvPicPr>
+            <a:picLocks noChangeAspect="1"/>
+          </p:cNvPicPr>
+          <p:nvPr/>
+        </p:nvPicPr>
+        <p:blipFill>
+          <a:blip r:embed="rId8"/>
+          <a:stretch>
+            <a:fillRect/>
+          </a:stretch>
+        </p:blipFill>
+        <p:spPr>
+          <a:xfrm>
+            <a:off x="691325" y="5850445"/>
+            <a:ext cx="285369" cy="285369"/>
+          </a:xfrm>
+          <a:prstGeom prst="rect">
+            <a:avLst/>
+          </a:prstGeom>
+        </p:spPr>
+      </p:pic>
+      <p:sp>
+        <p:nvSpPr>
+          <p:cNvPr id="20" name="Text 12"/>
+          <p:cNvSpPr txBox="1"/>
+          <p:nvPr/>
+        </p:nvSpPr>
+        <p:spPr>
+          <a:xfrm>
+            <a:off x="1439418" y="5585460"/>
+            <a:ext cx="10200894" cy="815340"/>
+          </a:xfrm>
+          <a:prstGeom prst="rect">
+            <a:avLst/>
+          </a:prstGeom>
+          <a:noFill/>
+          <a:ln/>
+        </p:spPr>
+        <p:txBody>
+          <a:bodyPr wrap="square" lIns="0" tIns="0" rIns="0" bIns="0" rtlCol="0" anchor="ctr"/>
+          <a:lstStyle/>
+          <a:p>
+            <a:pPr marL="0" indent="0">
+              <a:buNone/>
+            </a:pPr>
+            <a:r>
+              <a:rPr lang="en-US" sz="2400" b="1" dirty="0">
+                <a:solidFill>
+                  <a:srgbClr val="1A5C2C"/>
+                </a:solidFill>
+                <a:latin typeface="Cambria" pitchFamily="34" charset="0"/>
+                <a:ea typeface="Cambria" pitchFamily="34" charset="-122"/>
+                <a:cs typeface="Cambria" pitchFamily="34" charset="-120"/>
+              </a:rPr>
+              <a:t>6  </a:t>
+            </a:r>
+            <a:r>
+              <a:rPr lang="en-US" sz="2400" dirty="0">
+                <a:solidFill>
+                  <a:srgbClr val="1F2A22"/>
+                </a:solidFill>
+                <a:latin typeface="Calibri" pitchFamily="34" charset="0"/>
+                <a:ea typeface="Calibri" pitchFamily="34" charset="-122"/>
+                <a:cs typeface="Calibri" pitchFamily="34" charset="-120"/>
+              </a:rPr>
+              <a:t>Leadership response in the monthly review</a:t>
+            </a:r>
+            <a:endParaRPr lang="en-US" sz="2400" dirty="0"/>
+          </a:p>
+        </p:txBody>
+      </p:sp>
+    </p:spTree>
+  </p:cSld>
+  <p:clrMapOvr>
+    <a:masterClrMapping/>
+  </p:clrMapOvr>
+</p:sld>
+</file>
+
+<file path=ppt/slides/slide25.xml><?xml version="1.0" encoding="utf-8"?>
+<p:sld xmlns:a="http://schemas.openxmlformats.org/drawingml/2006/main" xmlns:p="http://schemas.openxmlformats.org/presentationml/2006/main" xmlns:r="http://schemas.openxmlformats.org/officeDocument/2006/relationships">
+  <p:cSld>
+    <p:bg>
+      <p:bgPr>
+        <a:solidFill>
+          <a:srgbClr val="FFFFFF"/>
+        </a:solidFill>
+        <a:effectLst/>
+      </p:bgPr>
+    </p:bg>
+    <p:spTree>
+      <p:nvGrpSpPr>
+        <p:cNvPr id="1" name=""/>
+        <p:cNvGrpSpPr/>
+        <p:nvPr/>
+      </p:nvGrpSpPr>
+      <p:grpSpPr/>
+      <p:sp>
+        <p:nvSpPr>
+          <p:cNvPr id="2" name="Text 0"/>
+          <p:cNvSpPr txBox="1"/>
+          <p:nvPr/>
+        </p:nvSpPr>
+        <p:spPr>
+          <a:xfrm>
+            <a:off x="548640" y="411480"/>
+            <a:ext cx="11064240" cy="868680"/>
+          </a:xfrm>
+          <a:prstGeom prst="rect">
+            <a:avLst/>
+          </a:prstGeom>
+          <a:noFill/>
+          <a:ln/>
+        </p:spPr>
+        <p:txBody>
+          <a:bodyPr wrap="square" lIns="0" tIns="0" rIns="0" bIns="0" rtlCol="0" anchor="ctr"/>
+          <a:lstStyle/>
+          <a:p>
+            <a:pPr marL="0" indent="0">
+              <a:buNone/>
+            </a:pPr>
+            <a:r>
+              <a:rPr lang="en-US" sz="3600" b="1" dirty="0">
+                <a:solidFill>
+                  <a:srgbClr val="1A5C2C"/>
+                </a:solidFill>
+                <a:latin typeface="Cambria" pitchFamily="34" charset="0"/>
+                <a:ea typeface="Cambria" pitchFamily="34" charset="-122"/>
+                <a:cs typeface="Cambria" pitchFamily="34" charset="-120"/>
+              </a:rPr>
+              <a:t>Step 2 · FACES</a:t>
+            </a:r>
+            <a:endParaRPr lang="en-US" sz="3600" dirty="0"/>
+          </a:p>
+        </p:txBody>
+      </p:sp>
+      <p:sp>
+        <p:nvSpPr>
+          <p:cNvPr id="3" name="Shape 1"/>
+          <p:cNvSpPr/>
+          <p:nvPr/>
+        </p:nvSpPr>
+        <p:spPr>
+          <a:xfrm>
+            <a:off x="548640" y="1677924"/>
+            <a:ext cx="640080" cy="640080"/>
+          </a:xfrm>
+          <a:prstGeom prst="ellipse">
+            <a:avLst/>
+          </a:prstGeom>
+          <a:solidFill>
+            <a:srgbClr val="1A5C2C"/>
+          </a:solidFill>
+          <a:ln w="12700">
+            <a:solidFill>
+              <a:srgbClr val="1A5C2C"/>
+            </a:solidFill>
+            <a:prstDash val="solid"/>
+          </a:ln>
+        </p:spPr>
+        <p:txBody>
+          <a:bodyPr/>
+          <a:lstStyle/>
+          <a:p>
+            <a:endParaRPr lang="en-ZA"/>
+          </a:p>
+        </p:txBody>
+      </p:sp>
+      <p:pic>
+        <p:nvPicPr>
+          <p:cNvPr id="4" name="Image 0" descr="preencoded.png"/>
+          <p:cNvPicPr>
+            <a:picLocks noChangeAspect="1"/>
+          </p:cNvPicPr>
+          <p:nvPr/>
+        </p:nvPicPr>
+        <p:blipFill>
+          <a:blip r:embed="rId2"/>
+          <a:stretch>
+            <a:fillRect/>
+          </a:stretch>
+        </p:blipFill>
+        <p:spPr>
+          <a:xfrm>
+            <a:off x="708660" y="1837944"/>
+            <a:ext cx="320040" cy="320040"/>
+          </a:xfrm>
+          <a:prstGeom prst="rect">
+            <a:avLst/>
+          </a:prstGeom>
+        </p:spPr>
+      </p:pic>
+      <p:sp>
+        <p:nvSpPr>
+          <p:cNvPr id="5" name="Text 2"/>
+          <p:cNvSpPr txBox="1"/>
+          <p:nvPr/>
+        </p:nvSpPr>
+        <p:spPr>
+          <a:xfrm>
+            <a:off x="1508760" y="1508760"/>
+            <a:ext cx="10131552" cy="978408"/>
+          </a:xfrm>
+          <a:prstGeom prst="rect">
+            <a:avLst/>
+          </a:prstGeom>
+          <a:noFill/>
+          <a:ln/>
+        </p:spPr>
+        <p:txBody>
+          <a:bodyPr wrap="square" lIns="0" tIns="0" rIns="0" bIns="0" rtlCol="0" anchor="ctr"/>
+          <a:lstStyle/>
+          <a:p>
+            <a:pPr marL="0" indent="0">
+              <a:buNone/>
+            </a:pPr>
+            <a:r>
+              <a:rPr lang="en-US" sz="2600" b="1" dirty="0">
+                <a:solidFill>
+                  <a:srgbClr val="1A5C2C"/>
+                </a:solidFill>
+                <a:latin typeface="Cambria" pitchFamily="34" charset="0"/>
+                <a:ea typeface="Cambria" pitchFamily="34" charset="-122"/>
+                <a:cs typeface="Cambria" pitchFamily="34" charset="-120"/>
+              </a:rPr>
+              <a:t>F  </a:t>
+            </a:r>
+            <a:r>
+              <a:rPr lang="en-US" sz="2600" dirty="0">
+                <a:solidFill>
+                  <a:srgbClr val="1F2A22"/>
+                </a:solidFill>
+                <a:latin typeface="Calibri" pitchFamily="34" charset="0"/>
+                <a:ea typeface="Calibri" pitchFamily="34" charset="-122"/>
+                <a:cs typeface="Calibri" pitchFamily="34" charset="-120"/>
+              </a:rPr>
+              <a:t>Foster a Results Culture</a:t>
+            </a:r>
+            <a:endParaRPr lang="en-US" sz="2600" dirty="0"/>
+          </a:p>
+        </p:txBody>
+      </p:sp>
+      <p:sp>
+        <p:nvSpPr>
+          <p:cNvPr id="6" name="Shape 3"/>
+          <p:cNvSpPr/>
+          <p:nvPr/>
+        </p:nvSpPr>
+        <p:spPr>
+          <a:xfrm>
+            <a:off x="548640" y="2656332"/>
+            <a:ext cx="640080" cy="640080"/>
+          </a:xfrm>
+          <a:prstGeom prst="ellipse">
+            <a:avLst/>
+          </a:prstGeom>
+          <a:solidFill>
+            <a:srgbClr val="1A5C2C"/>
+          </a:solidFill>
+          <a:ln w="12700">
+            <a:solidFill>
+              <a:srgbClr val="1A5C2C"/>
+            </a:solidFill>
+            <a:prstDash val="solid"/>
+          </a:ln>
+        </p:spPr>
+        <p:txBody>
+          <a:bodyPr/>
+          <a:lstStyle/>
+          <a:p>
+            <a:endParaRPr lang="en-ZA"/>
+          </a:p>
+        </p:txBody>
+      </p:sp>
+      <p:pic>
+        <p:nvPicPr>
+          <p:cNvPr id="7" name="Image 1" descr="preencoded.png"/>
+          <p:cNvPicPr>
+            <a:picLocks noChangeAspect="1"/>
+          </p:cNvPicPr>
+          <p:nvPr/>
+        </p:nvPicPr>
+        <p:blipFill>
+          <a:blip r:embed="rId6"/>
+          <a:stretch>
+            <a:fillRect/>
+          </a:stretch>
+        </p:blipFill>
+        <p:spPr>
+          <a:xfrm>
+            <a:off x="708660" y="2816352"/>
+            <a:ext cx="320040" cy="320040"/>
+          </a:xfrm>
+          <a:prstGeom prst="rect">
+            <a:avLst/>
+          </a:prstGeom>
+        </p:spPr>
+      </p:pic>
+      <p:sp>
+        <p:nvSpPr>
+          <p:cNvPr id="8" name="Text 4"/>
+          <p:cNvSpPr txBox="1"/>
+          <p:nvPr/>
+        </p:nvSpPr>
+        <p:spPr>
+          <a:xfrm>
+            <a:off x="1508760" y="2487168"/>
+            <a:ext cx="10131552" cy="978408"/>
+          </a:xfrm>
+          <a:prstGeom prst="rect">
+            <a:avLst/>
+          </a:prstGeom>
+          <a:noFill/>
+          <a:ln/>
+        </p:spPr>
+        <p:txBody>
+          <a:bodyPr wrap="square" lIns="0" tIns="0" rIns="0" bIns="0" rtlCol="0" anchor="ctr"/>
+          <a:lstStyle/>
+          <a:p>
+            <a:pPr marL="0" indent="0">
+              <a:buNone/>
+            </a:pPr>
+            <a:r>
+              <a:rPr lang="en-US" sz="2600" b="1" dirty="0">
+                <a:solidFill>
+                  <a:srgbClr val="1A5C2C"/>
+                </a:solidFill>
+                <a:latin typeface="Cambria" pitchFamily="34" charset="0"/>
+                <a:ea typeface="Cambria" pitchFamily="34" charset="-122"/>
+                <a:cs typeface="Cambria" pitchFamily="34" charset="-120"/>
+              </a:rPr>
+              <a:t>A  </a:t>
+            </a:r>
+            <a:r>
+              <a:rPr lang="en-US" sz="2600" dirty="0">
+                <a:solidFill>
+                  <a:srgbClr val="1F2A22"/>
+                </a:solidFill>
+                <a:latin typeface="Calibri" pitchFamily="34" charset="0"/>
+                <a:ea typeface="Calibri" pitchFamily="34" charset="-122"/>
+                <a:cs typeface="Calibri" pitchFamily="34" charset="-120"/>
+              </a:rPr>
+              <a:t>Align Individual Performance</a:t>
+            </a:r>
+            <a:endParaRPr lang="en-US" sz="2600" dirty="0"/>
+          </a:p>
+        </p:txBody>
+      </p:sp>
+      <p:sp>
+        <p:nvSpPr>
+          <p:cNvPr id="9" name="Shape 5"/>
+          <p:cNvSpPr/>
+          <p:nvPr/>
+        </p:nvSpPr>
+        <p:spPr>
+          <a:xfrm>
+            <a:off x="548640" y="3634740"/>
+            <a:ext cx="640080" cy="640080"/>
+          </a:xfrm>
+          <a:prstGeom prst="ellipse">
+            <a:avLst/>
+          </a:prstGeom>
+          <a:solidFill>
+            <a:srgbClr val="1A5C2C"/>
+          </a:solidFill>
+          <a:ln w="12700">
+            <a:solidFill>
+              <a:srgbClr val="1A5C2C"/>
+            </a:solidFill>
+            <a:prstDash val="solid"/>
+          </a:ln>
+        </p:spPr>
+        <p:txBody>
+          <a:bodyPr/>
+          <a:lstStyle/>
+          <a:p>
+            <a:endParaRPr lang="en-ZA"/>
+          </a:p>
+        </p:txBody>
+      </p:sp>
+      <p:pic>
+        <p:nvPicPr>
+          <p:cNvPr id="10" name="Image 2" descr="preencoded.png"/>
+          <p:cNvPicPr>
+            <a:picLocks noChangeAspect="1"/>
+          </p:cNvPicPr>
+          <p:nvPr/>
+        </p:nvPicPr>
+        <p:blipFill>
+          <a:blip r:embed="rId5"/>
+          <a:stretch>
+            <a:fillRect/>
+          </a:stretch>
+        </p:blipFill>
+        <p:spPr>
+          <a:xfrm>
+            <a:off x="708660" y="3794760"/>
+            <a:ext cx="320040" cy="320040"/>
+          </a:xfrm>
+          <a:prstGeom prst="rect">
+            <a:avLst/>
+          </a:prstGeom>
+        </p:spPr>
+      </p:pic>
+      <p:sp>
+        <p:nvSpPr>
+          <p:cNvPr id="11" name="Text 6"/>
+          <p:cNvSpPr txBox="1"/>
+          <p:nvPr/>
+        </p:nvSpPr>
+        <p:spPr>
+          <a:xfrm>
+            <a:off x="1508760" y="3465576"/>
+            <a:ext cx="10131552" cy="978408"/>
+          </a:xfrm>
+          <a:prstGeom prst="rect">
+            <a:avLst/>
+          </a:prstGeom>
+          <a:noFill/>
+          <a:ln/>
+        </p:spPr>
+        <p:txBody>
+          <a:bodyPr wrap="square" lIns="0" tIns="0" rIns="0" bIns="0" rtlCol="0" anchor="ctr"/>
+          <a:lstStyle/>
+          <a:p>
+            <a:pPr marL="0" indent="0">
+              <a:buNone/>
+            </a:pPr>
+            <a:r>
+              <a:rPr lang="en-US" sz="2600" b="1" dirty="0">
+                <a:solidFill>
+                  <a:srgbClr val="1A5C2C"/>
+                </a:solidFill>
+                <a:latin typeface="Cambria" pitchFamily="34" charset="0"/>
+                <a:ea typeface="Cambria" pitchFamily="34" charset="-122"/>
+                <a:cs typeface="Cambria" pitchFamily="34" charset="-120"/>
+              </a:rPr>
+              <a:t>C  </a:t>
+            </a:r>
+            <a:r>
+              <a:rPr lang="en-US" sz="2600" dirty="0">
+                <a:solidFill>
+                  <a:srgbClr val="1F2A22"/>
+                </a:solidFill>
+                <a:latin typeface="Calibri" pitchFamily="34" charset="0"/>
+                <a:ea typeface="Calibri" pitchFamily="34" charset="-122"/>
+                <a:cs typeface="Calibri" pitchFamily="34" charset="-120"/>
+              </a:rPr>
+              <a:t>Create Measurement Transparency</a:t>
+            </a:r>
+            <a:endParaRPr lang="en-US" sz="2600" dirty="0"/>
+          </a:p>
+        </p:txBody>
+      </p:sp>
+      <p:sp>
+        <p:nvSpPr>
+          <p:cNvPr id="12" name="Shape 7"/>
+          <p:cNvSpPr/>
+          <p:nvPr/>
+        </p:nvSpPr>
+        <p:spPr>
+          <a:xfrm>
+            <a:off x="548640" y="4613148"/>
+            <a:ext cx="640080" cy="640080"/>
+          </a:xfrm>
+          <a:prstGeom prst="ellipse">
+            <a:avLst/>
+          </a:prstGeom>
+          <a:solidFill>
+            <a:srgbClr val="1A5C2C"/>
+          </a:solidFill>
+          <a:ln w="12700">
+            <a:solidFill>
+              <a:srgbClr val="1A5C2C"/>
+            </a:solidFill>
+            <a:prstDash val="solid"/>
+          </a:ln>
+        </p:spPr>
+        <p:txBody>
+          <a:bodyPr/>
+          <a:lstStyle/>
+          <a:p>
+            <a:endParaRPr lang="en-ZA"/>
+          </a:p>
+        </p:txBody>
+      </p:sp>
+      <p:pic>
+        <p:nvPicPr>
+          <p:cNvPr id="13" name="Image 3" descr="preencoded.png"/>
+          <p:cNvPicPr>
+            <a:picLocks noChangeAspect="1"/>
+          </p:cNvPicPr>
+          <p:nvPr/>
+        </p:nvPicPr>
+        <p:blipFill>
+          <a:blip r:embed="rId4"/>
+          <a:stretch>
+            <a:fillRect/>
+          </a:stretch>
+        </p:blipFill>
+        <p:spPr>
+          <a:xfrm>
+            <a:off x="708660" y="4773168"/>
+            <a:ext cx="320040" cy="320040"/>
+          </a:xfrm>
+          <a:prstGeom prst="rect">
+            <a:avLst/>
+          </a:prstGeom>
+        </p:spPr>
+      </p:pic>
+      <p:sp>
+        <p:nvSpPr>
+          <p:cNvPr id="14" name="Text 8"/>
+          <p:cNvSpPr txBox="1"/>
+          <p:nvPr/>
+        </p:nvSpPr>
+        <p:spPr>
+          <a:xfrm>
+            <a:off x="1508760" y="4443984"/>
+            <a:ext cx="10131552" cy="978408"/>
+          </a:xfrm>
+          <a:prstGeom prst="rect">
+            <a:avLst/>
+          </a:prstGeom>
+          <a:noFill/>
+          <a:ln/>
+        </p:spPr>
+        <p:txBody>
+          <a:bodyPr wrap="square" lIns="0" tIns="0" rIns="0" bIns="0" rtlCol="0" anchor="ctr"/>
+          <a:lstStyle/>
+          <a:p>
+            <a:pPr marL="0" indent="0">
+              <a:buNone/>
+            </a:pPr>
+            <a:r>
+              <a:rPr lang="en-US" sz="2600" b="1" dirty="0">
+                <a:solidFill>
+                  <a:srgbClr val="1A5C2C"/>
+                </a:solidFill>
+                <a:latin typeface="Cambria" pitchFamily="34" charset="0"/>
+                <a:ea typeface="Cambria" pitchFamily="34" charset="-122"/>
+                <a:cs typeface="Cambria" pitchFamily="34" charset="-120"/>
+              </a:rPr>
+              <a:t>E  </a:t>
+            </a:r>
+            <a:r>
+              <a:rPr lang="en-US" sz="2600" dirty="0">
+                <a:solidFill>
+                  <a:srgbClr val="1F2A22"/>
+                </a:solidFill>
+                <a:latin typeface="Calibri" pitchFamily="34" charset="0"/>
+                <a:ea typeface="Calibri" pitchFamily="34" charset="-122"/>
+                <a:cs typeface="Calibri" pitchFamily="34" charset="-120"/>
+              </a:rPr>
+              <a:t>Embed Shared Accountability</a:t>
+            </a:r>
+            <a:endParaRPr lang="en-US" sz="2600" dirty="0"/>
+          </a:p>
+        </p:txBody>
+      </p:sp>
+      <p:sp>
+        <p:nvSpPr>
+          <p:cNvPr id="15" name="Shape 9"/>
+          <p:cNvSpPr/>
+          <p:nvPr/>
+        </p:nvSpPr>
+        <p:spPr>
+          <a:xfrm>
+            <a:off x="548640" y="5591556"/>
+            <a:ext cx="640080" cy="640080"/>
+          </a:xfrm>
+          <a:prstGeom prst="ellipse">
+            <a:avLst/>
+          </a:prstGeom>
+          <a:solidFill>
+            <a:srgbClr val="1A5C2C"/>
+          </a:solidFill>
+          <a:ln w="12700">
+            <a:solidFill>
+              <a:srgbClr val="1A5C2C"/>
+            </a:solidFill>
+            <a:prstDash val="solid"/>
+          </a:ln>
+        </p:spPr>
+        <p:txBody>
+          <a:bodyPr/>
+          <a:lstStyle/>
+          <a:p>
+            <a:endParaRPr lang="en-ZA"/>
+          </a:p>
+        </p:txBody>
+      </p:sp>
+      <p:pic>
+        <p:nvPicPr>
+          <p:cNvPr id="16" name="Image 4" descr="preencoded.png"/>
+          <p:cNvPicPr>
+            <a:picLocks noChangeAspect="1"/>
+          </p:cNvPicPr>
+          <p:nvPr/>
+        </p:nvPicPr>
+        <p:blipFill>
+          <a:blip r:embed="rId3"/>
+          <a:stretch>
+            <a:fillRect/>
+          </a:stretch>
+        </p:blipFill>
+        <p:spPr>
+          <a:xfrm>
+            <a:off x="708660" y="5751576"/>
+            <a:ext cx="320040" cy="320040"/>
+          </a:xfrm>
+          <a:prstGeom prst="rect">
+            <a:avLst/>
+          </a:prstGeom>
+        </p:spPr>
+      </p:pic>
+      <p:sp>
+        <p:nvSpPr>
+          <p:cNvPr id="17" name="Text 10"/>
+          <p:cNvSpPr txBox="1"/>
+          <p:nvPr/>
+        </p:nvSpPr>
+        <p:spPr>
+          <a:xfrm>
+            <a:off x="1508760" y="5422392"/>
+            <a:ext cx="10131552" cy="978408"/>
+          </a:xfrm>
+          <a:prstGeom prst="rect">
+            <a:avLst/>
+          </a:prstGeom>
+          <a:noFill/>
+          <a:ln/>
+        </p:spPr>
+        <p:txBody>
+          <a:bodyPr wrap="square" lIns="0" tIns="0" rIns="0" bIns="0" rtlCol="0" anchor="ctr"/>
+          <a:lstStyle/>
+          <a:p>
+            <a:pPr marL="0" indent="0">
+              <a:buNone/>
+            </a:pPr>
+            <a:r>
+              <a:rPr lang="en-US" sz="2600" b="1" dirty="0">
+                <a:solidFill>
+                  <a:srgbClr val="1A5C2C"/>
+                </a:solidFill>
+                <a:latin typeface="Cambria" pitchFamily="34" charset="0"/>
+                <a:ea typeface="Cambria" pitchFamily="34" charset="-122"/>
+                <a:cs typeface="Cambria" pitchFamily="34" charset="-120"/>
+              </a:rPr>
+              <a:t>S  </a:t>
+            </a:r>
+            <a:r>
+              <a:rPr lang="en-US" sz="2600" dirty="0">
+                <a:solidFill>
+                  <a:srgbClr val="1F2A22"/>
+                </a:solidFill>
+                <a:latin typeface="Calibri" pitchFamily="34" charset="0"/>
+                <a:ea typeface="Calibri" pitchFamily="34" charset="-122"/>
+                <a:cs typeface="Calibri" pitchFamily="34" charset="-120"/>
+              </a:rPr>
+              <a:t>Support Continuous Development</a:t>
+            </a:r>
+            <a:endParaRPr lang="en-US" sz="2600" dirty="0"/>
+          </a:p>
+        </p:txBody>
+      </p:sp>
+    </p:spTree>
+  </p:cSld>
+  <p:clrMapOvr>
+    <a:masterClrMapping/>
+  </p:clrMapOvr>
+</p:sld>
+</file>
+
+<file path=ppt/slides/slide26.xml><?xml version="1.0" encoding="utf-8"?>
+<p:sld xmlns:a="http://schemas.openxmlformats.org/drawingml/2006/main" xmlns:p="http://schemas.openxmlformats.org/presentationml/2006/main" xmlns:r="http://schemas.openxmlformats.org/officeDocument/2006/relationships">
+  <p:cSld>
+    <p:bg>
+      <p:bgPr>
+        <a:solidFill>
+          <a:srgbClr val="FFFFFF"/>
+        </a:solidFill>
+        <a:effectLst/>
+      </p:bgPr>
+    </p:bg>
+    <p:spTree>
+      <p:nvGrpSpPr>
+        <p:cNvPr id="1" name=""/>
+        <p:cNvGrpSpPr/>
+        <p:nvPr/>
+      </p:nvGrpSpPr>
+      <p:grpSpPr/>
+      <p:sp>
+        <p:nvSpPr>
+          <p:cNvPr id="2" name="Text 0"/>
+          <p:cNvSpPr txBox="1"/>
+          <p:nvPr/>
+        </p:nvSpPr>
+        <p:spPr>
+          <a:xfrm>
+            <a:off x="548640" y="411480"/>
+            <a:ext cx="11064240" cy="868680"/>
+          </a:xfrm>
+          <a:prstGeom prst="rect">
+            <a:avLst/>
+          </a:prstGeom>
+          <a:noFill/>
+          <a:ln/>
+        </p:spPr>
+        <p:txBody>
+          <a:bodyPr wrap="square" lIns="0" tIns="0" rIns="0" bIns="0" rtlCol="0" anchor="ctr"/>
+          <a:lstStyle/>
+          <a:p>
+            <a:pPr marL="0" indent="0">
+              <a:buNone/>
+            </a:pPr>
+            <a:r>
+              <a:rPr lang="en-US" sz="3600" b="1" dirty="0">
+                <a:solidFill>
+                  <a:srgbClr val="1A5C2C"/>
+                </a:solidFill>
+                <a:latin typeface="Cambria" pitchFamily="34" charset="0"/>
+                <a:ea typeface="Cambria" pitchFamily="34" charset="-122"/>
+                <a:cs typeface="Cambria" pitchFamily="34" charset="-120"/>
+              </a:rPr>
+              <a:t>Step 3 · EXECUTION</a:t>
+            </a:r>
+            <a:endParaRPr lang="en-US" sz="3600" dirty="0"/>
+          </a:p>
+        </p:txBody>
+      </p:sp>
+      <p:sp>
+        <p:nvSpPr>
+          <p:cNvPr id="3" name="Shape 1"/>
+          <p:cNvSpPr/>
+          <p:nvPr/>
+        </p:nvSpPr>
+        <p:spPr>
+          <a:xfrm>
+            <a:off x="548640" y="1590294"/>
+            <a:ext cx="380492" cy="380492"/>
+          </a:xfrm>
+          <a:prstGeom prst="ellipse">
+            <a:avLst/>
+          </a:prstGeom>
+          <a:solidFill>
+            <a:srgbClr val="1A5C2C"/>
+          </a:solidFill>
+          <a:ln w="12700">
+            <a:solidFill>
+              <a:srgbClr val="1A5C2C"/>
+            </a:solidFill>
+            <a:prstDash val="solid"/>
+          </a:ln>
+        </p:spPr>
+        <p:txBody>
+          <a:bodyPr/>
+          <a:lstStyle/>
+          <a:p>
+            <a:endParaRPr lang="en-ZA"/>
+          </a:p>
+        </p:txBody>
+      </p:sp>
+      <p:pic>
+        <p:nvPicPr>
+          <p:cNvPr id="4" name="Image 0" descr="preencoded.png"/>
+          <p:cNvPicPr>
+            <a:picLocks noChangeAspect="1"/>
+          </p:cNvPicPr>
+          <p:nvPr/>
+        </p:nvPicPr>
+        <p:blipFill>
+          <a:blip r:embed="rId2"/>
+          <a:stretch>
+            <a:fillRect/>
+          </a:stretch>
+        </p:blipFill>
+        <p:spPr>
+          <a:xfrm>
+            <a:off x="643763" y="1685417"/>
+            <a:ext cx="190246" cy="190246"/>
+          </a:xfrm>
+          <a:prstGeom prst="rect">
+            <a:avLst/>
+          </a:prstGeom>
+        </p:spPr>
+      </p:pic>
+      <p:sp>
+        <p:nvSpPr>
+          <p:cNvPr id="5" name="Text 2"/>
+          <p:cNvSpPr txBox="1"/>
+          <p:nvPr/>
+        </p:nvSpPr>
+        <p:spPr>
+          <a:xfrm>
+            <a:off x="1249172" y="1508760"/>
+            <a:ext cx="10391140" cy="543560"/>
+          </a:xfrm>
+          <a:prstGeom prst="rect">
+            <a:avLst/>
+          </a:prstGeom>
+          <a:noFill/>
+          <a:ln/>
+        </p:spPr>
+        <p:txBody>
+          <a:bodyPr wrap="square" lIns="0" tIns="0" rIns="0" bIns="0" rtlCol="0" anchor="ctr"/>
+          <a:lstStyle/>
+          <a:p>
+            <a:pPr marL="0" indent="0">
+              <a:buNone/>
+            </a:pPr>
+            <a:r>
+              <a:rPr lang="en-US" sz="2400" b="1" dirty="0">
+                <a:solidFill>
+                  <a:srgbClr val="1A5C2C"/>
+                </a:solidFill>
+                <a:latin typeface="Cambria" pitchFamily="34" charset="0"/>
+                <a:ea typeface="Cambria" pitchFamily="34" charset="-122"/>
+                <a:cs typeface="Cambria" pitchFamily="34" charset="-120"/>
+              </a:rPr>
+              <a:t>E  </a:t>
+            </a:r>
+            <a:r>
+              <a:rPr lang="en-US" sz="2400" dirty="0">
+                <a:solidFill>
+                  <a:srgbClr val="1F2A22"/>
+                </a:solidFill>
+                <a:latin typeface="Calibri" pitchFamily="34" charset="0"/>
+                <a:ea typeface="Calibri" pitchFamily="34" charset="-122"/>
+                <a:cs typeface="Calibri" pitchFamily="34" charset="-120"/>
+              </a:rPr>
+              <a:t>Enterprise: Strategy First</a:t>
+            </a:r>
+            <a:endParaRPr lang="en-US" sz="2400" dirty="0"/>
+          </a:p>
+        </p:txBody>
+      </p:sp>
+      <p:sp>
+        <p:nvSpPr>
+          <p:cNvPr id="6" name="Shape 3"/>
+          <p:cNvSpPr/>
+          <p:nvPr/>
+        </p:nvSpPr>
+        <p:spPr>
+          <a:xfrm>
+            <a:off x="548640" y="2133854"/>
+            <a:ext cx="380492" cy="380492"/>
+          </a:xfrm>
+          <a:prstGeom prst="ellipse">
+            <a:avLst/>
+          </a:prstGeom>
+          <a:solidFill>
+            <a:srgbClr val="1A5C2C"/>
+          </a:solidFill>
+          <a:ln w="12700">
+            <a:solidFill>
+              <a:srgbClr val="1A5C2C"/>
+            </a:solidFill>
+            <a:prstDash val="solid"/>
+          </a:ln>
+        </p:spPr>
+        <p:txBody>
+          <a:bodyPr/>
+          <a:lstStyle/>
+          <a:p>
+            <a:endParaRPr lang="en-ZA"/>
+          </a:p>
+        </p:txBody>
+      </p:sp>
+      <p:pic>
+        <p:nvPicPr>
+          <p:cNvPr id="7" name="Image 1" descr="preencoded.png"/>
+          <p:cNvPicPr>
+            <a:picLocks noChangeAspect="1"/>
+          </p:cNvPicPr>
+          <p:nvPr/>
+        </p:nvPicPr>
+        <p:blipFill>
+          <a:blip r:embed="rId2"/>
+          <a:stretch>
+            <a:fillRect/>
+          </a:stretch>
+        </p:blipFill>
+        <p:spPr>
+          <a:xfrm>
+            <a:off x="643763" y="2228977"/>
+            <a:ext cx="190246" cy="190246"/>
+          </a:xfrm>
+          <a:prstGeom prst="rect">
+            <a:avLst/>
+          </a:prstGeom>
+        </p:spPr>
+      </p:pic>
+      <p:sp>
+        <p:nvSpPr>
+          <p:cNvPr id="8" name="Text 4"/>
+          <p:cNvSpPr txBox="1"/>
+          <p:nvPr/>
+        </p:nvSpPr>
+        <p:spPr>
+          <a:xfrm>
+            <a:off x="1249172" y="2052320"/>
+            <a:ext cx="10391140" cy="543560"/>
+          </a:xfrm>
+          <a:prstGeom prst="rect">
+            <a:avLst/>
+          </a:prstGeom>
+          <a:noFill/>
+          <a:ln/>
+        </p:spPr>
+        <p:txBody>
+          <a:bodyPr wrap="square" lIns="0" tIns="0" rIns="0" bIns="0" rtlCol="0" anchor="ctr"/>
+          <a:lstStyle/>
+          <a:p>
+            <a:pPr marL="0" indent="0">
+              <a:buNone/>
+            </a:pPr>
+            <a:r>
+              <a:rPr lang="en-US" sz="2400" b="1" dirty="0">
+                <a:solidFill>
+                  <a:srgbClr val="1A5C2C"/>
+                </a:solidFill>
+                <a:latin typeface="Cambria" pitchFamily="34" charset="0"/>
+                <a:ea typeface="Cambria" pitchFamily="34" charset="-122"/>
+                <a:cs typeface="Cambria" pitchFamily="34" charset="-120"/>
+              </a:rPr>
+              <a:t>X  </a:t>
+            </a:r>
+            <a:r>
+              <a:rPr lang="en-US" sz="2400" dirty="0">
+                <a:solidFill>
+                  <a:srgbClr val="1F2A22"/>
+                </a:solidFill>
+                <a:latin typeface="Calibri" pitchFamily="34" charset="0"/>
+                <a:ea typeface="Calibri" pitchFamily="34" charset="-122"/>
+                <a:cs typeface="Calibri" pitchFamily="34" charset="-120"/>
+              </a:rPr>
+              <a:t>eXecution: Line-of-Sight</a:t>
+            </a:r>
+            <a:endParaRPr lang="en-US" sz="2400" dirty="0"/>
+          </a:p>
+        </p:txBody>
+      </p:sp>
+      <p:sp>
+        <p:nvSpPr>
+          <p:cNvPr id="9" name="Shape 5"/>
+          <p:cNvSpPr/>
+          <p:nvPr/>
+        </p:nvSpPr>
+        <p:spPr>
+          <a:xfrm>
+            <a:off x="548640" y="2677414"/>
+            <a:ext cx="380492" cy="380492"/>
+          </a:xfrm>
+          <a:prstGeom prst="ellipse">
+            <a:avLst/>
+          </a:prstGeom>
+          <a:solidFill>
+            <a:srgbClr val="1A5C2C"/>
+          </a:solidFill>
+          <a:ln w="12700">
+            <a:solidFill>
+              <a:srgbClr val="1A5C2C"/>
+            </a:solidFill>
+            <a:prstDash val="solid"/>
+          </a:ln>
+        </p:spPr>
+        <p:txBody>
+          <a:bodyPr/>
+          <a:lstStyle/>
+          <a:p>
+            <a:endParaRPr lang="en-ZA"/>
+          </a:p>
+        </p:txBody>
+      </p:sp>
+      <p:pic>
+        <p:nvPicPr>
+          <p:cNvPr id="10" name="Image 2" descr="preencoded.png"/>
+          <p:cNvPicPr>
+            <a:picLocks noChangeAspect="1"/>
+          </p:cNvPicPr>
+          <p:nvPr/>
+        </p:nvPicPr>
+        <p:blipFill>
+          <a:blip r:embed="rId2"/>
+          <a:stretch>
+            <a:fillRect/>
+          </a:stretch>
+        </p:blipFill>
+        <p:spPr>
+          <a:xfrm>
+            <a:off x="643763" y="2772537"/>
+            <a:ext cx="190246" cy="190246"/>
+          </a:xfrm>
+          <a:prstGeom prst="rect">
+            <a:avLst/>
+          </a:prstGeom>
+        </p:spPr>
+      </p:pic>
+      <p:sp>
+        <p:nvSpPr>
+          <p:cNvPr id="11" name="Text 6"/>
+          <p:cNvSpPr txBox="1"/>
+          <p:nvPr/>
+        </p:nvSpPr>
+        <p:spPr>
+          <a:xfrm>
+            <a:off x="1249172" y="2595880"/>
+            <a:ext cx="10391140" cy="543560"/>
+          </a:xfrm>
+          <a:prstGeom prst="rect">
+            <a:avLst/>
+          </a:prstGeom>
+          <a:noFill/>
+          <a:ln/>
+        </p:spPr>
+        <p:txBody>
+          <a:bodyPr wrap="square" lIns="0" tIns="0" rIns="0" bIns="0" rtlCol="0" anchor="ctr"/>
+          <a:lstStyle/>
+          <a:p>
+            <a:pPr marL="0" indent="0">
+              <a:buNone/>
+            </a:pPr>
+            <a:r>
+              <a:rPr lang="en-US" sz="2400" b="1" dirty="0">
+                <a:solidFill>
+                  <a:srgbClr val="1A5C2C"/>
+                </a:solidFill>
+                <a:latin typeface="Cambria" pitchFamily="34" charset="0"/>
+                <a:ea typeface="Cambria" pitchFamily="34" charset="-122"/>
+                <a:cs typeface="Cambria" pitchFamily="34" charset="-120"/>
+              </a:rPr>
+              <a:t>E  </a:t>
+            </a:r>
+            <a:r>
+              <a:rPr lang="en-US" sz="2400" dirty="0">
+                <a:solidFill>
+                  <a:srgbClr val="1F2A22"/>
+                </a:solidFill>
+                <a:latin typeface="Calibri" pitchFamily="34" charset="0"/>
+                <a:ea typeface="Calibri" pitchFamily="34" charset="-122"/>
+                <a:cs typeface="Calibri" pitchFamily="34" charset="-120"/>
+              </a:rPr>
+              <a:t>Evidence: Evidence-Based Measurement</a:t>
+            </a:r>
+            <a:endParaRPr lang="en-US" sz="2400" dirty="0"/>
+          </a:p>
+        </p:txBody>
+      </p:sp>
+      <p:sp>
+        <p:nvSpPr>
+          <p:cNvPr id="12" name="Shape 7"/>
+          <p:cNvSpPr/>
+          <p:nvPr/>
+        </p:nvSpPr>
+        <p:spPr>
+          <a:xfrm>
+            <a:off x="548640" y="3220974"/>
+            <a:ext cx="380492" cy="380492"/>
+          </a:xfrm>
+          <a:prstGeom prst="ellipse">
+            <a:avLst/>
+          </a:prstGeom>
+          <a:solidFill>
+            <a:srgbClr val="1A5C2C"/>
+          </a:solidFill>
+          <a:ln w="12700">
+            <a:solidFill>
+              <a:srgbClr val="1A5C2C"/>
+            </a:solidFill>
+            <a:prstDash val="solid"/>
+          </a:ln>
+        </p:spPr>
+        <p:txBody>
+          <a:bodyPr/>
+          <a:lstStyle/>
+          <a:p>
+            <a:endParaRPr lang="en-ZA"/>
+          </a:p>
+        </p:txBody>
+      </p:sp>
+      <p:pic>
+        <p:nvPicPr>
+          <p:cNvPr id="13" name="Image 3" descr="preencoded.png"/>
+          <p:cNvPicPr>
+            <a:picLocks noChangeAspect="1"/>
+          </p:cNvPicPr>
+          <p:nvPr/>
+        </p:nvPicPr>
+        <p:blipFill>
+          <a:blip r:embed="rId2"/>
+          <a:stretch>
+            <a:fillRect/>
+          </a:stretch>
+        </p:blipFill>
+        <p:spPr>
+          <a:xfrm>
+            <a:off x="643763" y="3316097"/>
+            <a:ext cx="190246" cy="190246"/>
+          </a:xfrm>
+          <a:prstGeom prst="rect">
+            <a:avLst/>
+          </a:prstGeom>
+        </p:spPr>
+      </p:pic>
+      <p:sp>
+        <p:nvSpPr>
+          <p:cNvPr id="14" name="Text 8"/>
+          <p:cNvSpPr txBox="1"/>
+          <p:nvPr/>
+        </p:nvSpPr>
+        <p:spPr>
+          <a:xfrm>
+            <a:off x="1249172" y="3139440"/>
+            <a:ext cx="10391140" cy="543560"/>
+          </a:xfrm>
+          <a:prstGeom prst="rect">
+            <a:avLst/>
+          </a:prstGeom>
+          <a:noFill/>
+          <a:ln/>
+        </p:spPr>
+        <p:txBody>
+          <a:bodyPr wrap="square" lIns="0" tIns="0" rIns="0" bIns="0" rtlCol="0" anchor="ctr"/>
+          <a:lstStyle/>
+          <a:p>
+            <a:pPr marL="0" indent="0">
+              <a:buNone/>
+            </a:pPr>
+            <a:r>
+              <a:rPr lang="en-US" sz="2400" b="1" dirty="0">
+                <a:solidFill>
+                  <a:srgbClr val="1A5C2C"/>
+                </a:solidFill>
+                <a:latin typeface="Cambria" pitchFamily="34" charset="0"/>
+                <a:ea typeface="Cambria" pitchFamily="34" charset="-122"/>
+                <a:cs typeface="Cambria" pitchFamily="34" charset="-120"/>
+              </a:rPr>
+              <a:t>C  </a:t>
+            </a:r>
+            <a:r>
+              <a:rPr lang="en-US" sz="2400" dirty="0">
+                <a:solidFill>
+                  <a:srgbClr val="1F2A22"/>
+                </a:solidFill>
+                <a:latin typeface="Calibri" pitchFamily="34" charset="0"/>
+                <a:ea typeface="Calibri" pitchFamily="34" charset="-122"/>
+                <a:cs typeface="Calibri" pitchFamily="34" charset="-120"/>
+              </a:rPr>
+              <a:t>Collective: Collective Ownership</a:t>
+            </a:r>
+            <a:endParaRPr lang="en-US" sz="2400" dirty="0"/>
+          </a:p>
+        </p:txBody>
+      </p:sp>
+      <p:sp>
+        <p:nvSpPr>
+          <p:cNvPr id="15" name="Shape 9"/>
+          <p:cNvSpPr/>
+          <p:nvPr/>
+        </p:nvSpPr>
+        <p:spPr>
+          <a:xfrm>
+            <a:off x="548640" y="3764534"/>
+            <a:ext cx="380492" cy="380492"/>
+          </a:xfrm>
+          <a:prstGeom prst="ellipse">
+            <a:avLst/>
+          </a:prstGeom>
+          <a:solidFill>
+            <a:srgbClr val="1A5C2C"/>
+          </a:solidFill>
+          <a:ln w="12700">
+            <a:solidFill>
+              <a:srgbClr val="1A5C2C"/>
+            </a:solidFill>
+            <a:prstDash val="solid"/>
+          </a:ln>
+        </p:spPr>
+        <p:txBody>
+          <a:bodyPr/>
+          <a:lstStyle/>
+          <a:p>
+            <a:endParaRPr lang="en-ZA"/>
+          </a:p>
+        </p:txBody>
+      </p:sp>
+      <p:pic>
+        <p:nvPicPr>
+          <p:cNvPr id="16" name="Image 4" descr="preencoded.png"/>
+          <p:cNvPicPr>
+            <a:picLocks noChangeAspect="1"/>
+          </p:cNvPicPr>
+          <p:nvPr/>
+        </p:nvPicPr>
+        <p:blipFill>
+          <a:blip r:embed="rId2"/>
+          <a:stretch>
+            <a:fillRect/>
+          </a:stretch>
+        </p:blipFill>
+        <p:spPr>
+          <a:xfrm>
+            <a:off x="643763" y="3859657"/>
+            <a:ext cx="190246" cy="190246"/>
+          </a:xfrm>
+          <a:prstGeom prst="rect">
+            <a:avLst/>
+          </a:prstGeom>
+        </p:spPr>
+      </p:pic>
+      <p:sp>
+        <p:nvSpPr>
+          <p:cNvPr id="17" name="Text 10"/>
+          <p:cNvSpPr txBox="1"/>
+          <p:nvPr/>
+        </p:nvSpPr>
+        <p:spPr>
+          <a:xfrm>
+            <a:off x="1249172" y="3683000"/>
+            <a:ext cx="10391140" cy="543560"/>
+          </a:xfrm>
+          <a:prstGeom prst="rect">
+            <a:avLst/>
+          </a:prstGeom>
+          <a:noFill/>
+          <a:ln/>
+        </p:spPr>
+        <p:txBody>
+          <a:bodyPr wrap="square" lIns="0" tIns="0" rIns="0" bIns="0" rtlCol="0" anchor="ctr"/>
+          <a:lstStyle/>
+          <a:p>
+            <a:pPr marL="0" indent="0">
+              <a:buNone/>
+            </a:pPr>
+            <a:r>
+              <a:rPr lang="en-US" sz="2400" b="1" dirty="0">
+                <a:solidFill>
+                  <a:srgbClr val="1A5C2C"/>
+                </a:solidFill>
+                <a:latin typeface="Cambria" pitchFamily="34" charset="0"/>
+                <a:ea typeface="Cambria" pitchFamily="34" charset="-122"/>
+                <a:cs typeface="Cambria" pitchFamily="34" charset="-120"/>
+              </a:rPr>
+              <a:t>U  </a:t>
+            </a:r>
+            <a:r>
+              <a:rPr lang="en-US" sz="2400" dirty="0">
+                <a:solidFill>
+                  <a:srgbClr val="1F2A22"/>
+                </a:solidFill>
+                <a:latin typeface="Calibri" pitchFamily="34" charset="0"/>
+                <a:ea typeface="Calibri" pitchFamily="34" charset="-122"/>
+                <a:cs typeface="Calibri" pitchFamily="34" charset="-120"/>
+              </a:rPr>
+              <a:t>Understand: Outcomes First</a:t>
+            </a:r>
+            <a:endParaRPr lang="en-US" sz="2400" dirty="0"/>
+          </a:p>
+        </p:txBody>
+      </p:sp>
+      <p:sp>
+        <p:nvSpPr>
+          <p:cNvPr id="18" name="Shape 11"/>
+          <p:cNvSpPr/>
+          <p:nvPr/>
+        </p:nvSpPr>
+        <p:spPr>
+          <a:xfrm>
+            <a:off x="548640" y="4308094"/>
+            <a:ext cx="380492" cy="380492"/>
+          </a:xfrm>
+          <a:prstGeom prst="ellipse">
+            <a:avLst/>
+          </a:prstGeom>
+          <a:solidFill>
+            <a:srgbClr val="1A5C2C"/>
+          </a:solidFill>
+          <a:ln w="12700">
+            <a:solidFill>
+              <a:srgbClr val="1A5C2C"/>
+            </a:solidFill>
+            <a:prstDash val="solid"/>
+          </a:ln>
+        </p:spPr>
+        <p:txBody>
+          <a:bodyPr/>
+          <a:lstStyle/>
+          <a:p>
+            <a:endParaRPr lang="en-ZA"/>
+          </a:p>
+        </p:txBody>
+      </p:sp>
+      <p:pic>
+        <p:nvPicPr>
+          <p:cNvPr id="19" name="Image 5" descr="preencoded.png"/>
+          <p:cNvPicPr>
+            <a:picLocks noChangeAspect="1"/>
+          </p:cNvPicPr>
+          <p:nvPr/>
+        </p:nvPicPr>
+        <p:blipFill>
+          <a:blip r:embed="rId2"/>
+          <a:stretch>
+            <a:fillRect/>
+          </a:stretch>
+        </p:blipFill>
+        <p:spPr>
+          <a:xfrm>
+            <a:off x="643763" y="4403217"/>
+            <a:ext cx="190246" cy="190246"/>
+          </a:xfrm>
+          <a:prstGeom prst="rect">
+            <a:avLst/>
+          </a:prstGeom>
+        </p:spPr>
+      </p:pic>
+      <p:sp>
+        <p:nvSpPr>
+          <p:cNvPr id="20" name="Text 12"/>
+          <p:cNvSpPr txBox="1"/>
+          <p:nvPr/>
+        </p:nvSpPr>
+        <p:spPr>
+          <a:xfrm>
+            <a:off x="1249172" y="4226560"/>
+            <a:ext cx="10391140" cy="543560"/>
+          </a:xfrm>
+          <a:prstGeom prst="rect">
+            <a:avLst/>
+          </a:prstGeom>
+          <a:noFill/>
+          <a:ln/>
+        </p:spPr>
+        <p:txBody>
+          <a:bodyPr wrap="square" lIns="0" tIns="0" rIns="0" bIns="0" rtlCol="0" anchor="ctr"/>
+          <a:lstStyle/>
+          <a:p>
+            <a:pPr marL="0" indent="0">
+              <a:buNone/>
+            </a:pPr>
+            <a:r>
+              <a:rPr lang="en-US" sz="2400" b="1" dirty="0">
+                <a:solidFill>
+                  <a:srgbClr val="1A5C2C"/>
+                </a:solidFill>
+                <a:latin typeface="Cambria" pitchFamily="34" charset="0"/>
+                <a:ea typeface="Cambria" pitchFamily="34" charset="-122"/>
+                <a:cs typeface="Cambria" pitchFamily="34" charset="-120"/>
+              </a:rPr>
+              <a:t>T  </a:t>
+            </a:r>
+            <a:r>
+              <a:rPr lang="en-US" sz="2400" dirty="0">
+                <a:solidFill>
+                  <a:srgbClr val="1F2A22"/>
+                </a:solidFill>
+                <a:latin typeface="Calibri" pitchFamily="34" charset="0"/>
+                <a:ea typeface="Calibri" pitchFamily="34" charset="-122"/>
+                <a:cs typeface="Calibri" pitchFamily="34" charset="-120"/>
+              </a:rPr>
+              <a:t>Transparent: Measurement Logic</a:t>
+            </a:r>
+            <a:endParaRPr lang="en-US" sz="2400" dirty="0"/>
+          </a:p>
+        </p:txBody>
+      </p:sp>
+      <p:sp>
+        <p:nvSpPr>
+          <p:cNvPr id="21" name="Shape 13"/>
+          <p:cNvSpPr/>
+          <p:nvPr/>
+        </p:nvSpPr>
+        <p:spPr>
+          <a:xfrm>
+            <a:off x="548640" y="4851654"/>
+            <a:ext cx="380492" cy="380492"/>
+          </a:xfrm>
+          <a:prstGeom prst="ellipse">
+            <a:avLst/>
+          </a:prstGeom>
+          <a:solidFill>
+            <a:srgbClr val="1A5C2C"/>
+          </a:solidFill>
+          <a:ln w="12700">
+            <a:solidFill>
+              <a:srgbClr val="1A5C2C"/>
+            </a:solidFill>
+            <a:prstDash val="solid"/>
+          </a:ln>
+        </p:spPr>
+        <p:txBody>
+          <a:bodyPr/>
+          <a:lstStyle/>
+          <a:p>
+            <a:endParaRPr lang="en-ZA"/>
+          </a:p>
+        </p:txBody>
+      </p:sp>
+      <p:pic>
+        <p:nvPicPr>
+          <p:cNvPr id="22" name="Image 6" descr="preencoded.png"/>
+          <p:cNvPicPr>
+            <a:picLocks noChangeAspect="1"/>
+          </p:cNvPicPr>
+          <p:nvPr/>
+        </p:nvPicPr>
+        <p:blipFill>
+          <a:blip r:embed="rId2"/>
+          <a:stretch>
+            <a:fillRect/>
+          </a:stretch>
+        </p:blipFill>
+        <p:spPr>
+          <a:xfrm>
+            <a:off x="643763" y="4946777"/>
+            <a:ext cx="190246" cy="190246"/>
+          </a:xfrm>
+          <a:prstGeom prst="rect">
+            <a:avLst/>
+          </a:prstGeom>
+        </p:spPr>
+      </p:pic>
+      <p:sp>
+        <p:nvSpPr>
+          <p:cNvPr id="23" name="Text 14"/>
+          <p:cNvSpPr txBox="1"/>
+          <p:nvPr/>
+        </p:nvSpPr>
+        <p:spPr>
+          <a:xfrm>
+            <a:off x="1249172" y="4770120"/>
+            <a:ext cx="10391140" cy="543560"/>
+          </a:xfrm>
+          <a:prstGeom prst="rect">
+            <a:avLst/>
+          </a:prstGeom>
+          <a:noFill/>
+          <a:ln/>
+        </p:spPr>
+        <p:txBody>
+          <a:bodyPr wrap="square" lIns="0" tIns="0" rIns="0" bIns="0" rtlCol="0" anchor="ctr"/>
+          <a:lstStyle/>
+          <a:p>
+            <a:pPr marL="0" indent="0">
+              <a:buNone/>
+            </a:pPr>
+            <a:r>
+              <a:rPr lang="en-US" sz="2400" b="1" dirty="0">
+                <a:solidFill>
+                  <a:srgbClr val="1A5C2C"/>
+                </a:solidFill>
+                <a:latin typeface="Cambria" pitchFamily="34" charset="0"/>
+                <a:ea typeface="Cambria" pitchFamily="34" charset="-122"/>
+                <a:cs typeface="Cambria" pitchFamily="34" charset="-120"/>
+              </a:rPr>
+              <a:t>I  </a:t>
+            </a:r>
+            <a:r>
+              <a:rPr lang="en-US" sz="2400" dirty="0">
+                <a:solidFill>
+                  <a:srgbClr val="1F2A22"/>
+                </a:solidFill>
+                <a:latin typeface="Calibri" pitchFamily="34" charset="0"/>
+                <a:ea typeface="Calibri" pitchFamily="34" charset="-122"/>
+                <a:cs typeface="Calibri" pitchFamily="34" charset="-120"/>
+              </a:rPr>
+              <a:t>Incentive: Incentive Alignment</a:t>
+            </a:r>
+            <a:endParaRPr lang="en-US" sz="2400" dirty="0"/>
+          </a:p>
+        </p:txBody>
+      </p:sp>
+      <p:sp>
+        <p:nvSpPr>
+          <p:cNvPr id="24" name="Shape 15"/>
+          <p:cNvSpPr/>
+          <p:nvPr/>
+        </p:nvSpPr>
+        <p:spPr>
+          <a:xfrm>
+            <a:off x="548640" y="5395214"/>
+            <a:ext cx="380492" cy="380492"/>
+          </a:xfrm>
+          <a:prstGeom prst="ellipse">
+            <a:avLst/>
+          </a:prstGeom>
+          <a:solidFill>
+            <a:srgbClr val="1A5C2C"/>
+          </a:solidFill>
+          <a:ln w="12700">
+            <a:solidFill>
+              <a:srgbClr val="1A5C2C"/>
+            </a:solidFill>
+            <a:prstDash val="solid"/>
+          </a:ln>
+        </p:spPr>
+        <p:txBody>
+          <a:bodyPr/>
+          <a:lstStyle/>
+          <a:p>
+            <a:endParaRPr lang="en-ZA"/>
+          </a:p>
+        </p:txBody>
+      </p:sp>
+      <p:pic>
+        <p:nvPicPr>
+          <p:cNvPr id="25" name="Image 7" descr="preencoded.png"/>
+          <p:cNvPicPr>
+            <a:picLocks noChangeAspect="1"/>
+          </p:cNvPicPr>
+          <p:nvPr/>
+        </p:nvPicPr>
+        <p:blipFill>
+          <a:blip r:embed="rId2"/>
+          <a:stretch>
+            <a:fillRect/>
+          </a:stretch>
+        </p:blipFill>
+        <p:spPr>
+          <a:xfrm>
+            <a:off x="643763" y="5490337"/>
+            <a:ext cx="190246" cy="190246"/>
+          </a:xfrm>
+          <a:prstGeom prst="rect">
+            <a:avLst/>
+          </a:prstGeom>
+        </p:spPr>
+      </p:pic>
+      <p:sp>
+        <p:nvSpPr>
+          <p:cNvPr id="26" name="Text 16"/>
+          <p:cNvSpPr txBox="1"/>
+          <p:nvPr/>
+        </p:nvSpPr>
+        <p:spPr>
+          <a:xfrm>
+            <a:off x="1249172" y="5313680"/>
+            <a:ext cx="10391140" cy="543560"/>
+          </a:xfrm>
+          <a:prstGeom prst="rect">
+            <a:avLst/>
+          </a:prstGeom>
+          <a:noFill/>
+          <a:ln/>
+        </p:spPr>
+        <p:txBody>
+          <a:bodyPr wrap="square" lIns="0" tIns="0" rIns="0" bIns="0" rtlCol="0" anchor="ctr"/>
+          <a:lstStyle/>
+          <a:p>
+            <a:pPr marL="0" indent="0">
+              <a:buNone/>
+            </a:pPr>
+            <a:r>
+              <a:rPr lang="en-US" sz="2400" b="1" dirty="0">
+                <a:solidFill>
+                  <a:srgbClr val="1A5C2C"/>
+                </a:solidFill>
+                <a:latin typeface="Cambria" pitchFamily="34" charset="0"/>
+                <a:ea typeface="Cambria" pitchFamily="34" charset="-122"/>
+                <a:cs typeface="Cambria" pitchFamily="34" charset="-120"/>
+              </a:rPr>
+              <a:t>O  </a:t>
+            </a:r>
+            <a:r>
+              <a:rPr lang="en-US" sz="2400" dirty="0">
+                <a:solidFill>
+                  <a:srgbClr val="1F2A22"/>
+                </a:solidFill>
+                <a:latin typeface="Calibri" pitchFamily="34" charset="0"/>
+                <a:ea typeface="Calibri" pitchFamily="34" charset="-122"/>
+                <a:cs typeface="Calibri" pitchFamily="34" charset="-120"/>
+              </a:rPr>
+              <a:t>Ongoing: Review Rhythm</a:t>
+            </a:r>
+            <a:endParaRPr lang="en-US" sz="2400" dirty="0"/>
+          </a:p>
+        </p:txBody>
+      </p:sp>
+      <p:sp>
+        <p:nvSpPr>
+          <p:cNvPr id="27" name="Shape 17"/>
+          <p:cNvSpPr/>
+          <p:nvPr/>
+        </p:nvSpPr>
+        <p:spPr>
+          <a:xfrm>
+            <a:off x="548640" y="5938774"/>
+            <a:ext cx="380492" cy="380492"/>
+          </a:xfrm>
+          <a:prstGeom prst="ellipse">
+            <a:avLst/>
+          </a:prstGeom>
+          <a:solidFill>
+            <a:srgbClr val="1A5C2C"/>
+          </a:solidFill>
+          <a:ln w="12700">
+            <a:solidFill>
+              <a:srgbClr val="1A5C2C"/>
+            </a:solidFill>
+            <a:prstDash val="solid"/>
+          </a:ln>
+        </p:spPr>
+        <p:txBody>
+          <a:bodyPr/>
+          <a:lstStyle/>
+          <a:p>
+            <a:endParaRPr lang="en-ZA"/>
+          </a:p>
+        </p:txBody>
+      </p:sp>
+      <p:pic>
+        <p:nvPicPr>
+          <p:cNvPr id="28" name="Image 8" descr="preencoded.png"/>
+          <p:cNvPicPr>
+            <a:picLocks noChangeAspect="1"/>
+          </p:cNvPicPr>
+          <p:nvPr/>
+        </p:nvPicPr>
+        <p:blipFill>
+          <a:blip r:embed="rId2"/>
+          <a:stretch>
+            <a:fillRect/>
+          </a:stretch>
+        </p:blipFill>
+        <p:spPr>
+          <a:xfrm>
+            <a:off x="643763" y="6033897"/>
+            <a:ext cx="190246" cy="190246"/>
+          </a:xfrm>
+          <a:prstGeom prst="rect">
+            <a:avLst/>
+          </a:prstGeom>
+        </p:spPr>
+      </p:pic>
+      <p:sp>
+        <p:nvSpPr>
+          <p:cNvPr id="29" name="Text 18"/>
+          <p:cNvSpPr txBox="1"/>
+          <p:nvPr/>
+        </p:nvSpPr>
+        <p:spPr>
+          <a:xfrm>
+            <a:off x="1249172" y="5857240"/>
+            <a:ext cx="10391140" cy="543560"/>
+          </a:xfrm>
+          <a:prstGeom prst="rect">
+            <a:avLst/>
+          </a:prstGeom>
+          <a:noFill/>
+          <a:ln/>
+        </p:spPr>
+        <p:txBody>
+          <a:bodyPr wrap="square" lIns="0" tIns="0" rIns="0" bIns="0" rtlCol="0" anchor="ctr"/>
+          <a:lstStyle/>
+          <a:p>
+            <a:pPr marL="0" indent="0">
+              <a:buNone/>
+            </a:pPr>
+            <a:r>
+              <a:rPr lang="en-US" sz="2400" b="1" dirty="0">
+                <a:solidFill>
+                  <a:srgbClr val="1A5C2C"/>
+                </a:solidFill>
+                <a:latin typeface="Cambria" pitchFamily="34" charset="0"/>
+                <a:ea typeface="Cambria" pitchFamily="34" charset="-122"/>
+                <a:cs typeface="Cambria" pitchFamily="34" charset="-120"/>
+              </a:rPr>
+              <a:t>N  </a:t>
+            </a:r>
+            <a:r>
+              <a:rPr lang="en-US" sz="2400" dirty="0">
+                <a:solidFill>
+                  <a:srgbClr val="1F2A22"/>
+                </a:solidFill>
+                <a:latin typeface="Calibri" pitchFamily="34" charset="0"/>
+                <a:ea typeface="Calibri" pitchFamily="34" charset="-122"/>
+                <a:cs typeface="Calibri" pitchFamily="34" charset="-120"/>
+              </a:rPr>
+              <a:t>Navigate: Collective Insight</a:t>
+            </a:r>
+            <a:endParaRPr lang="en-US" sz="2400" dirty="0"/>
+          </a:p>
+        </p:txBody>
+      </p:sp>
+    </p:spTree>
+  </p:cSld>
+  <p:clrMapOvr>
+    <a:masterClrMapping/>
+  </p:clrMapOvr>
+</p:sld>
+</file>
+
+<file path=ppt/slides/slide27.xml><?xml version="1.0" encoding="utf-8"?>
+<p:sld xmlns:a="http://schemas.openxmlformats.org/drawingml/2006/main" xmlns:r="http://schemas.openxmlformats.org/officeDocument/2006/relationships" xmlns:p="http://schemas.openxmlformats.org/presentationml/2006/main">
   <p:cSld name="Slide 25">
     <p:bg>
       <p:bgPr>
@@ -16600,715 +18922,7 @@
 </p:sld>
 </file>
 
-<file path=ppt/slides/slide25.xml><?xml version="1.0" encoding="utf-8"?>
-<p:sld xmlns:a="http://schemas.openxmlformats.org/drawingml/2006/main" xmlns:r="http://schemas.openxmlformats.org/officeDocument/2006/relationships" xmlns:p="http://schemas.openxmlformats.org/presentationml/2006/main">
-  <p:cSld name="Slide 26">
-    <p:bg>
-      <p:bgPr>
-        <a:solidFill>
-          <a:srgbClr val="FFFFFF"/>
-        </a:solidFill>
-        <a:effectLst/>
-      </p:bgPr>
-    </p:bg>
-    <p:spTree>
-      <p:nvGrpSpPr>
-        <p:cNvPr id="1" name=""/>
-        <p:cNvGrpSpPr/>
-        <p:nvPr/>
-      </p:nvGrpSpPr>
-      <p:grpSpPr>
-        <a:xfrm>
-          <a:off x="0" y="0"/>
-          <a:ext cx="0" cy="0"/>
-          <a:chOff x="0" y="0"/>
-          <a:chExt cx="0" cy="0"/>
-        </a:xfrm>
-      </p:grpSpPr>
-      <p:sp>
-        <p:nvSpPr>
-          <p:cNvPr id="2" name="Text 0"/>
-          <p:cNvSpPr txBox="1"/>
-          <p:nvPr/>
-        </p:nvSpPr>
-        <p:spPr>
-          <a:xfrm>
-            <a:off x="548640" y="411480"/>
-            <a:ext cx="11064240" cy="868680"/>
-          </a:xfrm>
-          <a:prstGeom prst="rect">
-            <a:avLst/>
-          </a:prstGeom>
-          <a:noFill/>
-          <a:ln/>
-        </p:spPr>
-        <p:txBody>
-          <a:bodyPr wrap="square" lIns="0" tIns="0" rIns="0" bIns="0" rtlCol="0" anchor="ctr"/>
-          <a:lstStyle/>
-          <a:p>
-            <a:pPr marL="0" indent="0">
-              <a:buNone/>
-            </a:pPr>
-            <a:r>
-              <a:rPr lang="en-US" sz="3600" b="1" dirty="0">
-                <a:solidFill>
-                  <a:srgbClr val="1A5C2C"/>
-                </a:solidFill>
-                <a:latin typeface="Cambria" pitchFamily="34" charset="0"/>
-                <a:ea typeface="Cambria" pitchFamily="34" charset="-122"/>
-                <a:cs typeface="Cambria" pitchFamily="34" charset="-120"/>
-              </a:rPr>
-              <a:t>Step 1 · Scoring Logic</a:t>
-            </a:r>
-            <a:endParaRPr lang="en-US" sz="3600" dirty="0"/>
-          </a:p>
-        </p:txBody>
-      </p:sp>
-      <p:sp>
-        <p:nvSpPr>
-          <p:cNvPr id="3" name="Shape 1"/>
-          <p:cNvSpPr/>
-          <p:nvPr/>
-        </p:nvSpPr>
-        <p:spPr>
-          <a:xfrm>
-            <a:off x="548640" y="1631061"/>
-            <a:ext cx="570738" cy="570738"/>
-          </a:xfrm>
-          <a:prstGeom prst="ellipse">
-            <a:avLst/>
-          </a:prstGeom>
-          <a:solidFill>
-            <a:srgbClr val="1A5C2C"/>
-          </a:solidFill>
-          <a:ln w="12700">
-            <a:solidFill>
-              <a:srgbClr val="1A5C2C"/>
-            </a:solidFill>
-            <a:prstDash val="solid"/>
-          </a:ln>
-        </p:spPr>
-        <p:txBody>
-          <a:bodyPr/>
-          <a:lstStyle/>
-          <a:p>
-            <a:endParaRPr lang="en-ZA"/>
-          </a:p>
-        </p:txBody>
-      </p:sp>
-      <p:pic>
-        <p:nvPicPr>
-          <p:cNvPr id="4" name="Image 0" descr="preencoded.png"/>
-          <p:cNvPicPr>
-            <a:picLocks noChangeAspect="1"/>
-          </p:cNvPicPr>
-          <p:nvPr/>
-        </p:nvPicPr>
-        <p:blipFill>
-          <a:blip r:embed="rId3"/>
-          <a:stretch>
-            <a:fillRect/>
-          </a:stretch>
-        </p:blipFill>
-        <p:spPr>
-          <a:xfrm>
-            <a:off x="691325" y="1773746"/>
-            <a:ext cx="285369" cy="285369"/>
-          </a:xfrm>
-          <a:prstGeom prst="rect">
-            <a:avLst/>
-          </a:prstGeom>
-        </p:spPr>
-      </p:pic>
-      <p:sp>
-        <p:nvSpPr>
-          <p:cNvPr id="5" name="Text 2"/>
-          <p:cNvSpPr txBox="1"/>
-          <p:nvPr/>
-        </p:nvSpPr>
-        <p:spPr>
-          <a:xfrm>
-            <a:off x="1439418" y="1508760"/>
-            <a:ext cx="10200894" cy="815340"/>
-          </a:xfrm>
-          <a:prstGeom prst="rect">
-            <a:avLst/>
-          </a:prstGeom>
-          <a:noFill/>
-          <a:ln/>
-        </p:spPr>
-        <p:txBody>
-          <a:bodyPr wrap="square" lIns="0" tIns="0" rIns="0" bIns="0" rtlCol="0" anchor="ctr"/>
-          <a:lstStyle/>
-          <a:p>
-            <a:pPr marL="0" indent="0">
-              <a:buNone/>
-            </a:pPr>
-            <a:r>
-              <a:rPr lang="en-US" sz="2400" b="1" dirty="0">
-                <a:solidFill>
-                  <a:srgbClr val="1A5C2C"/>
-                </a:solidFill>
-                <a:latin typeface="Cambria" pitchFamily="34" charset="0"/>
-                <a:ea typeface="Cambria" pitchFamily="34" charset="-122"/>
-                <a:cs typeface="Cambria" pitchFamily="34" charset="-120"/>
-              </a:rPr>
-              <a:t>1  </a:t>
-            </a:r>
-            <a:r>
-              <a:rPr lang="en-US" sz="2400" dirty="0">
-                <a:solidFill>
-                  <a:srgbClr val="1F2A22"/>
-                </a:solidFill>
-                <a:latin typeface="Calibri" pitchFamily="34" charset="0"/>
-                <a:ea typeface="Calibri" pitchFamily="34" charset="-122"/>
-                <a:cs typeface="Calibri" pitchFamily="34" charset="-120"/>
-              </a:rPr>
-              <a:t>Performance level that earns this rating</a:t>
-            </a:r>
-            <a:endParaRPr lang="en-US" sz="2400" dirty="0"/>
-          </a:p>
-        </p:txBody>
-      </p:sp>
-      <p:sp>
-        <p:nvSpPr>
-          <p:cNvPr id="6" name="Shape 3"/>
-          <p:cNvSpPr/>
-          <p:nvPr/>
-        </p:nvSpPr>
-        <p:spPr>
-          <a:xfrm>
-            <a:off x="548640" y="2446401"/>
-            <a:ext cx="570738" cy="570738"/>
-          </a:xfrm>
-          <a:prstGeom prst="ellipse">
-            <a:avLst/>
-          </a:prstGeom>
-          <a:solidFill>
-            <a:srgbClr val="1A5C2C"/>
-          </a:solidFill>
-          <a:ln w="12700">
-            <a:solidFill>
-              <a:srgbClr val="1A5C2C"/>
-            </a:solidFill>
-            <a:prstDash val="solid"/>
-          </a:ln>
-        </p:spPr>
-        <p:txBody>
-          <a:bodyPr/>
-          <a:lstStyle/>
-          <a:p>
-            <a:endParaRPr lang="en-ZA"/>
-          </a:p>
-        </p:txBody>
-      </p:sp>
-      <p:pic>
-        <p:nvPicPr>
-          <p:cNvPr id="7" name="Image 1" descr="preencoded.png"/>
-          <p:cNvPicPr>
-            <a:picLocks noChangeAspect="1"/>
-          </p:cNvPicPr>
-          <p:nvPr/>
-        </p:nvPicPr>
-        <p:blipFill>
-          <a:blip r:embed="rId4"/>
-          <a:stretch>
-            <a:fillRect/>
-          </a:stretch>
-        </p:blipFill>
-        <p:spPr>
-          <a:xfrm>
-            <a:off x="691325" y="2589085"/>
-            <a:ext cx="285369" cy="285369"/>
-          </a:xfrm>
-          <a:prstGeom prst="rect">
-            <a:avLst/>
-          </a:prstGeom>
-        </p:spPr>
-      </p:pic>
-      <p:sp>
-        <p:nvSpPr>
-          <p:cNvPr id="8" name="Text 4"/>
-          <p:cNvSpPr txBox="1"/>
-          <p:nvPr/>
-        </p:nvSpPr>
-        <p:spPr>
-          <a:xfrm>
-            <a:off x="1439418" y="2324100"/>
-            <a:ext cx="10200894" cy="815340"/>
-          </a:xfrm>
-          <a:prstGeom prst="rect">
-            <a:avLst/>
-          </a:prstGeom>
-          <a:noFill/>
-          <a:ln/>
-        </p:spPr>
-        <p:txBody>
-          <a:bodyPr wrap="square" lIns="0" tIns="0" rIns="0" bIns="0" rtlCol="0" anchor="ctr"/>
-          <a:lstStyle/>
-          <a:p>
-            <a:pPr marL="0" indent="0">
-              <a:buNone/>
-            </a:pPr>
-            <a:r>
-              <a:rPr lang="en-US" sz="2400" b="1" dirty="0">
-                <a:solidFill>
-                  <a:srgbClr val="1A5C2C"/>
-                </a:solidFill>
-                <a:latin typeface="Cambria" pitchFamily="34" charset="0"/>
-                <a:ea typeface="Cambria" pitchFamily="34" charset="-122"/>
-                <a:cs typeface="Cambria" pitchFamily="34" charset="-120"/>
-              </a:rPr>
-              <a:t>2  </a:t>
-            </a:r>
-            <a:r>
-              <a:rPr lang="en-US" sz="2400" dirty="0">
-                <a:solidFill>
-                  <a:srgbClr val="1F2A22"/>
-                </a:solidFill>
-                <a:latin typeface="Calibri" pitchFamily="34" charset="0"/>
-                <a:ea typeface="Calibri" pitchFamily="34" charset="-122"/>
-                <a:cs typeface="Calibri" pitchFamily="34" charset="-120"/>
-              </a:rPr>
-              <a:t>Evidence required to confirm it</a:t>
-            </a:r>
-            <a:endParaRPr lang="en-US" sz="2400" dirty="0"/>
-          </a:p>
-        </p:txBody>
-      </p:sp>
-      <p:sp>
-        <p:nvSpPr>
-          <p:cNvPr id="9" name="Shape 5"/>
-          <p:cNvSpPr/>
-          <p:nvPr/>
-        </p:nvSpPr>
-        <p:spPr>
-          <a:xfrm>
-            <a:off x="548640" y="3261741"/>
-            <a:ext cx="570738" cy="570738"/>
-          </a:xfrm>
-          <a:prstGeom prst="ellipse">
-            <a:avLst/>
-          </a:prstGeom>
-          <a:solidFill>
-            <a:srgbClr val="1A5C2C"/>
-          </a:solidFill>
-          <a:ln w="12700">
-            <a:solidFill>
-              <a:srgbClr val="1A5C2C"/>
-            </a:solidFill>
-            <a:prstDash val="solid"/>
-          </a:ln>
-        </p:spPr>
-        <p:txBody>
-          <a:bodyPr/>
-          <a:lstStyle/>
-          <a:p>
-            <a:endParaRPr lang="en-ZA"/>
-          </a:p>
-        </p:txBody>
-      </p:sp>
-      <p:pic>
-        <p:nvPicPr>
-          <p:cNvPr id="10" name="Image 2" descr="preencoded.png"/>
-          <p:cNvPicPr>
-            <a:picLocks noChangeAspect="1"/>
-          </p:cNvPicPr>
-          <p:nvPr/>
-        </p:nvPicPr>
-        <p:blipFill>
-          <a:blip r:embed="rId5"/>
-          <a:stretch>
-            <a:fillRect/>
-          </a:stretch>
-        </p:blipFill>
-        <p:spPr>
-          <a:xfrm>
-            <a:off x="691325" y="3404425"/>
-            <a:ext cx="285369" cy="285369"/>
-          </a:xfrm>
-          <a:prstGeom prst="rect">
-            <a:avLst/>
-          </a:prstGeom>
-        </p:spPr>
-      </p:pic>
-      <p:sp>
-        <p:nvSpPr>
-          <p:cNvPr id="11" name="Text 6"/>
-          <p:cNvSpPr txBox="1"/>
-          <p:nvPr/>
-        </p:nvSpPr>
-        <p:spPr>
-          <a:xfrm>
-            <a:off x="1439418" y="3139440"/>
-            <a:ext cx="10200894" cy="815340"/>
-          </a:xfrm>
-          <a:prstGeom prst="rect">
-            <a:avLst/>
-          </a:prstGeom>
-          <a:noFill/>
-          <a:ln/>
-        </p:spPr>
-        <p:txBody>
-          <a:bodyPr wrap="square" lIns="0" tIns="0" rIns="0" bIns="0" rtlCol="0" anchor="ctr"/>
-          <a:lstStyle/>
-          <a:p>
-            <a:pPr marL="0" indent="0">
-              <a:buNone/>
-            </a:pPr>
-            <a:r>
-              <a:rPr lang="en-US" sz="2400" b="1" dirty="0">
-                <a:solidFill>
-                  <a:srgbClr val="1A5C2C"/>
-                </a:solidFill>
-                <a:latin typeface="Cambria" pitchFamily="34" charset="0"/>
-                <a:ea typeface="Cambria" pitchFamily="34" charset="-122"/>
-                <a:cs typeface="Cambria" pitchFamily="34" charset="-120"/>
-              </a:rPr>
-              <a:t>3  </a:t>
-            </a:r>
-            <a:r>
-              <a:rPr lang="en-US" sz="2400" dirty="0">
-                <a:solidFill>
-                  <a:srgbClr val="1F2A22"/>
-                </a:solidFill>
-                <a:latin typeface="Calibri" pitchFamily="34" charset="0"/>
-                <a:ea typeface="Calibri" pitchFamily="34" charset="-122"/>
-                <a:cs typeface="Calibri" pitchFamily="34" charset="-120"/>
-              </a:rPr>
-              <a:t>Contextual factors that might legitimately affect a rating</a:t>
-            </a:r>
-            <a:endParaRPr lang="en-US" sz="2400" dirty="0"/>
-          </a:p>
-        </p:txBody>
-      </p:sp>
-      <p:sp>
-        <p:nvSpPr>
-          <p:cNvPr id="12" name="Shape 7"/>
-          <p:cNvSpPr/>
-          <p:nvPr/>
-        </p:nvSpPr>
-        <p:spPr>
-          <a:xfrm>
-            <a:off x="548640" y="4077081"/>
-            <a:ext cx="570738" cy="570738"/>
-          </a:xfrm>
-          <a:prstGeom prst="ellipse">
-            <a:avLst/>
-          </a:prstGeom>
-          <a:solidFill>
-            <a:srgbClr val="1A5C2C"/>
-          </a:solidFill>
-          <a:ln w="12700">
-            <a:solidFill>
-              <a:srgbClr val="1A5C2C"/>
-            </a:solidFill>
-            <a:prstDash val="solid"/>
-          </a:ln>
-        </p:spPr>
-        <p:txBody>
-          <a:bodyPr/>
-          <a:lstStyle/>
-          <a:p>
-            <a:endParaRPr lang="en-ZA"/>
-          </a:p>
-        </p:txBody>
-      </p:sp>
-      <p:pic>
-        <p:nvPicPr>
-          <p:cNvPr id="13" name="Image 3" descr="preencoded.png"/>
-          <p:cNvPicPr>
-            <a:picLocks noChangeAspect="1"/>
-          </p:cNvPicPr>
-          <p:nvPr/>
-        </p:nvPicPr>
-        <p:blipFill>
-          <a:blip r:embed="rId6"/>
-          <a:stretch>
-            <a:fillRect/>
-          </a:stretch>
-        </p:blipFill>
-        <p:spPr>
-          <a:xfrm>
-            <a:off x="691325" y="4219766"/>
-            <a:ext cx="285369" cy="285369"/>
-          </a:xfrm>
-          <a:prstGeom prst="rect">
-            <a:avLst/>
-          </a:prstGeom>
-        </p:spPr>
-      </p:pic>
-      <p:sp>
-        <p:nvSpPr>
-          <p:cNvPr id="14" name="Text 8"/>
-          <p:cNvSpPr txBox="1"/>
-          <p:nvPr/>
-        </p:nvSpPr>
-        <p:spPr>
-          <a:xfrm>
-            <a:off x="1439418" y="3954780"/>
-            <a:ext cx="10200894" cy="815340"/>
-          </a:xfrm>
-          <a:prstGeom prst="rect">
-            <a:avLst/>
-          </a:prstGeom>
-          <a:noFill/>
-          <a:ln/>
-        </p:spPr>
-        <p:txBody>
-          <a:bodyPr wrap="square" lIns="0" tIns="0" rIns="0" bIns="0" rtlCol="0" anchor="ctr"/>
-          <a:lstStyle/>
-          <a:p>
-            <a:pPr marL="0" indent="0">
-              <a:buNone/>
-            </a:pPr>
-            <a:r>
-              <a:rPr lang="en-US" sz="2400" b="1" dirty="0">
-                <a:solidFill>
-                  <a:srgbClr val="1A5C2C"/>
-                </a:solidFill>
-                <a:latin typeface="Cambria" pitchFamily="34" charset="0"/>
-                <a:ea typeface="Cambria" pitchFamily="34" charset="-122"/>
-                <a:cs typeface="Cambria" pitchFamily="34" charset="-120"/>
-              </a:rPr>
-              <a:t>4  </a:t>
-            </a:r>
-            <a:r>
-              <a:rPr lang="en-US" sz="2400" dirty="0">
-                <a:solidFill>
-                  <a:srgbClr val="1F2A22"/>
-                </a:solidFill>
-                <a:latin typeface="Calibri" pitchFamily="34" charset="0"/>
-                <a:ea typeface="Calibri" pitchFamily="34" charset="-122"/>
-                <a:cs typeface="Calibri" pitchFamily="34" charset="-120"/>
-              </a:rPr>
-              <a:t>Lines of sight of progress</a:t>
-            </a:r>
-            <a:endParaRPr lang="en-US" sz="2400" dirty="0"/>
-          </a:p>
-        </p:txBody>
-      </p:sp>
-      <p:sp>
-        <p:nvSpPr>
-          <p:cNvPr id="15" name="Shape 9"/>
-          <p:cNvSpPr/>
-          <p:nvPr/>
-        </p:nvSpPr>
-        <p:spPr>
-          <a:xfrm>
-            <a:off x="548640" y="4892421"/>
-            <a:ext cx="570738" cy="570738"/>
-          </a:xfrm>
-          <a:prstGeom prst="ellipse">
-            <a:avLst/>
-          </a:prstGeom>
-          <a:solidFill>
-            <a:srgbClr val="1A5C2C"/>
-          </a:solidFill>
-          <a:ln w="12700">
-            <a:solidFill>
-              <a:srgbClr val="1A5C2C"/>
-            </a:solidFill>
-            <a:prstDash val="solid"/>
-          </a:ln>
-        </p:spPr>
-        <p:txBody>
-          <a:bodyPr/>
-          <a:lstStyle/>
-          <a:p>
-            <a:endParaRPr lang="en-ZA"/>
-          </a:p>
-        </p:txBody>
-      </p:sp>
-      <p:pic>
-        <p:nvPicPr>
-          <p:cNvPr id="16" name="Image 4" descr="preencoded.png"/>
-          <p:cNvPicPr>
-            <a:picLocks noChangeAspect="1"/>
-          </p:cNvPicPr>
-          <p:nvPr/>
-        </p:nvPicPr>
-        <p:blipFill>
-          <a:blip r:embed="rId7"/>
-          <a:stretch>
-            <a:fillRect/>
-          </a:stretch>
-        </p:blipFill>
-        <p:spPr>
-          <a:xfrm>
-            <a:off x="691325" y="5035106"/>
-            <a:ext cx="285369" cy="285369"/>
-          </a:xfrm>
-          <a:prstGeom prst="rect">
-            <a:avLst/>
-          </a:prstGeom>
-        </p:spPr>
-      </p:pic>
-      <p:sp>
-        <p:nvSpPr>
-          <p:cNvPr id="17" name="Text 10"/>
-          <p:cNvSpPr txBox="1"/>
-          <p:nvPr/>
-        </p:nvSpPr>
-        <p:spPr>
-          <a:xfrm>
-            <a:off x="1439418" y="4770120"/>
-            <a:ext cx="10200894" cy="815340"/>
-          </a:xfrm>
-          <a:prstGeom prst="rect">
-            <a:avLst/>
-          </a:prstGeom>
-          <a:noFill/>
-          <a:ln/>
-        </p:spPr>
-        <p:txBody>
-          <a:bodyPr wrap="square" lIns="0" tIns="0" rIns="0" bIns="0" rtlCol="0" anchor="ctr"/>
-          <a:lstStyle/>
-          <a:p>
-            <a:pPr marL="0" indent="0">
-              <a:buNone/>
-            </a:pPr>
-            <a:r>
-              <a:rPr lang="en-US" sz="2400" b="1" dirty="0">
-                <a:solidFill>
-                  <a:srgbClr val="1A5C2C"/>
-                </a:solidFill>
-                <a:latin typeface="Cambria" pitchFamily="34" charset="0"/>
-                <a:ea typeface="Cambria" pitchFamily="34" charset="-122"/>
-                <a:cs typeface="Cambria" pitchFamily="34" charset="-120"/>
-              </a:rPr>
-              <a:t>5  </a:t>
-            </a:r>
-            <a:r>
-              <a:rPr lang="en-US" sz="2400" dirty="0">
-                <a:solidFill>
-                  <a:srgbClr val="1F2A22"/>
-                </a:solidFill>
-                <a:latin typeface="Calibri" pitchFamily="34" charset="0"/>
-                <a:ea typeface="Calibri" pitchFamily="34" charset="-122"/>
-                <a:cs typeface="Calibri" pitchFamily="34" charset="-120"/>
-              </a:rPr>
-              <a:t>Review cadence and why</a:t>
-            </a:r>
-            <a:endParaRPr lang="en-US" sz="2400" dirty="0"/>
-          </a:p>
-        </p:txBody>
-      </p:sp>
-      <p:sp>
-        <p:nvSpPr>
-          <p:cNvPr id="18" name="Shape 11"/>
-          <p:cNvSpPr/>
-          <p:nvPr/>
-        </p:nvSpPr>
-        <p:spPr>
-          <a:xfrm>
-            <a:off x="548640" y="5707761"/>
-            <a:ext cx="570738" cy="570738"/>
-          </a:xfrm>
-          <a:prstGeom prst="ellipse">
-            <a:avLst/>
-          </a:prstGeom>
-          <a:solidFill>
-            <a:srgbClr val="1A5C2C"/>
-          </a:solidFill>
-          <a:ln w="12700">
-            <a:solidFill>
-              <a:srgbClr val="1A5C2C"/>
-            </a:solidFill>
-            <a:prstDash val="solid"/>
-          </a:ln>
-        </p:spPr>
-        <p:txBody>
-          <a:bodyPr/>
-          <a:lstStyle/>
-          <a:p>
-            <a:endParaRPr lang="en-ZA"/>
-          </a:p>
-        </p:txBody>
-      </p:sp>
-      <p:pic>
-        <p:nvPicPr>
-          <p:cNvPr id="19" name="Image 5" descr="preencoded.png"/>
-          <p:cNvPicPr>
-            <a:picLocks noChangeAspect="1"/>
-          </p:cNvPicPr>
-          <p:nvPr/>
-        </p:nvPicPr>
-        <p:blipFill>
-          <a:blip r:embed="rId8"/>
-          <a:stretch>
-            <a:fillRect/>
-          </a:stretch>
-        </p:blipFill>
-        <p:spPr>
-          <a:xfrm>
-            <a:off x="691325" y="5850445"/>
-            <a:ext cx="285369" cy="285369"/>
-          </a:xfrm>
-          <a:prstGeom prst="rect">
-            <a:avLst/>
-          </a:prstGeom>
-        </p:spPr>
-      </p:pic>
-      <p:sp>
-        <p:nvSpPr>
-          <p:cNvPr id="20" name="Text 12"/>
-          <p:cNvSpPr txBox="1"/>
-          <p:nvPr/>
-        </p:nvSpPr>
-        <p:spPr>
-          <a:xfrm>
-            <a:off x="1439418" y="5585460"/>
-            <a:ext cx="10200894" cy="815340"/>
-          </a:xfrm>
-          <a:prstGeom prst="rect">
-            <a:avLst/>
-          </a:prstGeom>
-          <a:noFill/>
-          <a:ln/>
-        </p:spPr>
-        <p:txBody>
-          <a:bodyPr wrap="square" lIns="0" tIns="0" rIns="0" bIns="0" rtlCol="0" anchor="ctr"/>
-          <a:lstStyle/>
-          <a:p>
-            <a:pPr marL="0" indent="0">
-              <a:buNone/>
-            </a:pPr>
-            <a:r>
-              <a:rPr lang="en-US" sz="2400" b="1" dirty="0">
-                <a:solidFill>
-                  <a:srgbClr val="1A5C2C"/>
-                </a:solidFill>
-                <a:latin typeface="Cambria" pitchFamily="34" charset="0"/>
-                <a:ea typeface="Cambria" pitchFamily="34" charset="-122"/>
-                <a:cs typeface="Cambria" pitchFamily="34" charset="-120"/>
-              </a:rPr>
-              <a:t>6  </a:t>
-            </a:r>
-            <a:r>
-              <a:rPr lang="en-US" sz="2400" dirty="0">
-                <a:solidFill>
-                  <a:srgbClr val="1F2A22"/>
-                </a:solidFill>
-                <a:latin typeface="Calibri" pitchFamily="34" charset="0"/>
-                <a:ea typeface="Calibri" pitchFamily="34" charset="-122"/>
-                <a:cs typeface="Calibri" pitchFamily="34" charset="-120"/>
-              </a:rPr>
-              <a:t>Leadership response in the monthly review</a:t>
-            </a:r>
-            <a:endParaRPr lang="en-US" sz="2400" dirty="0"/>
-          </a:p>
-        </p:txBody>
-      </p:sp>
-    </p:spTree>
-  </p:cSld>
-  <p:clrMapOvr>
-    <a:masterClrMapping/>
-  </p:clrMapOvr>
-</p:sld>
-</file>
-
-<file path=ppt/slides/slide27.xml><?xml version="1.0" encoding="utf-8"?>
+<file path=ppt/slides/slide28.xml><?xml version="1.0" encoding="utf-8"?>
 <p:sld xmlns:a="http://schemas.openxmlformats.org/drawingml/2006/main" xmlns:r="http://schemas.openxmlformats.org/officeDocument/2006/relationships" xmlns:p="http://schemas.openxmlformats.org/presentationml/2006/main">
   <p:cSld name="Slide 28">
     <p:bg>
@@ -17501,1620 +19115,6 @@
                 <a:cs typeface="Calibri" pitchFamily="34" charset="-120"/>
               </a:rPr>
               <a:t>Specificity is the test of whether the unit has converted into intent.</a:t>
-            </a:r>
-            <a:endParaRPr lang="en-US" sz="2400" dirty="0"/>
-          </a:p>
-        </p:txBody>
-      </p:sp>
-    </p:spTree>
-  </p:cSld>
-  <p:clrMapOvr>
-    <a:masterClrMapping/>
-  </p:clrMapOvr>
-</p:sld>
-</file>
-
-<file path=ppt/slides/slide28.xml><?xml version="1.0" encoding="utf-8"?>
-<p:sld xmlns:a="http://schemas.openxmlformats.org/drawingml/2006/main" xmlns:p="http://schemas.openxmlformats.org/presentationml/2006/main" xmlns:r="http://schemas.openxmlformats.org/officeDocument/2006/relationships">
-  <p:cSld>
-    <p:bg>
-      <p:bgPr>
-        <a:solidFill>
-          <a:srgbClr val="FFFFFF"/>
-        </a:solidFill>
-        <a:effectLst/>
-      </p:bgPr>
-    </p:bg>
-    <p:spTree>
-      <p:nvGrpSpPr>
-        <p:cNvPr id="1" name=""/>
-        <p:cNvGrpSpPr/>
-        <p:nvPr/>
-      </p:nvGrpSpPr>
-      <p:grpSpPr/>
-      <p:sp>
-        <p:nvSpPr>
-          <p:cNvPr id="2" name="Text 0"/>
-          <p:cNvSpPr txBox="1"/>
-          <p:nvPr/>
-        </p:nvSpPr>
-        <p:spPr>
-          <a:xfrm>
-            <a:off x="548640" y="411480"/>
-            <a:ext cx="11064240" cy="868680"/>
-          </a:xfrm>
-          <a:prstGeom prst="rect">
-            <a:avLst/>
-          </a:prstGeom>
-          <a:noFill/>
-          <a:ln/>
-        </p:spPr>
-        <p:txBody>
-          <a:bodyPr wrap="square" lIns="0" tIns="0" rIns="0" bIns="0" rtlCol="0" anchor="ctr"/>
-          <a:lstStyle/>
-          <a:p>
-            <a:pPr marL="0" indent="0">
-              <a:buNone/>
-            </a:pPr>
-            <a:r>
-              <a:rPr lang="en-US" sz="3600" b="1" dirty="0">
-                <a:solidFill>
-                  <a:srgbClr val="1A5C2C"/>
-                </a:solidFill>
-                <a:latin typeface="Cambria" pitchFamily="34" charset="0"/>
-                <a:ea typeface="Cambria" pitchFamily="34" charset="-122"/>
-                <a:cs typeface="Cambria" pitchFamily="34" charset="-120"/>
-              </a:rPr>
-              <a:t>Step 2 · FACES</a:t>
-            </a:r>
-            <a:endParaRPr lang="en-US" sz="3600" dirty="0"/>
-          </a:p>
-        </p:txBody>
-      </p:sp>
-      <p:sp>
-        <p:nvSpPr>
-          <p:cNvPr id="3" name="Shape 1"/>
-          <p:cNvSpPr/>
-          <p:nvPr/>
-        </p:nvSpPr>
-        <p:spPr>
-          <a:xfrm>
-            <a:off x="548640" y="1677924"/>
-            <a:ext cx="640080" cy="640080"/>
-          </a:xfrm>
-          <a:prstGeom prst="ellipse">
-            <a:avLst/>
-          </a:prstGeom>
-          <a:solidFill>
-            <a:srgbClr val="1A5C2C"/>
-          </a:solidFill>
-          <a:ln w="12700">
-            <a:solidFill>
-              <a:srgbClr val="1A5C2C"/>
-            </a:solidFill>
-            <a:prstDash val="solid"/>
-          </a:ln>
-        </p:spPr>
-        <p:txBody>
-          <a:bodyPr/>
-          <a:lstStyle/>
-          <a:p>
-            <a:endParaRPr lang="en-ZA"/>
-          </a:p>
-        </p:txBody>
-      </p:sp>
-      <p:pic>
-        <p:nvPicPr>
-          <p:cNvPr id="4" name="Image 0" descr="preencoded.png"/>
-          <p:cNvPicPr>
-            <a:picLocks noChangeAspect="1"/>
-          </p:cNvPicPr>
-          <p:nvPr/>
-        </p:nvPicPr>
-        <p:blipFill>
-          <a:blip r:embed="rId2"/>
-          <a:stretch>
-            <a:fillRect/>
-          </a:stretch>
-        </p:blipFill>
-        <p:spPr>
-          <a:xfrm>
-            <a:off x="708660" y="1837944"/>
-            <a:ext cx="320040" cy="320040"/>
-          </a:xfrm>
-          <a:prstGeom prst="rect">
-            <a:avLst/>
-          </a:prstGeom>
-        </p:spPr>
-      </p:pic>
-      <p:sp>
-        <p:nvSpPr>
-          <p:cNvPr id="5" name="Text 2"/>
-          <p:cNvSpPr txBox="1"/>
-          <p:nvPr/>
-        </p:nvSpPr>
-        <p:spPr>
-          <a:xfrm>
-            <a:off x="1508760" y="1508760"/>
-            <a:ext cx="10131552" cy="978408"/>
-          </a:xfrm>
-          <a:prstGeom prst="rect">
-            <a:avLst/>
-          </a:prstGeom>
-          <a:noFill/>
-          <a:ln/>
-        </p:spPr>
-        <p:txBody>
-          <a:bodyPr wrap="square" lIns="0" tIns="0" rIns="0" bIns="0" rtlCol="0" anchor="ctr"/>
-          <a:lstStyle/>
-          <a:p>
-            <a:pPr marL="0" indent="0">
-              <a:buNone/>
-            </a:pPr>
-            <a:r>
-              <a:rPr lang="en-US" sz="2600" b="1" dirty="0">
-                <a:solidFill>
-                  <a:srgbClr val="1A5C2C"/>
-                </a:solidFill>
-                <a:latin typeface="Cambria" pitchFamily="34" charset="0"/>
-                <a:ea typeface="Cambria" pitchFamily="34" charset="-122"/>
-                <a:cs typeface="Cambria" pitchFamily="34" charset="-120"/>
-              </a:rPr>
-              <a:t>F  </a:t>
-            </a:r>
-            <a:r>
-              <a:rPr lang="en-US" sz="2600" dirty="0">
-                <a:solidFill>
-                  <a:srgbClr val="1F2A22"/>
-                </a:solidFill>
-                <a:latin typeface="Calibri" pitchFamily="34" charset="0"/>
-                <a:ea typeface="Calibri" pitchFamily="34" charset="-122"/>
-                <a:cs typeface="Calibri" pitchFamily="34" charset="-120"/>
-              </a:rPr>
-              <a:t>Foster a Results Culture</a:t>
-            </a:r>
-            <a:endParaRPr lang="en-US" sz="2600" dirty="0"/>
-          </a:p>
-        </p:txBody>
-      </p:sp>
-      <p:sp>
-        <p:nvSpPr>
-          <p:cNvPr id="6" name="Shape 3"/>
-          <p:cNvSpPr/>
-          <p:nvPr/>
-        </p:nvSpPr>
-        <p:spPr>
-          <a:xfrm>
-            <a:off x="548640" y="2656332"/>
-            <a:ext cx="640080" cy="640080"/>
-          </a:xfrm>
-          <a:prstGeom prst="ellipse">
-            <a:avLst/>
-          </a:prstGeom>
-          <a:solidFill>
-            <a:srgbClr val="1A5C2C"/>
-          </a:solidFill>
-          <a:ln w="12700">
-            <a:solidFill>
-              <a:srgbClr val="1A5C2C"/>
-            </a:solidFill>
-            <a:prstDash val="solid"/>
-          </a:ln>
-        </p:spPr>
-        <p:txBody>
-          <a:bodyPr/>
-          <a:lstStyle/>
-          <a:p>
-            <a:endParaRPr lang="en-ZA"/>
-          </a:p>
-        </p:txBody>
-      </p:sp>
-      <p:pic>
-        <p:nvPicPr>
-          <p:cNvPr id="7" name="Image 1" descr="preencoded.png"/>
-          <p:cNvPicPr>
-            <a:picLocks noChangeAspect="1"/>
-          </p:cNvPicPr>
-          <p:nvPr/>
-        </p:nvPicPr>
-        <p:blipFill>
-          <a:blip r:embed="rId6"/>
-          <a:stretch>
-            <a:fillRect/>
-          </a:stretch>
-        </p:blipFill>
-        <p:spPr>
-          <a:xfrm>
-            <a:off x="708660" y="2816352"/>
-            <a:ext cx="320040" cy="320040"/>
-          </a:xfrm>
-          <a:prstGeom prst="rect">
-            <a:avLst/>
-          </a:prstGeom>
-        </p:spPr>
-      </p:pic>
-      <p:sp>
-        <p:nvSpPr>
-          <p:cNvPr id="8" name="Text 4"/>
-          <p:cNvSpPr txBox="1"/>
-          <p:nvPr/>
-        </p:nvSpPr>
-        <p:spPr>
-          <a:xfrm>
-            <a:off x="1508760" y="2487168"/>
-            <a:ext cx="10131552" cy="978408"/>
-          </a:xfrm>
-          <a:prstGeom prst="rect">
-            <a:avLst/>
-          </a:prstGeom>
-          <a:noFill/>
-          <a:ln/>
-        </p:spPr>
-        <p:txBody>
-          <a:bodyPr wrap="square" lIns="0" tIns="0" rIns="0" bIns="0" rtlCol="0" anchor="ctr"/>
-          <a:lstStyle/>
-          <a:p>
-            <a:pPr marL="0" indent="0">
-              <a:buNone/>
-            </a:pPr>
-            <a:r>
-              <a:rPr lang="en-US" sz="2600" b="1" dirty="0">
-                <a:solidFill>
-                  <a:srgbClr val="1A5C2C"/>
-                </a:solidFill>
-                <a:latin typeface="Cambria" pitchFamily="34" charset="0"/>
-                <a:ea typeface="Cambria" pitchFamily="34" charset="-122"/>
-                <a:cs typeface="Cambria" pitchFamily="34" charset="-120"/>
-              </a:rPr>
-              <a:t>A  </a:t>
-            </a:r>
-            <a:r>
-              <a:rPr lang="en-US" sz="2600" dirty="0">
-                <a:solidFill>
-                  <a:srgbClr val="1F2A22"/>
-                </a:solidFill>
-                <a:latin typeface="Calibri" pitchFamily="34" charset="0"/>
-                <a:ea typeface="Calibri" pitchFamily="34" charset="-122"/>
-                <a:cs typeface="Calibri" pitchFamily="34" charset="-120"/>
-              </a:rPr>
-              <a:t>Align Individual Performance</a:t>
-            </a:r>
-            <a:endParaRPr lang="en-US" sz="2600" dirty="0"/>
-          </a:p>
-        </p:txBody>
-      </p:sp>
-      <p:sp>
-        <p:nvSpPr>
-          <p:cNvPr id="9" name="Shape 5"/>
-          <p:cNvSpPr/>
-          <p:nvPr/>
-        </p:nvSpPr>
-        <p:spPr>
-          <a:xfrm>
-            <a:off x="548640" y="3634740"/>
-            <a:ext cx="640080" cy="640080"/>
-          </a:xfrm>
-          <a:prstGeom prst="ellipse">
-            <a:avLst/>
-          </a:prstGeom>
-          <a:solidFill>
-            <a:srgbClr val="1A5C2C"/>
-          </a:solidFill>
-          <a:ln w="12700">
-            <a:solidFill>
-              <a:srgbClr val="1A5C2C"/>
-            </a:solidFill>
-            <a:prstDash val="solid"/>
-          </a:ln>
-        </p:spPr>
-        <p:txBody>
-          <a:bodyPr/>
-          <a:lstStyle/>
-          <a:p>
-            <a:endParaRPr lang="en-ZA"/>
-          </a:p>
-        </p:txBody>
-      </p:sp>
-      <p:pic>
-        <p:nvPicPr>
-          <p:cNvPr id="10" name="Image 2" descr="preencoded.png"/>
-          <p:cNvPicPr>
-            <a:picLocks noChangeAspect="1"/>
-          </p:cNvPicPr>
-          <p:nvPr/>
-        </p:nvPicPr>
-        <p:blipFill>
-          <a:blip r:embed="rId5"/>
-          <a:stretch>
-            <a:fillRect/>
-          </a:stretch>
-        </p:blipFill>
-        <p:spPr>
-          <a:xfrm>
-            <a:off x="708660" y="3794760"/>
-            <a:ext cx="320040" cy="320040"/>
-          </a:xfrm>
-          <a:prstGeom prst="rect">
-            <a:avLst/>
-          </a:prstGeom>
-        </p:spPr>
-      </p:pic>
-      <p:sp>
-        <p:nvSpPr>
-          <p:cNvPr id="11" name="Text 6"/>
-          <p:cNvSpPr txBox="1"/>
-          <p:nvPr/>
-        </p:nvSpPr>
-        <p:spPr>
-          <a:xfrm>
-            <a:off x="1508760" y="3465576"/>
-            <a:ext cx="10131552" cy="978408"/>
-          </a:xfrm>
-          <a:prstGeom prst="rect">
-            <a:avLst/>
-          </a:prstGeom>
-          <a:noFill/>
-          <a:ln/>
-        </p:spPr>
-        <p:txBody>
-          <a:bodyPr wrap="square" lIns="0" tIns="0" rIns="0" bIns="0" rtlCol="0" anchor="ctr"/>
-          <a:lstStyle/>
-          <a:p>
-            <a:pPr marL="0" indent="0">
-              <a:buNone/>
-            </a:pPr>
-            <a:r>
-              <a:rPr lang="en-US" sz="2600" b="1" dirty="0">
-                <a:solidFill>
-                  <a:srgbClr val="1A5C2C"/>
-                </a:solidFill>
-                <a:latin typeface="Cambria" pitchFamily="34" charset="0"/>
-                <a:ea typeface="Cambria" pitchFamily="34" charset="-122"/>
-                <a:cs typeface="Cambria" pitchFamily="34" charset="-120"/>
-              </a:rPr>
-              <a:t>C  </a:t>
-            </a:r>
-            <a:r>
-              <a:rPr lang="en-US" sz="2600" dirty="0">
-                <a:solidFill>
-                  <a:srgbClr val="1F2A22"/>
-                </a:solidFill>
-                <a:latin typeface="Calibri" pitchFamily="34" charset="0"/>
-                <a:ea typeface="Calibri" pitchFamily="34" charset="-122"/>
-                <a:cs typeface="Calibri" pitchFamily="34" charset="-120"/>
-              </a:rPr>
-              <a:t>Create Measurement Transparency</a:t>
-            </a:r>
-            <a:endParaRPr lang="en-US" sz="2600" dirty="0"/>
-          </a:p>
-        </p:txBody>
-      </p:sp>
-      <p:sp>
-        <p:nvSpPr>
-          <p:cNvPr id="12" name="Shape 7"/>
-          <p:cNvSpPr/>
-          <p:nvPr/>
-        </p:nvSpPr>
-        <p:spPr>
-          <a:xfrm>
-            <a:off x="548640" y="4613148"/>
-            <a:ext cx="640080" cy="640080"/>
-          </a:xfrm>
-          <a:prstGeom prst="ellipse">
-            <a:avLst/>
-          </a:prstGeom>
-          <a:solidFill>
-            <a:srgbClr val="1A5C2C"/>
-          </a:solidFill>
-          <a:ln w="12700">
-            <a:solidFill>
-              <a:srgbClr val="1A5C2C"/>
-            </a:solidFill>
-            <a:prstDash val="solid"/>
-          </a:ln>
-        </p:spPr>
-        <p:txBody>
-          <a:bodyPr/>
-          <a:lstStyle/>
-          <a:p>
-            <a:endParaRPr lang="en-ZA"/>
-          </a:p>
-        </p:txBody>
-      </p:sp>
-      <p:pic>
-        <p:nvPicPr>
-          <p:cNvPr id="13" name="Image 3" descr="preencoded.png"/>
-          <p:cNvPicPr>
-            <a:picLocks noChangeAspect="1"/>
-          </p:cNvPicPr>
-          <p:nvPr/>
-        </p:nvPicPr>
-        <p:blipFill>
-          <a:blip r:embed="rId4"/>
-          <a:stretch>
-            <a:fillRect/>
-          </a:stretch>
-        </p:blipFill>
-        <p:spPr>
-          <a:xfrm>
-            <a:off x="708660" y="4773168"/>
-            <a:ext cx="320040" cy="320040"/>
-          </a:xfrm>
-          <a:prstGeom prst="rect">
-            <a:avLst/>
-          </a:prstGeom>
-        </p:spPr>
-      </p:pic>
-      <p:sp>
-        <p:nvSpPr>
-          <p:cNvPr id="14" name="Text 8"/>
-          <p:cNvSpPr txBox="1"/>
-          <p:nvPr/>
-        </p:nvSpPr>
-        <p:spPr>
-          <a:xfrm>
-            <a:off x="1508760" y="4443984"/>
-            <a:ext cx="10131552" cy="978408"/>
-          </a:xfrm>
-          <a:prstGeom prst="rect">
-            <a:avLst/>
-          </a:prstGeom>
-          <a:noFill/>
-          <a:ln/>
-        </p:spPr>
-        <p:txBody>
-          <a:bodyPr wrap="square" lIns="0" tIns="0" rIns="0" bIns="0" rtlCol="0" anchor="ctr"/>
-          <a:lstStyle/>
-          <a:p>
-            <a:pPr marL="0" indent="0">
-              <a:buNone/>
-            </a:pPr>
-            <a:r>
-              <a:rPr lang="en-US" sz="2600" b="1" dirty="0">
-                <a:solidFill>
-                  <a:srgbClr val="1A5C2C"/>
-                </a:solidFill>
-                <a:latin typeface="Cambria" pitchFamily="34" charset="0"/>
-                <a:ea typeface="Cambria" pitchFamily="34" charset="-122"/>
-                <a:cs typeface="Cambria" pitchFamily="34" charset="-120"/>
-              </a:rPr>
-              <a:t>E  </a:t>
-            </a:r>
-            <a:r>
-              <a:rPr lang="en-US" sz="2600" dirty="0">
-                <a:solidFill>
-                  <a:srgbClr val="1F2A22"/>
-                </a:solidFill>
-                <a:latin typeface="Calibri" pitchFamily="34" charset="0"/>
-                <a:ea typeface="Calibri" pitchFamily="34" charset="-122"/>
-                <a:cs typeface="Calibri" pitchFamily="34" charset="-120"/>
-              </a:rPr>
-              <a:t>Embed Shared Accountability</a:t>
-            </a:r>
-            <a:endParaRPr lang="en-US" sz="2600" dirty="0"/>
-          </a:p>
-        </p:txBody>
-      </p:sp>
-      <p:sp>
-        <p:nvSpPr>
-          <p:cNvPr id="15" name="Shape 9"/>
-          <p:cNvSpPr/>
-          <p:nvPr/>
-        </p:nvSpPr>
-        <p:spPr>
-          <a:xfrm>
-            <a:off x="548640" y="5591556"/>
-            <a:ext cx="640080" cy="640080"/>
-          </a:xfrm>
-          <a:prstGeom prst="ellipse">
-            <a:avLst/>
-          </a:prstGeom>
-          <a:solidFill>
-            <a:srgbClr val="1A5C2C"/>
-          </a:solidFill>
-          <a:ln w="12700">
-            <a:solidFill>
-              <a:srgbClr val="1A5C2C"/>
-            </a:solidFill>
-            <a:prstDash val="solid"/>
-          </a:ln>
-        </p:spPr>
-        <p:txBody>
-          <a:bodyPr/>
-          <a:lstStyle/>
-          <a:p>
-            <a:endParaRPr lang="en-ZA"/>
-          </a:p>
-        </p:txBody>
-      </p:sp>
-      <p:pic>
-        <p:nvPicPr>
-          <p:cNvPr id="16" name="Image 4" descr="preencoded.png"/>
-          <p:cNvPicPr>
-            <a:picLocks noChangeAspect="1"/>
-          </p:cNvPicPr>
-          <p:nvPr/>
-        </p:nvPicPr>
-        <p:blipFill>
-          <a:blip r:embed="rId3"/>
-          <a:stretch>
-            <a:fillRect/>
-          </a:stretch>
-        </p:blipFill>
-        <p:spPr>
-          <a:xfrm>
-            <a:off x="708660" y="5751576"/>
-            <a:ext cx="320040" cy="320040"/>
-          </a:xfrm>
-          <a:prstGeom prst="rect">
-            <a:avLst/>
-          </a:prstGeom>
-        </p:spPr>
-      </p:pic>
-      <p:sp>
-        <p:nvSpPr>
-          <p:cNvPr id="17" name="Text 10"/>
-          <p:cNvSpPr txBox="1"/>
-          <p:nvPr/>
-        </p:nvSpPr>
-        <p:spPr>
-          <a:xfrm>
-            <a:off x="1508760" y="5422392"/>
-            <a:ext cx="10131552" cy="978408"/>
-          </a:xfrm>
-          <a:prstGeom prst="rect">
-            <a:avLst/>
-          </a:prstGeom>
-          <a:noFill/>
-          <a:ln/>
-        </p:spPr>
-        <p:txBody>
-          <a:bodyPr wrap="square" lIns="0" tIns="0" rIns="0" bIns="0" rtlCol="0" anchor="ctr"/>
-          <a:lstStyle/>
-          <a:p>
-            <a:pPr marL="0" indent="0">
-              <a:buNone/>
-            </a:pPr>
-            <a:r>
-              <a:rPr lang="en-US" sz="2600" b="1" dirty="0">
-                <a:solidFill>
-                  <a:srgbClr val="1A5C2C"/>
-                </a:solidFill>
-                <a:latin typeface="Cambria" pitchFamily="34" charset="0"/>
-                <a:ea typeface="Cambria" pitchFamily="34" charset="-122"/>
-                <a:cs typeface="Cambria" pitchFamily="34" charset="-120"/>
-              </a:rPr>
-              <a:t>S  </a:t>
-            </a:r>
-            <a:r>
-              <a:rPr lang="en-US" sz="2600" dirty="0">
-                <a:solidFill>
-                  <a:srgbClr val="1F2A22"/>
-                </a:solidFill>
-                <a:latin typeface="Calibri" pitchFamily="34" charset="0"/>
-                <a:ea typeface="Calibri" pitchFamily="34" charset="-122"/>
-                <a:cs typeface="Calibri" pitchFamily="34" charset="-120"/>
-              </a:rPr>
-              <a:t>Support Continuous Development</a:t>
-            </a:r>
-            <a:endParaRPr lang="en-US" sz="2600" dirty="0"/>
-          </a:p>
-        </p:txBody>
-      </p:sp>
-    </p:spTree>
-  </p:cSld>
-  <p:clrMapOvr>
-    <a:masterClrMapping/>
-  </p:clrMapOvr>
-</p:sld>
-</file>
-
-<file path=ppt/slides/slide29.xml><?xml version="1.0" encoding="utf-8"?>
-<p:sld xmlns:a="http://schemas.openxmlformats.org/drawingml/2006/main" xmlns:p="http://schemas.openxmlformats.org/presentationml/2006/main" xmlns:r="http://schemas.openxmlformats.org/officeDocument/2006/relationships">
-  <p:cSld>
-    <p:bg>
-      <p:bgPr>
-        <a:solidFill>
-          <a:srgbClr val="FFFFFF"/>
-        </a:solidFill>
-        <a:effectLst/>
-      </p:bgPr>
-    </p:bg>
-    <p:spTree>
-      <p:nvGrpSpPr>
-        <p:cNvPr id="1" name=""/>
-        <p:cNvGrpSpPr/>
-        <p:nvPr/>
-      </p:nvGrpSpPr>
-      <p:grpSpPr/>
-      <p:sp>
-        <p:nvSpPr>
-          <p:cNvPr id="2" name="Text 0"/>
-          <p:cNvSpPr txBox="1"/>
-          <p:nvPr/>
-        </p:nvSpPr>
-        <p:spPr>
-          <a:xfrm>
-            <a:off x="548640" y="411480"/>
-            <a:ext cx="11064240" cy="868680"/>
-          </a:xfrm>
-          <a:prstGeom prst="rect">
-            <a:avLst/>
-          </a:prstGeom>
-          <a:noFill/>
-          <a:ln/>
-        </p:spPr>
-        <p:txBody>
-          <a:bodyPr wrap="square" lIns="0" tIns="0" rIns="0" bIns="0" rtlCol="0" anchor="ctr"/>
-          <a:lstStyle/>
-          <a:p>
-            <a:pPr marL="0" indent="0">
-              <a:buNone/>
-            </a:pPr>
-            <a:r>
-              <a:rPr lang="en-US" sz="3600" b="1" dirty="0">
-                <a:solidFill>
-                  <a:srgbClr val="1A5C2C"/>
-                </a:solidFill>
-                <a:latin typeface="Cambria" pitchFamily="34" charset="0"/>
-                <a:ea typeface="Cambria" pitchFamily="34" charset="-122"/>
-                <a:cs typeface="Cambria" pitchFamily="34" charset="-120"/>
-              </a:rPr>
-              <a:t>Step 3 · EXECUTION</a:t>
-            </a:r>
-            <a:endParaRPr lang="en-US" sz="3600" dirty="0"/>
-          </a:p>
-        </p:txBody>
-      </p:sp>
-      <p:sp>
-        <p:nvSpPr>
-          <p:cNvPr id="3" name="Shape 1"/>
-          <p:cNvSpPr/>
-          <p:nvPr/>
-        </p:nvSpPr>
-        <p:spPr>
-          <a:xfrm>
-            <a:off x="548640" y="1590294"/>
-            <a:ext cx="380492" cy="380492"/>
-          </a:xfrm>
-          <a:prstGeom prst="ellipse">
-            <a:avLst/>
-          </a:prstGeom>
-          <a:solidFill>
-            <a:srgbClr val="1A5C2C"/>
-          </a:solidFill>
-          <a:ln w="12700">
-            <a:solidFill>
-              <a:srgbClr val="1A5C2C"/>
-            </a:solidFill>
-            <a:prstDash val="solid"/>
-          </a:ln>
-        </p:spPr>
-        <p:txBody>
-          <a:bodyPr/>
-          <a:lstStyle/>
-          <a:p>
-            <a:endParaRPr lang="en-ZA"/>
-          </a:p>
-        </p:txBody>
-      </p:sp>
-      <p:pic>
-        <p:nvPicPr>
-          <p:cNvPr id="4" name="Image 0" descr="preencoded.png"/>
-          <p:cNvPicPr>
-            <a:picLocks noChangeAspect="1"/>
-          </p:cNvPicPr>
-          <p:nvPr/>
-        </p:nvPicPr>
-        <p:blipFill>
-          <a:blip r:embed="rId2"/>
-          <a:stretch>
-            <a:fillRect/>
-          </a:stretch>
-        </p:blipFill>
-        <p:spPr>
-          <a:xfrm>
-            <a:off x="643763" y="1685417"/>
-            <a:ext cx="190246" cy="190246"/>
-          </a:xfrm>
-          <a:prstGeom prst="rect">
-            <a:avLst/>
-          </a:prstGeom>
-        </p:spPr>
-      </p:pic>
-      <p:sp>
-        <p:nvSpPr>
-          <p:cNvPr id="5" name="Text 2"/>
-          <p:cNvSpPr txBox="1"/>
-          <p:nvPr/>
-        </p:nvSpPr>
-        <p:spPr>
-          <a:xfrm>
-            <a:off x="1249172" y="1508760"/>
-            <a:ext cx="10391140" cy="543560"/>
-          </a:xfrm>
-          <a:prstGeom prst="rect">
-            <a:avLst/>
-          </a:prstGeom>
-          <a:noFill/>
-          <a:ln/>
-        </p:spPr>
-        <p:txBody>
-          <a:bodyPr wrap="square" lIns="0" tIns="0" rIns="0" bIns="0" rtlCol="0" anchor="ctr"/>
-          <a:lstStyle/>
-          <a:p>
-            <a:pPr marL="0" indent="0">
-              <a:buNone/>
-            </a:pPr>
-            <a:r>
-              <a:rPr lang="en-US" sz="2400" b="1" dirty="0">
-                <a:solidFill>
-                  <a:srgbClr val="1A5C2C"/>
-                </a:solidFill>
-                <a:latin typeface="Cambria" pitchFamily="34" charset="0"/>
-                <a:ea typeface="Cambria" pitchFamily="34" charset="-122"/>
-                <a:cs typeface="Cambria" pitchFamily="34" charset="-120"/>
-              </a:rPr>
-              <a:t>E  </a:t>
-            </a:r>
-            <a:r>
-              <a:rPr lang="en-US" sz="2400" dirty="0">
-                <a:solidFill>
-                  <a:srgbClr val="1F2A22"/>
-                </a:solidFill>
-                <a:latin typeface="Calibri" pitchFamily="34" charset="0"/>
-                <a:ea typeface="Calibri" pitchFamily="34" charset="-122"/>
-                <a:cs typeface="Calibri" pitchFamily="34" charset="-120"/>
-              </a:rPr>
-              <a:t>Enterprise: Strategy First</a:t>
-            </a:r>
-            <a:endParaRPr lang="en-US" sz="2400" dirty="0"/>
-          </a:p>
-        </p:txBody>
-      </p:sp>
-      <p:sp>
-        <p:nvSpPr>
-          <p:cNvPr id="6" name="Shape 3"/>
-          <p:cNvSpPr/>
-          <p:nvPr/>
-        </p:nvSpPr>
-        <p:spPr>
-          <a:xfrm>
-            <a:off x="548640" y="2133854"/>
-            <a:ext cx="380492" cy="380492"/>
-          </a:xfrm>
-          <a:prstGeom prst="ellipse">
-            <a:avLst/>
-          </a:prstGeom>
-          <a:solidFill>
-            <a:srgbClr val="1A5C2C"/>
-          </a:solidFill>
-          <a:ln w="12700">
-            <a:solidFill>
-              <a:srgbClr val="1A5C2C"/>
-            </a:solidFill>
-            <a:prstDash val="solid"/>
-          </a:ln>
-        </p:spPr>
-        <p:txBody>
-          <a:bodyPr/>
-          <a:lstStyle/>
-          <a:p>
-            <a:endParaRPr lang="en-ZA"/>
-          </a:p>
-        </p:txBody>
-      </p:sp>
-      <p:pic>
-        <p:nvPicPr>
-          <p:cNvPr id="7" name="Image 1" descr="preencoded.png"/>
-          <p:cNvPicPr>
-            <a:picLocks noChangeAspect="1"/>
-          </p:cNvPicPr>
-          <p:nvPr/>
-        </p:nvPicPr>
-        <p:blipFill>
-          <a:blip r:embed="rId2"/>
-          <a:stretch>
-            <a:fillRect/>
-          </a:stretch>
-        </p:blipFill>
-        <p:spPr>
-          <a:xfrm>
-            <a:off x="643763" y="2228977"/>
-            <a:ext cx="190246" cy="190246"/>
-          </a:xfrm>
-          <a:prstGeom prst="rect">
-            <a:avLst/>
-          </a:prstGeom>
-        </p:spPr>
-      </p:pic>
-      <p:sp>
-        <p:nvSpPr>
-          <p:cNvPr id="8" name="Text 4"/>
-          <p:cNvSpPr txBox="1"/>
-          <p:nvPr/>
-        </p:nvSpPr>
-        <p:spPr>
-          <a:xfrm>
-            <a:off x="1249172" y="2052320"/>
-            <a:ext cx="10391140" cy="543560"/>
-          </a:xfrm>
-          <a:prstGeom prst="rect">
-            <a:avLst/>
-          </a:prstGeom>
-          <a:noFill/>
-          <a:ln/>
-        </p:spPr>
-        <p:txBody>
-          <a:bodyPr wrap="square" lIns="0" tIns="0" rIns="0" bIns="0" rtlCol="0" anchor="ctr"/>
-          <a:lstStyle/>
-          <a:p>
-            <a:pPr marL="0" indent="0">
-              <a:buNone/>
-            </a:pPr>
-            <a:r>
-              <a:rPr lang="en-US" sz="2400" b="1" dirty="0">
-                <a:solidFill>
-                  <a:srgbClr val="1A5C2C"/>
-                </a:solidFill>
-                <a:latin typeface="Cambria" pitchFamily="34" charset="0"/>
-                <a:ea typeface="Cambria" pitchFamily="34" charset="-122"/>
-                <a:cs typeface="Cambria" pitchFamily="34" charset="-120"/>
-              </a:rPr>
-              <a:t>X  </a:t>
-            </a:r>
-            <a:r>
-              <a:rPr lang="en-US" sz="2400" dirty="0">
-                <a:solidFill>
-                  <a:srgbClr val="1F2A22"/>
-                </a:solidFill>
-                <a:latin typeface="Calibri" pitchFamily="34" charset="0"/>
-                <a:ea typeface="Calibri" pitchFamily="34" charset="-122"/>
-                <a:cs typeface="Calibri" pitchFamily="34" charset="-120"/>
-              </a:rPr>
-              <a:t>eXecution: Line-of-Sight</a:t>
-            </a:r>
-            <a:endParaRPr lang="en-US" sz="2400" dirty="0"/>
-          </a:p>
-        </p:txBody>
-      </p:sp>
-      <p:sp>
-        <p:nvSpPr>
-          <p:cNvPr id="9" name="Shape 5"/>
-          <p:cNvSpPr/>
-          <p:nvPr/>
-        </p:nvSpPr>
-        <p:spPr>
-          <a:xfrm>
-            <a:off x="548640" y="2677414"/>
-            <a:ext cx="380492" cy="380492"/>
-          </a:xfrm>
-          <a:prstGeom prst="ellipse">
-            <a:avLst/>
-          </a:prstGeom>
-          <a:solidFill>
-            <a:srgbClr val="1A5C2C"/>
-          </a:solidFill>
-          <a:ln w="12700">
-            <a:solidFill>
-              <a:srgbClr val="1A5C2C"/>
-            </a:solidFill>
-            <a:prstDash val="solid"/>
-          </a:ln>
-        </p:spPr>
-        <p:txBody>
-          <a:bodyPr/>
-          <a:lstStyle/>
-          <a:p>
-            <a:endParaRPr lang="en-ZA"/>
-          </a:p>
-        </p:txBody>
-      </p:sp>
-      <p:pic>
-        <p:nvPicPr>
-          <p:cNvPr id="10" name="Image 2" descr="preencoded.png"/>
-          <p:cNvPicPr>
-            <a:picLocks noChangeAspect="1"/>
-          </p:cNvPicPr>
-          <p:nvPr/>
-        </p:nvPicPr>
-        <p:blipFill>
-          <a:blip r:embed="rId2"/>
-          <a:stretch>
-            <a:fillRect/>
-          </a:stretch>
-        </p:blipFill>
-        <p:spPr>
-          <a:xfrm>
-            <a:off x="643763" y="2772537"/>
-            <a:ext cx="190246" cy="190246"/>
-          </a:xfrm>
-          <a:prstGeom prst="rect">
-            <a:avLst/>
-          </a:prstGeom>
-        </p:spPr>
-      </p:pic>
-      <p:sp>
-        <p:nvSpPr>
-          <p:cNvPr id="11" name="Text 6"/>
-          <p:cNvSpPr txBox="1"/>
-          <p:nvPr/>
-        </p:nvSpPr>
-        <p:spPr>
-          <a:xfrm>
-            <a:off x="1249172" y="2595880"/>
-            <a:ext cx="10391140" cy="543560"/>
-          </a:xfrm>
-          <a:prstGeom prst="rect">
-            <a:avLst/>
-          </a:prstGeom>
-          <a:noFill/>
-          <a:ln/>
-        </p:spPr>
-        <p:txBody>
-          <a:bodyPr wrap="square" lIns="0" tIns="0" rIns="0" bIns="0" rtlCol="0" anchor="ctr"/>
-          <a:lstStyle/>
-          <a:p>
-            <a:pPr marL="0" indent="0">
-              <a:buNone/>
-            </a:pPr>
-            <a:r>
-              <a:rPr lang="en-US" sz="2400" b="1" dirty="0">
-                <a:solidFill>
-                  <a:srgbClr val="1A5C2C"/>
-                </a:solidFill>
-                <a:latin typeface="Cambria" pitchFamily="34" charset="0"/>
-                <a:ea typeface="Cambria" pitchFamily="34" charset="-122"/>
-                <a:cs typeface="Cambria" pitchFamily="34" charset="-120"/>
-              </a:rPr>
-              <a:t>E  </a:t>
-            </a:r>
-            <a:r>
-              <a:rPr lang="en-US" sz="2400" dirty="0">
-                <a:solidFill>
-                  <a:srgbClr val="1F2A22"/>
-                </a:solidFill>
-                <a:latin typeface="Calibri" pitchFamily="34" charset="0"/>
-                <a:ea typeface="Calibri" pitchFamily="34" charset="-122"/>
-                <a:cs typeface="Calibri" pitchFamily="34" charset="-120"/>
-              </a:rPr>
-              <a:t>Evidence: Evidence-Based Measurement</a:t>
-            </a:r>
-            <a:endParaRPr lang="en-US" sz="2400" dirty="0"/>
-          </a:p>
-        </p:txBody>
-      </p:sp>
-      <p:sp>
-        <p:nvSpPr>
-          <p:cNvPr id="12" name="Shape 7"/>
-          <p:cNvSpPr/>
-          <p:nvPr/>
-        </p:nvSpPr>
-        <p:spPr>
-          <a:xfrm>
-            <a:off x="548640" y="3220974"/>
-            <a:ext cx="380492" cy="380492"/>
-          </a:xfrm>
-          <a:prstGeom prst="ellipse">
-            <a:avLst/>
-          </a:prstGeom>
-          <a:solidFill>
-            <a:srgbClr val="1A5C2C"/>
-          </a:solidFill>
-          <a:ln w="12700">
-            <a:solidFill>
-              <a:srgbClr val="1A5C2C"/>
-            </a:solidFill>
-            <a:prstDash val="solid"/>
-          </a:ln>
-        </p:spPr>
-        <p:txBody>
-          <a:bodyPr/>
-          <a:lstStyle/>
-          <a:p>
-            <a:endParaRPr lang="en-ZA"/>
-          </a:p>
-        </p:txBody>
-      </p:sp>
-      <p:pic>
-        <p:nvPicPr>
-          <p:cNvPr id="13" name="Image 3" descr="preencoded.png"/>
-          <p:cNvPicPr>
-            <a:picLocks noChangeAspect="1"/>
-          </p:cNvPicPr>
-          <p:nvPr/>
-        </p:nvPicPr>
-        <p:blipFill>
-          <a:blip r:embed="rId2"/>
-          <a:stretch>
-            <a:fillRect/>
-          </a:stretch>
-        </p:blipFill>
-        <p:spPr>
-          <a:xfrm>
-            <a:off x="643763" y="3316097"/>
-            <a:ext cx="190246" cy="190246"/>
-          </a:xfrm>
-          <a:prstGeom prst="rect">
-            <a:avLst/>
-          </a:prstGeom>
-        </p:spPr>
-      </p:pic>
-      <p:sp>
-        <p:nvSpPr>
-          <p:cNvPr id="14" name="Text 8"/>
-          <p:cNvSpPr txBox="1"/>
-          <p:nvPr/>
-        </p:nvSpPr>
-        <p:spPr>
-          <a:xfrm>
-            <a:off x="1249172" y="3139440"/>
-            <a:ext cx="10391140" cy="543560"/>
-          </a:xfrm>
-          <a:prstGeom prst="rect">
-            <a:avLst/>
-          </a:prstGeom>
-          <a:noFill/>
-          <a:ln/>
-        </p:spPr>
-        <p:txBody>
-          <a:bodyPr wrap="square" lIns="0" tIns="0" rIns="0" bIns="0" rtlCol="0" anchor="ctr"/>
-          <a:lstStyle/>
-          <a:p>
-            <a:pPr marL="0" indent="0">
-              <a:buNone/>
-            </a:pPr>
-            <a:r>
-              <a:rPr lang="en-US" sz="2400" b="1" dirty="0">
-                <a:solidFill>
-                  <a:srgbClr val="1A5C2C"/>
-                </a:solidFill>
-                <a:latin typeface="Cambria" pitchFamily="34" charset="0"/>
-                <a:ea typeface="Cambria" pitchFamily="34" charset="-122"/>
-                <a:cs typeface="Cambria" pitchFamily="34" charset="-120"/>
-              </a:rPr>
-              <a:t>C  </a:t>
-            </a:r>
-            <a:r>
-              <a:rPr lang="en-US" sz="2400" dirty="0">
-                <a:solidFill>
-                  <a:srgbClr val="1F2A22"/>
-                </a:solidFill>
-                <a:latin typeface="Calibri" pitchFamily="34" charset="0"/>
-                <a:ea typeface="Calibri" pitchFamily="34" charset="-122"/>
-                <a:cs typeface="Calibri" pitchFamily="34" charset="-120"/>
-              </a:rPr>
-              <a:t>Collective: Collective Ownership</a:t>
-            </a:r>
-            <a:endParaRPr lang="en-US" sz="2400" dirty="0"/>
-          </a:p>
-        </p:txBody>
-      </p:sp>
-      <p:sp>
-        <p:nvSpPr>
-          <p:cNvPr id="15" name="Shape 9"/>
-          <p:cNvSpPr/>
-          <p:nvPr/>
-        </p:nvSpPr>
-        <p:spPr>
-          <a:xfrm>
-            <a:off x="548640" y="3764534"/>
-            <a:ext cx="380492" cy="380492"/>
-          </a:xfrm>
-          <a:prstGeom prst="ellipse">
-            <a:avLst/>
-          </a:prstGeom>
-          <a:solidFill>
-            <a:srgbClr val="1A5C2C"/>
-          </a:solidFill>
-          <a:ln w="12700">
-            <a:solidFill>
-              <a:srgbClr val="1A5C2C"/>
-            </a:solidFill>
-            <a:prstDash val="solid"/>
-          </a:ln>
-        </p:spPr>
-        <p:txBody>
-          <a:bodyPr/>
-          <a:lstStyle/>
-          <a:p>
-            <a:endParaRPr lang="en-ZA"/>
-          </a:p>
-        </p:txBody>
-      </p:sp>
-      <p:pic>
-        <p:nvPicPr>
-          <p:cNvPr id="16" name="Image 4" descr="preencoded.png"/>
-          <p:cNvPicPr>
-            <a:picLocks noChangeAspect="1"/>
-          </p:cNvPicPr>
-          <p:nvPr/>
-        </p:nvPicPr>
-        <p:blipFill>
-          <a:blip r:embed="rId2"/>
-          <a:stretch>
-            <a:fillRect/>
-          </a:stretch>
-        </p:blipFill>
-        <p:spPr>
-          <a:xfrm>
-            <a:off x="643763" y="3859657"/>
-            <a:ext cx="190246" cy="190246"/>
-          </a:xfrm>
-          <a:prstGeom prst="rect">
-            <a:avLst/>
-          </a:prstGeom>
-        </p:spPr>
-      </p:pic>
-      <p:sp>
-        <p:nvSpPr>
-          <p:cNvPr id="17" name="Text 10"/>
-          <p:cNvSpPr txBox="1"/>
-          <p:nvPr/>
-        </p:nvSpPr>
-        <p:spPr>
-          <a:xfrm>
-            <a:off x="1249172" y="3683000"/>
-            <a:ext cx="10391140" cy="543560"/>
-          </a:xfrm>
-          <a:prstGeom prst="rect">
-            <a:avLst/>
-          </a:prstGeom>
-          <a:noFill/>
-          <a:ln/>
-        </p:spPr>
-        <p:txBody>
-          <a:bodyPr wrap="square" lIns="0" tIns="0" rIns="0" bIns="0" rtlCol="0" anchor="ctr"/>
-          <a:lstStyle/>
-          <a:p>
-            <a:pPr marL="0" indent="0">
-              <a:buNone/>
-            </a:pPr>
-            <a:r>
-              <a:rPr lang="en-US" sz="2400" b="1" dirty="0">
-                <a:solidFill>
-                  <a:srgbClr val="1A5C2C"/>
-                </a:solidFill>
-                <a:latin typeface="Cambria" pitchFamily="34" charset="0"/>
-                <a:ea typeface="Cambria" pitchFamily="34" charset="-122"/>
-                <a:cs typeface="Cambria" pitchFamily="34" charset="-120"/>
-              </a:rPr>
-              <a:t>U  </a:t>
-            </a:r>
-            <a:r>
-              <a:rPr lang="en-US" sz="2400" dirty="0">
-                <a:solidFill>
-                  <a:srgbClr val="1F2A22"/>
-                </a:solidFill>
-                <a:latin typeface="Calibri" pitchFamily="34" charset="0"/>
-                <a:ea typeface="Calibri" pitchFamily="34" charset="-122"/>
-                <a:cs typeface="Calibri" pitchFamily="34" charset="-120"/>
-              </a:rPr>
-              <a:t>Understand: Outcomes First</a:t>
-            </a:r>
-            <a:endParaRPr lang="en-US" sz="2400" dirty="0"/>
-          </a:p>
-        </p:txBody>
-      </p:sp>
-      <p:sp>
-        <p:nvSpPr>
-          <p:cNvPr id="18" name="Shape 11"/>
-          <p:cNvSpPr/>
-          <p:nvPr/>
-        </p:nvSpPr>
-        <p:spPr>
-          <a:xfrm>
-            <a:off x="548640" y="4308094"/>
-            <a:ext cx="380492" cy="380492"/>
-          </a:xfrm>
-          <a:prstGeom prst="ellipse">
-            <a:avLst/>
-          </a:prstGeom>
-          <a:solidFill>
-            <a:srgbClr val="1A5C2C"/>
-          </a:solidFill>
-          <a:ln w="12700">
-            <a:solidFill>
-              <a:srgbClr val="1A5C2C"/>
-            </a:solidFill>
-            <a:prstDash val="solid"/>
-          </a:ln>
-        </p:spPr>
-        <p:txBody>
-          <a:bodyPr/>
-          <a:lstStyle/>
-          <a:p>
-            <a:endParaRPr lang="en-ZA"/>
-          </a:p>
-        </p:txBody>
-      </p:sp>
-      <p:pic>
-        <p:nvPicPr>
-          <p:cNvPr id="19" name="Image 5" descr="preencoded.png"/>
-          <p:cNvPicPr>
-            <a:picLocks noChangeAspect="1"/>
-          </p:cNvPicPr>
-          <p:nvPr/>
-        </p:nvPicPr>
-        <p:blipFill>
-          <a:blip r:embed="rId2"/>
-          <a:stretch>
-            <a:fillRect/>
-          </a:stretch>
-        </p:blipFill>
-        <p:spPr>
-          <a:xfrm>
-            <a:off x="643763" y="4403217"/>
-            <a:ext cx="190246" cy="190246"/>
-          </a:xfrm>
-          <a:prstGeom prst="rect">
-            <a:avLst/>
-          </a:prstGeom>
-        </p:spPr>
-      </p:pic>
-      <p:sp>
-        <p:nvSpPr>
-          <p:cNvPr id="20" name="Text 12"/>
-          <p:cNvSpPr txBox="1"/>
-          <p:nvPr/>
-        </p:nvSpPr>
-        <p:spPr>
-          <a:xfrm>
-            <a:off x="1249172" y="4226560"/>
-            <a:ext cx="10391140" cy="543560"/>
-          </a:xfrm>
-          <a:prstGeom prst="rect">
-            <a:avLst/>
-          </a:prstGeom>
-          <a:noFill/>
-          <a:ln/>
-        </p:spPr>
-        <p:txBody>
-          <a:bodyPr wrap="square" lIns="0" tIns="0" rIns="0" bIns="0" rtlCol="0" anchor="ctr"/>
-          <a:lstStyle/>
-          <a:p>
-            <a:pPr marL="0" indent="0">
-              <a:buNone/>
-            </a:pPr>
-            <a:r>
-              <a:rPr lang="en-US" sz="2400" b="1" dirty="0">
-                <a:solidFill>
-                  <a:srgbClr val="1A5C2C"/>
-                </a:solidFill>
-                <a:latin typeface="Cambria" pitchFamily="34" charset="0"/>
-                <a:ea typeface="Cambria" pitchFamily="34" charset="-122"/>
-                <a:cs typeface="Cambria" pitchFamily="34" charset="-120"/>
-              </a:rPr>
-              <a:t>T  </a:t>
-            </a:r>
-            <a:r>
-              <a:rPr lang="en-US" sz="2400" dirty="0">
-                <a:solidFill>
-                  <a:srgbClr val="1F2A22"/>
-                </a:solidFill>
-                <a:latin typeface="Calibri" pitchFamily="34" charset="0"/>
-                <a:ea typeface="Calibri" pitchFamily="34" charset="-122"/>
-                <a:cs typeface="Calibri" pitchFamily="34" charset="-120"/>
-              </a:rPr>
-              <a:t>Transparent: Measurement Logic</a:t>
-            </a:r>
-            <a:endParaRPr lang="en-US" sz="2400" dirty="0"/>
-          </a:p>
-        </p:txBody>
-      </p:sp>
-      <p:sp>
-        <p:nvSpPr>
-          <p:cNvPr id="21" name="Shape 13"/>
-          <p:cNvSpPr/>
-          <p:nvPr/>
-        </p:nvSpPr>
-        <p:spPr>
-          <a:xfrm>
-            <a:off x="548640" y="4851654"/>
-            <a:ext cx="380492" cy="380492"/>
-          </a:xfrm>
-          <a:prstGeom prst="ellipse">
-            <a:avLst/>
-          </a:prstGeom>
-          <a:solidFill>
-            <a:srgbClr val="1A5C2C"/>
-          </a:solidFill>
-          <a:ln w="12700">
-            <a:solidFill>
-              <a:srgbClr val="1A5C2C"/>
-            </a:solidFill>
-            <a:prstDash val="solid"/>
-          </a:ln>
-        </p:spPr>
-        <p:txBody>
-          <a:bodyPr/>
-          <a:lstStyle/>
-          <a:p>
-            <a:endParaRPr lang="en-ZA"/>
-          </a:p>
-        </p:txBody>
-      </p:sp>
-      <p:pic>
-        <p:nvPicPr>
-          <p:cNvPr id="22" name="Image 6" descr="preencoded.png"/>
-          <p:cNvPicPr>
-            <a:picLocks noChangeAspect="1"/>
-          </p:cNvPicPr>
-          <p:nvPr/>
-        </p:nvPicPr>
-        <p:blipFill>
-          <a:blip r:embed="rId2"/>
-          <a:stretch>
-            <a:fillRect/>
-          </a:stretch>
-        </p:blipFill>
-        <p:spPr>
-          <a:xfrm>
-            <a:off x="643763" y="4946777"/>
-            <a:ext cx="190246" cy="190246"/>
-          </a:xfrm>
-          <a:prstGeom prst="rect">
-            <a:avLst/>
-          </a:prstGeom>
-        </p:spPr>
-      </p:pic>
-      <p:sp>
-        <p:nvSpPr>
-          <p:cNvPr id="23" name="Text 14"/>
-          <p:cNvSpPr txBox="1"/>
-          <p:nvPr/>
-        </p:nvSpPr>
-        <p:spPr>
-          <a:xfrm>
-            <a:off x="1249172" y="4770120"/>
-            <a:ext cx="10391140" cy="543560"/>
-          </a:xfrm>
-          <a:prstGeom prst="rect">
-            <a:avLst/>
-          </a:prstGeom>
-          <a:noFill/>
-          <a:ln/>
-        </p:spPr>
-        <p:txBody>
-          <a:bodyPr wrap="square" lIns="0" tIns="0" rIns="0" bIns="0" rtlCol="0" anchor="ctr"/>
-          <a:lstStyle/>
-          <a:p>
-            <a:pPr marL="0" indent="0">
-              <a:buNone/>
-            </a:pPr>
-            <a:r>
-              <a:rPr lang="en-US" sz="2400" b="1" dirty="0">
-                <a:solidFill>
-                  <a:srgbClr val="1A5C2C"/>
-                </a:solidFill>
-                <a:latin typeface="Cambria" pitchFamily="34" charset="0"/>
-                <a:ea typeface="Cambria" pitchFamily="34" charset="-122"/>
-                <a:cs typeface="Cambria" pitchFamily="34" charset="-120"/>
-              </a:rPr>
-              <a:t>I  </a:t>
-            </a:r>
-            <a:r>
-              <a:rPr lang="en-US" sz="2400" dirty="0">
-                <a:solidFill>
-                  <a:srgbClr val="1F2A22"/>
-                </a:solidFill>
-                <a:latin typeface="Calibri" pitchFamily="34" charset="0"/>
-                <a:ea typeface="Calibri" pitchFamily="34" charset="-122"/>
-                <a:cs typeface="Calibri" pitchFamily="34" charset="-120"/>
-              </a:rPr>
-              <a:t>Incentive: Incentive Alignment</a:t>
-            </a:r>
-            <a:endParaRPr lang="en-US" sz="2400" dirty="0"/>
-          </a:p>
-        </p:txBody>
-      </p:sp>
-      <p:sp>
-        <p:nvSpPr>
-          <p:cNvPr id="24" name="Shape 15"/>
-          <p:cNvSpPr/>
-          <p:nvPr/>
-        </p:nvSpPr>
-        <p:spPr>
-          <a:xfrm>
-            <a:off x="548640" y="5395214"/>
-            <a:ext cx="380492" cy="380492"/>
-          </a:xfrm>
-          <a:prstGeom prst="ellipse">
-            <a:avLst/>
-          </a:prstGeom>
-          <a:solidFill>
-            <a:srgbClr val="1A5C2C"/>
-          </a:solidFill>
-          <a:ln w="12700">
-            <a:solidFill>
-              <a:srgbClr val="1A5C2C"/>
-            </a:solidFill>
-            <a:prstDash val="solid"/>
-          </a:ln>
-        </p:spPr>
-        <p:txBody>
-          <a:bodyPr/>
-          <a:lstStyle/>
-          <a:p>
-            <a:endParaRPr lang="en-ZA"/>
-          </a:p>
-        </p:txBody>
-      </p:sp>
-      <p:pic>
-        <p:nvPicPr>
-          <p:cNvPr id="25" name="Image 7" descr="preencoded.png"/>
-          <p:cNvPicPr>
-            <a:picLocks noChangeAspect="1"/>
-          </p:cNvPicPr>
-          <p:nvPr/>
-        </p:nvPicPr>
-        <p:blipFill>
-          <a:blip r:embed="rId2"/>
-          <a:stretch>
-            <a:fillRect/>
-          </a:stretch>
-        </p:blipFill>
-        <p:spPr>
-          <a:xfrm>
-            <a:off x="643763" y="5490337"/>
-            <a:ext cx="190246" cy="190246"/>
-          </a:xfrm>
-          <a:prstGeom prst="rect">
-            <a:avLst/>
-          </a:prstGeom>
-        </p:spPr>
-      </p:pic>
-      <p:sp>
-        <p:nvSpPr>
-          <p:cNvPr id="26" name="Text 16"/>
-          <p:cNvSpPr txBox="1"/>
-          <p:nvPr/>
-        </p:nvSpPr>
-        <p:spPr>
-          <a:xfrm>
-            <a:off x="1249172" y="5313680"/>
-            <a:ext cx="10391140" cy="543560"/>
-          </a:xfrm>
-          <a:prstGeom prst="rect">
-            <a:avLst/>
-          </a:prstGeom>
-          <a:noFill/>
-          <a:ln/>
-        </p:spPr>
-        <p:txBody>
-          <a:bodyPr wrap="square" lIns="0" tIns="0" rIns="0" bIns="0" rtlCol="0" anchor="ctr"/>
-          <a:lstStyle/>
-          <a:p>
-            <a:pPr marL="0" indent="0">
-              <a:buNone/>
-            </a:pPr>
-            <a:r>
-              <a:rPr lang="en-US" sz="2400" b="1" dirty="0">
-                <a:solidFill>
-                  <a:srgbClr val="1A5C2C"/>
-                </a:solidFill>
-                <a:latin typeface="Cambria" pitchFamily="34" charset="0"/>
-                <a:ea typeface="Cambria" pitchFamily="34" charset="-122"/>
-                <a:cs typeface="Cambria" pitchFamily="34" charset="-120"/>
-              </a:rPr>
-              <a:t>O  </a:t>
-            </a:r>
-            <a:r>
-              <a:rPr lang="en-US" sz="2400" dirty="0">
-                <a:solidFill>
-                  <a:srgbClr val="1F2A22"/>
-                </a:solidFill>
-                <a:latin typeface="Calibri" pitchFamily="34" charset="0"/>
-                <a:ea typeface="Calibri" pitchFamily="34" charset="-122"/>
-                <a:cs typeface="Calibri" pitchFamily="34" charset="-120"/>
-              </a:rPr>
-              <a:t>Ongoing: Review Rhythm</a:t>
-            </a:r>
-            <a:endParaRPr lang="en-US" sz="2400" dirty="0"/>
-          </a:p>
-        </p:txBody>
-      </p:sp>
-      <p:sp>
-        <p:nvSpPr>
-          <p:cNvPr id="27" name="Shape 17"/>
-          <p:cNvSpPr/>
-          <p:nvPr/>
-        </p:nvSpPr>
-        <p:spPr>
-          <a:xfrm>
-            <a:off x="548640" y="5938774"/>
-            <a:ext cx="380492" cy="380492"/>
-          </a:xfrm>
-          <a:prstGeom prst="ellipse">
-            <a:avLst/>
-          </a:prstGeom>
-          <a:solidFill>
-            <a:srgbClr val="1A5C2C"/>
-          </a:solidFill>
-          <a:ln w="12700">
-            <a:solidFill>
-              <a:srgbClr val="1A5C2C"/>
-            </a:solidFill>
-            <a:prstDash val="solid"/>
-          </a:ln>
-        </p:spPr>
-        <p:txBody>
-          <a:bodyPr/>
-          <a:lstStyle/>
-          <a:p>
-            <a:endParaRPr lang="en-ZA"/>
-          </a:p>
-        </p:txBody>
-      </p:sp>
-      <p:pic>
-        <p:nvPicPr>
-          <p:cNvPr id="28" name="Image 8" descr="preencoded.png"/>
-          <p:cNvPicPr>
-            <a:picLocks noChangeAspect="1"/>
-          </p:cNvPicPr>
-          <p:nvPr/>
-        </p:nvPicPr>
-        <p:blipFill>
-          <a:blip r:embed="rId2"/>
-          <a:stretch>
-            <a:fillRect/>
-          </a:stretch>
-        </p:blipFill>
-        <p:spPr>
-          <a:xfrm>
-            <a:off x="643763" y="6033897"/>
-            <a:ext cx="190246" cy="190246"/>
-          </a:xfrm>
-          <a:prstGeom prst="rect">
-            <a:avLst/>
-          </a:prstGeom>
-        </p:spPr>
-      </p:pic>
-      <p:sp>
-        <p:nvSpPr>
-          <p:cNvPr id="29" name="Text 18"/>
-          <p:cNvSpPr txBox="1"/>
-          <p:nvPr/>
-        </p:nvSpPr>
-        <p:spPr>
-          <a:xfrm>
-            <a:off x="1249172" y="5857240"/>
-            <a:ext cx="10391140" cy="543560"/>
-          </a:xfrm>
-          <a:prstGeom prst="rect">
-            <a:avLst/>
-          </a:prstGeom>
-          <a:noFill/>
-          <a:ln/>
-        </p:spPr>
-        <p:txBody>
-          <a:bodyPr wrap="square" lIns="0" tIns="0" rIns="0" bIns="0" rtlCol="0" anchor="ctr"/>
-          <a:lstStyle/>
-          <a:p>
-            <a:pPr marL="0" indent="0">
-              <a:buNone/>
-            </a:pPr>
-            <a:r>
-              <a:rPr lang="en-US" sz="2400" b="1" dirty="0">
-                <a:solidFill>
-                  <a:srgbClr val="1A5C2C"/>
-                </a:solidFill>
-                <a:latin typeface="Cambria" pitchFamily="34" charset="0"/>
-                <a:ea typeface="Cambria" pitchFamily="34" charset="-122"/>
-                <a:cs typeface="Cambria" pitchFamily="34" charset="-120"/>
-              </a:rPr>
-              <a:t>N  </a:t>
-            </a:r>
-            <a:r>
-              <a:rPr lang="en-US" sz="2400" dirty="0">
-                <a:solidFill>
-                  <a:srgbClr val="1F2A22"/>
-                </a:solidFill>
-                <a:latin typeface="Calibri" pitchFamily="34" charset="0"/>
-                <a:ea typeface="Calibri" pitchFamily="34" charset="-122"/>
-                <a:cs typeface="Calibri" pitchFamily="34" charset="-120"/>
-              </a:rPr>
-              <a:t>Navigate: Collective Insight</a:t>
             </a:r>
             <a:endParaRPr lang="en-US" sz="2400" dirty="0"/>
           </a:p>

</xml_diff>

<commit_message>
WARD: Unit 6 Activity 3 (Key Result check-up, box 6C) and Unit 8 part 5.2 (WARD test, box 8E); facilitator pages, decks, reader folders, dashboard, Capstone, handover
Co-Authored-By: Claude Opus 5.5 <noreply@anthropic.com>

Claude-Session: https://claude.ai/code/session_01XPPoLFsFZBzmCgWNMADhB8
</commit_message>
<xml_diff>
--- a/Unit decks/Unit 06 - Performance Management Setup.pptx
+++ b/Unit decks/Unit 06 - Performance Management Setup.pptx
@@ -40,6 +40,7 @@
     <p:sldId id="279" r:id="rId24"/>
     <p:sldId id="280" r:id="rId25"/>
     <p:sldId id="293" r:id="rId34"/>
+    <p:sldId id="309" r:id="rId35"/>
     <p:sldId id="283" r:id="rId28"/>
   </p:sldIdLst>
   <p:sldSz cx="12192000" cy="6858000"/>
@@ -1948,76 +1949,76 @@
           <a:lstStyle/>
           <a:p>
             <a:r>
-              <a:rPr lang="en-GB" b="1" dirty="0"/>
+              <a:rPr lang="en-GB"/>
               <a:t>SECTION 5 · APPLICATION — IN PRACTICE</a:t>
             </a:r>
           </a:p>
           <a:p>
             <a:r>
-              <a:rPr lang="en-GB" dirty="0"/>
+              <a:rPr lang="en-GB"/>
               <a:t>Building Your Enterprise Performance Management System</a:t>
             </a:r>
           </a:p>
           <a:p>
             <a:r>
-              <a:rPr lang="en-GB" dirty="0"/>
-              <a:t>Application · Each group builds two connected components of the Enterprise Performance Management System for the strategy in its Capstone Blueprint: the S2R® Contribution Map™ and the FACES application.</a:t>
-            </a:r>
-          </a:p>
-          <a:p>
-            <a:endParaRPr lang="en-GB" dirty="0"/>
-          </a:p>
-          <a:p>
-            <a:r>
-              <a:rPr lang="en-GB" b="1" dirty="0"/>
+              <a:rPr lang="en-GB"/>
+              <a:t>Application · Each group builds three connected components of the Enterprise Performance Management System for the strategy in its Capstone Blueprint: the S2R® Contribution Map™, the FACES application and the WARD check-up for its enterprise Key Result.</a:t>
+            </a:r>
+          </a:p>
+          <a:p>
+            <a:endParaRPr lang="en-GB"/>
+          </a:p>
+          <a:p>
+            <a:r>
+              <a:rPr lang="en-GB"/>
               <a:t>Section learning outcomes:</a:t>
             </a:r>
           </a:p>
           <a:p>
             <a:r>
-              <a:rPr lang="en-GB" dirty="0"/>
+              <a:rPr lang="en-GB"/>
               <a:t>1. Design the contribution arrangements required to deliver a chosen enterprise Key Result.</a:t>
             </a:r>
           </a:p>
           <a:p>
             <a:r>
-              <a:rPr lang="en-GB" dirty="0"/>
+              <a:rPr lang="en-GB"/>
               <a:t>2. Establish shared management accountability for contributions across functions.</a:t>
             </a:r>
           </a:p>
           <a:p>
-            <a:endParaRPr lang="en-GB" dirty="0"/>
-          </a:p>
-          <a:p>
-            <a:r>
-              <a:rPr lang="en-GB" b="1" dirty="0"/>
+            <a:endParaRPr lang="en-GB"/>
+          </a:p>
+          <a:p>
+            <a:r>
+              <a:rPr lang="en-GB"/>
               <a:t>HOW TO TEACH IT:</a:t>
             </a:r>
           </a:p>
           <a:p>
-            <a:endParaRPr lang="en-GB" dirty="0"/>
-          </a:p>
-          <a:p>
-            <a:r>
-              <a:rPr lang="en-GB" b="1" dirty="0"/>
+            <a:endParaRPr lang="en-GB"/>
+          </a:p>
+          <a:p>
+            <a:r>
+              <a:rPr lang="en-GB"/>
               <a:t>1. Frame the application.</a:t>
             </a:r>
           </a:p>
           <a:p>
             <a:r>
-              <a:rPr lang="en-GB" dirty="0"/>
-              <a:t>Say: "You have already established your capstone organisation’s strategic direction, strategic objectives and Key Results. In this application, your group uses that work to develop two connected components of your Enterprise Performance Management System: Activity 1, the S2R® Contribution Map™, and Activity 2, the FACES application."</a:t>
-            </a:r>
-          </a:p>
-          <a:p>
-            <a:r>
-              <a:rPr lang="en-GB" dirty="0"/>
-              <a:t>Order: both activities are group work and Capstone work. Activity 1 needs the group’s confirmed Enterprise OKRs from Unit 3, part 5.2. Activity 2 uses the business functions the group names in Activity 1.</a:t>
-            </a:r>
-          </a:p>
-          <a:p>
-            <a:r>
-              <a:rPr lang="en-GB" dirty="0"/>
+              <a:rPr lang="en-GB"/>
+              <a:t>Say: "You have already established your capstone organisation’s strategic direction, strategic objectives and Key Results. In this application, your group uses that work to develop three connected components of your Enterprise Performance Management System: Activity 1, the S2R® Contribution Map™, Activity 2, the FACES application, and Activity 3, the WARD check-up for your enterprise Key Result."</a:t>
+            </a:r>
+          </a:p>
+          <a:p>
+            <a:r>
+              <a:rPr lang="en-GB"/>
+              <a:t>Order: all three activities are group work and Capstone work. Activity 1 needs the group’s confirmed Enterprise OKRs from Unit 3, part 5.2. Activity 2 uses the business functions the group names in Activity 1. Activity 3 sets the WARD check-up for the Key Result chosen in Activity 1, using the conditions named in the Contribution Map.</a:t>
+            </a:r>
+          </a:p>
+          <a:p>
+            <a:r>
+              <a:rPr lang="en-GB"/>
               <a:t>How to guide the work: brief each activity from the worked example in Section 4, then let the groups work through the steps on their own pages. The group chooses its scribe; the entries appear on every member’s page.</a:t>
             </a:r>
           </a:p>
@@ -2564,130 +2565,130 @@
           <a:lstStyle/>
           <a:p>
             <a:r>
-              <a:rPr lang="en-GB" b="1" dirty="0"/>
+              <a:rPr lang="en-GB"/>
               <a:t>UNIT SUMMARY (UNIT 6 SYNTHESIS)</a:t>
             </a:r>
           </a:p>
           <a:p>
-            <a:endParaRPr lang="en-GB" dirty="0"/>
-          </a:p>
-          <a:p>
-            <a:r>
-              <a:rPr lang="en-GB" b="1" dirty="0"/>
+            <a:endParaRPr lang="en-GB"/>
+          </a:p>
+          <a:p>
+            <a:r>
+              <a:rPr lang="en-GB"/>
               <a:t>HOW TO TEACH IT:</a:t>
             </a:r>
           </a:p>
           <a:p>
-            <a:endParaRPr lang="en-GB" dirty="0"/>
-          </a:p>
-          <a:p>
-            <a:r>
-              <a:rPr lang="en-GB" b="1" dirty="0"/>
+            <a:endParaRPr lang="en-GB"/>
+          </a:p>
+          <a:p>
+            <a:r>
+              <a:rPr lang="en-GB"/>
               <a:t>1. Recap the unit, section by section.</a:t>
             </a:r>
           </a:p>
           <a:p>
             <a:r>
-              <a:rPr lang="en-GB" dirty="0"/>
+              <a:rPr lang="en-GB"/>
               <a:t>- 1 · Awareness: Performance measurement answers what happened; performance management decides what to do about it. Enterprise performance comes from people performance (results against KPIs and OKRs, and behaviours) and organisational performance (the organisational conditions: environment, systems, resources and governance). The S2R® Contribution Map™ connects an enterprise Key Result to the contribution each function, its people and the organisation must make. FACES names the five functions that manage those contributions across both systems.</a:t>
             </a:r>
           </a:p>
           <a:p>
             <a:r>
-              <a:rPr lang="en-GB" dirty="0"/>
+              <a:rPr lang="en-GB"/>
               <a:t>- 2 · Intelligence: Performance management is the execution bridge that keeps strategy connected to performance throughout delivery. Four bridges sustain it: Decomposing the Big Picture, Defining the Logic of Success, Calibrating the Rhythm and Structuring the Dialogue. Compliance-driven and commitment-driven architectures shape how accountability works for people and for the organisation when results fall short.</a:t>
             </a:r>
           </a:p>
           <a:p>
             <a:r>
-              <a:rPr lang="en-GB" dirty="0"/>
+              <a:rPr lang="en-GB"/>
               <a:t>- 3 · Extrapolating: Each executive brings a natural performance focus and a potential blind spot. Unity in Diversity integrates the ten executive performance perspectives into one view of enterprise progress. Three shifts are moving performance management from annual to continuous, from rating-centric to development-centric, and from individual to team performance.</a:t>
             </a:r>
           </a:p>
           <a:p>
             <a:r>
-              <a:rPr lang="en-GB" dirty="0"/>
+              <a:rPr lang="en-GB"/>
               <a:t>- 4 · Integration: The worked example mapped one enterprise Key Result across Customer Service, IT, Operations and Workforce Planning: each function’s contribution, what its people must deliver and the organisational conditions that enable them, each with a measure or evidence. FACES then showed how those contributions are managed in practice.</a:t>
             </a:r>
           </a:p>
           <a:p>
             <a:r>
-              <a:rPr lang="en-GB" dirty="0"/>
-              <a:t>- 5 · Application: Each group built an S2R® Contribution Map™ for one of its own enterprise Key Results and applied FACES to manage each function’s contribution. The confirmed record feeds the team’s Capstone Blueprint.</a:t>
-            </a:r>
-          </a:p>
-          <a:p>
-            <a:endParaRPr lang="en-GB" dirty="0"/>
-          </a:p>
-          <a:p>
-            <a:r>
-              <a:rPr lang="en-GB" b="1" dirty="0"/>
+              <a:rPr lang="en-GB"/>
+              <a:t>- 5 · Application: Each group built an S2R® Contribution Map™ for one of its own enterprise Key Results, applied FACES to manage each function’s contribution and set the WARD check-up for the Key Result. The confirmed record feeds the team’s Capstone Blueprint.</a:t>
+            </a:r>
+          </a:p>
+          <a:p>
+            <a:endParaRPr lang="en-GB"/>
+          </a:p>
+          <a:p>
+            <a:r>
+              <a:rPr lang="en-GB"/>
               <a:t>2. Ask the closing question on the slide.</a:t>
             </a:r>
           </a:p>
           <a:p>
             <a:r>
-              <a:rPr lang="en-GB" dirty="0"/>
+              <a:rPr lang="en-GB"/>
               <a:t>Ask: "Which contribution in your group’s map was hardest to agree, and what does that tell you about the performance management system in your own organisation?" Take an answer from each group.</a:t>
             </a:r>
           </a:p>
           <a:p>
-            <a:endParaRPr lang="en-GB" dirty="0"/>
-          </a:p>
-          <a:p>
-            <a:r>
-              <a:rPr lang="en-GB" b="1" dirty="0"/>
+            <a:endParaRPr lang="en-GB"/>
+          </a:p>
+          <a:p>
+            <a:r>
+              <a:rPr lang="en-GB"/>
               <a:t>3. Close the unit.</a:t>
             </a:r>
           </a:p>
           <a:p>
             <a:r>
-              <a:rPr lang="en-GB" dirty="0"/>
+              <a:rPr lang="en-GB"/>
               <a:t>Say: "A performance management system that only measures has not yet become a management system. The moment measurement becomes the basis for a decision, a conversation, and an accountable intervention — that is the moment execution begins."</a:t>
             </a:r>
           </a:p>
           <a:p>
-            <a:endParaRPr lang="en-GB" dirty="0"/>
-          </a:p>
-          <a:p>
-            <a:r>
-              <a:rPr lang="en-GB" b="1" dirty="0"/>
+            <a:endParaRPr lang="en-GB"/>
+          </a:p>
+          <a:p>
+            <a:r>
+              <a:rPr lang="en-GB"/>
               <a:t>4. Say what happens on the portal.</a:t>
             </a:r>
           </a:p>
           <a:p>
             <a:r>
-              <a:rPr lang="en-GB" dirty="0"/>
+              <a:rPr lang="en-GB"/>
               <a:t>Say: "You now complete the unit on the portal: your four personal reflections and your group’s record in Section 5. When your page is complete, you submit the unit."</a:t>
             </a:r>
           </a:p>
           <a:p>
-            <a:endParaRPr lang="en-GB" dirty="0"/>
-          </a:p>
-          <a:p>
-            <a:r>
-              <a:rPr lang="en-GB" b="1" dirty="0"/>
+            <a:endParaRPr lang="en-GB"/>
+          </a:p>
+          <a:p>
+            <a:r>
+              <a:rPr lang="en-GB"/>
               <a:t>ON THE PORTAL, AFTER THE TEACHING:</a:t>
             </a:r>
           </a:p>
           <a:p>
             <a:r>
-              <a:rPr lang="en-GB" dirty="0"/>
+              <a:rPr lang="en-GB"/>
               <a:t>Participants complete every part of the participant file and submit the unit to the facilitator from the end of Section 5.</a:t>
             </a:r>
           </a:p>
           <a:p>
-            <a:endParaRPr lang="en-GB" dirty="0"/>
-          </a:p>
-          <a:p>
-            <a:r>
-              <a:rPr lang="en-GB" b="1" dirty="0"/>
+            <a:endParaRPr lang="en-GB"/>
+          </a:p>
+          <a:p>
+            <a:r>
+              <a:rPr lang="en-GB"/>
               <a:t>AFTER THE SESSION:</a:t>
             </a:r>
           </a:p>
           <a:p>
             <a:r>
-              <a:rPr lang="en-GB" dirty="0"/>
+              <a:rPr lang="en-GB"/>
               <a:t>Each submission reaches you in the facilitator dashboard. The personal reflections go to each participant’s Learning Portfolio; the group’s confirmed record feeds the team’s Capstone Blueprint.</a:t>
             </a:r>
           </a:p>
@@ -2774,173 +2775,441 @@
           <a:lstStyle/>
           <a:p>
             <a:r>
-              <a:rPr lang="en-GB" b="1" dirty="0"/>
+              <a:rPr lang="en-GB"/>
               <a:t>5.2 — ACTIVITY 2: APPLY FACES TO YOUR CONTRIBUTION MAP™ (CAPSTONE WORK)</a:t>
             </a:r>
           </a:p>
           <a:p>
-            <a:endParaRPr lang="en-GB" dirty="0"/>
-          </a:p>
-          <a:p>
-            <a:r>
-              <a:rPr lang="en-GB" b="1" dirty="0"/>
+            <a:endParaRPr lang="en-GB"/>
+          </a:p>
+          <a:p>
+            <a:r>
+              <a:rPr lang="en-GB"/>
               <a:t>HOW TO TEACH IT:</a:t>
             </a:r>
           </a:p>
           <a:p>
-            <a:endParaRPr lang="en-GB" dirty="0"/>
-          </a:p>
-          <a:p>
-            <a:r>
-              <a:rPr lang="en-GB" b="1" dirty="0"/>
+            <a:endParaRPr lang="en-GB"/>
+          </a:p>
+          <a:p>
+            <a:r>
+              <a:rPr lang="en-GB"/>
               <a:t>1. Brief the activity.</a:t>
             </a:r>
           </a:p>
           <a:p>
             <a:r>
-              <a:rPr lang="en-GB" dirty="0"/>
+              <a:rPr lang="en-GB"/>
               <a:t>Briefing: each group applies FACES to the contributions it mapped in Activity 1. For each business function it describes one practical management arrangement for each FACES function. Point the groups to the application questions and to the worked example in part 4.2.</a:t>
             </a:r>
           </a:p>
           <a:p>
-            <a:endParaRPr lang="en-GB" dirty="0"/>
-          </a:p>
-          <a:p>
-            <a:r>
-              <a:rPr lang="en-GB" dirty="0"/>
+            <a:endParaRPr lang="en-GB"/>
+          </a:p>
+          <a:p>
+            <a:r>
+              <a:rPr lang="en-GB"/>
               <a:t>The group has established the contributions required to achieve its enterprise Key Result. It now applies FACES to determine how these contributions will be managed. The business functions named in Activity 1 are shown in the FACES template on each participant’s page.</a:t>
             </a:r>
           </a:p>
           <a:p>
-            <a:endParaRPr lang="en-GB" dirty="0"/>
-          </a:p>
-          <a:p>
-            <a:r>
-              <a:rPr lang="en-GB" b="1" dirty="0"/>
+            <a:endParaRPr lang="en-GB"/>
+          </a:p>
+          <a:p>
+            <a:r>
+              <a:rPr lang="en-GB"/>
               <a:t>2. Step 3 · Teach the application question for each function.</a:t>
             </a:r>
           </a:p>
           <a:p>
             <a:r>
-              <a:rPr lang="en-GB" dirty="0"/>
+              <a:rPr lang="en-GB"/>
               <a:t>F · Foster a Results Culture: What routine or leadership practice will reinforce ownership of performance commitments and delivery obstacles? The template asks: How will employees and leaders demonstrate ownership of results?</a:t>
             </a:r>
           </a:p>
           <a:p>
             <a:r>
-              <a:rPr lang="en-GB" dirty="0"/>
+              <a:rPr lang="en-GB"/>
               <a:t>A · Align Performance: How will the function’s performance expectations and enabling conditions remain connected to the enterprise Key Result? The template asks: How will human contributions and organisational conditions remain aligned with the enterprise Key Result?</a:t>
             </a:r>
           </a:p>
           <a:p>
             <a:r>
-              <a:rPr lang="en-GB" dirty="0"/>
+              <a:rPr lang="en-GB"/>
               <a:t>C · Create Measurement Transparency: What evidence will make both people performance and organisational constraints visible? The template asks: How will people performance and the effectiveness of the organisational conditions be made visible?</a:t>
             </a:r>
           </a:p>
           <a:p>
             <a:r>
-              <a:rPr lang="en-GB" dirty="0"/>
+              <a:rPr lang="en-GB"/>
               <a:t>E · Embed Shared Accountability: Who will own performance commitments, enabling conditions and decisions required to address performance gaps? The template asks: Who will be responsible for contributions, enabling conditions and corrective decisions?</a:t>
             </a:r>
           </a:p>
           <a:p>
             <a:r>
-              <a:rPr lang="en-GB" dirty="0"/>
+              <a:rPr lang="en-GB"/>
               <a:t>S · Support Continuous Development: How will performance findings be used to strengthen employee capability and organisational effectiveness? The template asks: How will performance findings lead to improvements in human capability and organisational conditions?</a:t>
             </a:r>
           </a:p>
           <a:p>
-            <a:endParaRPr lang="en-GB" dirty="0"/>
-          </a:p>
-          <a:p>
-            <a:r>
-              <a:rPr lang="en-GB" b="1" dirty="0"/>
+            <a:endParaRPr lang="en-GB"/>
+          </a:p>
+          <a:p>
+            <a:r>
+              <a:rPr lang="en-GB"/>
               <a:t>3. Read the completion check.</a:t>
             </a:r>
           </a:p>
           <a:p>
             <a:r>
-              <a:rPr lang="en-GB" dirty="0"/>
+              <a:rPr lang="en-GB"/>
               <a:t>Before confirming, the group checks that:</a:t>
             </a:r>
           </a:p>
           <a:p>
             <a:r>
-              <a:rPr lang="en-GB" dirty="0"/>
+              <a:rPr lang="en-GB"/>
               <a:t>1. All five FACES functions have been addressed for each business function.</a:t>
             </a:r>
           </a:p>
           <a:p>
             <a:r>
-              <a:rPr lang="en-GB" dirty="0"/>
+              <a:rPr lang="en-GB"/>
               <a:t>2. Your responses describe practical management arrangements.</a:t>
             </a:r>
           </a:p>
           <a:p>
             <a:r>
-              <a:rPr lang="en-GB" dirty="0"/>
+              <a:rPr lang="en-GB"/>
               <a:t>3. Your FACES application uses the contributions and performance requirements established in Activity 1.</a:t>
             </a:r>
           </a:p>
           <a:p>
             <a:r>
-              <a:rPr lang="en-GB" dirty="0"/>
+              <a:rPr lang="en-GB"/>
               <a:t>Say: "The S2R® Contribution Map™ establishes the contributions required to achieve an enterprise result. FACES establishes how those contributions will be managed across the organisation. Together, they connect enterprise strategy to functional performance, human contribution, organisational enablement and collective accountability."</a:t>
             </a:r>
           </a:p>
           <a:p>
-            <a:endParaRPr lang="en-GB" dirty="0"/>
-          </a:p>
-          <a:p>
-            <a:r>
-              <a:rPr lang="en-GB" b="1" dirty="0"/>
+            <a:endParaRPr lang="en-GB"/>
+          </a:p>
+          <a:p>
+            <a:r>
+              <a:rPr lang="en-GB"/>
               <a:t>ON THE PORTAL, AFTER THE TEACHING:</a:t>
             </a:r>
           </a:p>
           <a:p>
             <a:r>
-              <a:rPr lang="en-GB" dirty="0"/>
+              <a:rPr lang="en-GB"/>
               <a:t>Participants work as a group in Activity 2 of Section 5 of the participant file. This is Capstone work. The group chooses its scribe for this work. The scribe types what the group agrees, and the entries appear on every member’s page.</a:t>
             </a:r>
           </a:p>
           <a:p>
             <a:r>
-              <a:rPr lang="en-GB" dirty="0"/>
+              <a:rPr lang="en-GB"/>
               <a:t>1. For each business function named in Activity 1, the group describes one practical management arrangement for each of the five FACES functions.</a:t>
             </a:r>
           </a:p>
           <a:p>
             <a:r>
-              <a:rPr lang="en-GB" dirty="0"/>
-              <a:t>2. The group reads the completion check.</a:t>
-            </a:r>
-          </a:p>
-          <a:p>
-            <a:r>
-              <a:rPr lang="en-GB" dirty="0"/>
-              <a:t>3. Each participant reads the record and selects Agree. Print gives a copy.</a:t>
-            </a:r>
-          </a:p>
-          <a:p>
-            <a:r>
-              <a:rPr lang="en-GB" dirty="0"/>
-              <a:t>The confirmed record feeds the team’s Capstone Blueprint.</a:t>
-            </a:r>
-          </a:p>
-          <a:p>
-            <a:endParaRPr lang="en-GB" dirty="0"/>
-          </a:p>
-          <a:p>
-            <a:r>
-              <a:rPr lang="en-GB" b="1" dirty="0"/>
+              <a:rPr lang="en-GB"/>
+              <a:t>2. The group reads the completion check, then goes to Activity 3.</a:t>
+            </a:r>
+          </a:p>
+        </p:txBody>
+      </p:sp>
+      <p:sp>
+        <p:nvSpPr>
+          <p:cNvPr id="4" name="Slide Number Placeholder 3"/>
+          <p:cNvSpPr>
+            <a:spLocks noGrp="1"/>
+          </p:cNvSpPr>
+          <p:nvPr>
+            <p:ph type="sldNum" sz="quarter" idx="10"/>
+          </p:nvPr>
+        </p:nvSpPr>
+        <p:spPr/>
+        <p:txBody>
+          <a:bodyPr/>
+          <a:lstStyle/>
+          <a:p>
+            <a:fld id="{F7021451-1387-4CA6-816F-3879F97B5CBC}" type="slidenum">
+              <a:rPr lang="en-US"/>
+              <a:t>7</a:t>
+            </a:fld>
+            <a:endParaRPr lang="en-US"/>
+          </a:p>
+        </p:txBody>
+      </p:sp>
+    </p:spTree>
+  </p:cSld>
+  <p:clrMapOvr>
+    <a:masterClrMapping/>
+  </p:clrMapOvr>
+</p:notes>
+</file>
+
+<file path=ppt/notesSlides/notesSlide29.xml><?xml version="1.0" encoding="utf-8"?>
+<p:notes xmlns:a="http://schemas.openxmlformats.org/drawingml/2006/main" xmlns:p="http://schemas.openxmlformats.org/presentationml/2006/main" xmlns:r="http://schemas.openxmlformats.org/officeDocument/2006/relationships">
+  <p:cSld>
+    <p:spTree>
+      <p:nvGrpSpPr>
+        <p:cNvPr id="1" name=""/>
+        <p:cNvGrpSpPr/>
+        <p:nvPr/>
+      </p:nvGrpSpPr>
+      <p:grpSpPr>
+        <a:xfrm>
+          <a:off x="0" y="0"/>
+          <a:ext cx="0" cy="0"/>
+          <a:chOff x="0" y="0"/>
+          <a:chExt cx="0" cy="0"/>
+        </a:xfrm>
+      </p:grpSpPr>
+      <p:sp>
+        <p:nvSpPr>
+          <p:cNvPr id="2" name="Slide Image Placeholder 1"/>
+          <p:cNvSpPr>
+            <a:spLocks noGrp="1" noRot="1" noChangeAspect="1"/>
+          </p:cNvSpPr>
+          <p:nvPr>
+            <p:ph type="sldImg"/>
+          </p:nvPr>
+        </p:nvSpPr>
+        <p:spPr/>
+      </p:sp>
+      <p:sp>
+        <p:nvSpPr>
+          <p:cNvPr id="3" name="Notes Placeholder 2"/>
+          <p:cNvSpPr>
+            <a:spLocks noGrp="1"/>
+          </p:cNvSpPr>
+          <p:nvPr>
+            <p:ph type="body" idx="1"/>
+          </p:nvPr>
+        </p:nvSpPr>
+        <p:spPr/>
+        <p:txBody>
+          <a:bodyPr/>
+          <a:lstStyle/>
+          <a:p>
+            <a:r>
+              <a:rPr lang="en-GB"/>
+              <a:t>5.3 — ACTIVITY 3: WARD · YOUR KEY RESULT’S VITAL CHECK-UP (CAPSTONE WORK)</a:t>
+            </a:r>
+          </a:p>
+          <a:p>
+            <a:endParaRPr lang="en-GB"/>
+          </a:p>
+          <a:p>
+            <a:r>
+              <a:rPr lang="en-GB"/>
+              <a:t>HOW TO TEACH IT:</a:t>
+            </a:r>
+          </a:p>
+          <a:p>
+            <a:endParaRPr lang="en-GB"/>
+          </a:p>
+          <a:p>
+            <a:r>
+              <a:rPr lang="en-GB"/>
+              <a:t>1. Open with the check-up.</a:t>
+            </a:r>
+          </a:p>
+          <a:p>
+            <a:r>
+              <a:rPr lang="en-GB"/>
+              <a:t>Say: "Every Key Result your group set in Unit 3 has a baseline, a target and a deadline. Performance management must set out in advance when a Key Result will be checked and which result raises a red flag. Corrective action then starts early, while the gap is still small enough to close. WARD is the vital check-up that sets these points for your Key Result."</a:t>
+            </a:r>
+          </a:p>
+          <a:p>
+            <a:endParaRPr lang="en-GB"/>
+          </a:p>
+          <a:p>
+            <a:r>
+              <a:rPr lang="en-GB"/>
+              <a:t>2. Teach the four letters.</a:t>
+            </a:r>
+          </a:p>
+          <a:p>
+            <a:r>
+              <a:rPr lang="en-GB"/>
+              <a:t>W · Waypoints: The dates on which the Key Result is checked, and the level it must have reached by each.</a:t>
+            </a:r>
+          </a:p>
+          <a:p>
+            <a:r>
+              <a:rPr lang="en-GB"/>
+              <a:t>A · Alert: How far off a waypoint the result can be before it raises a red flag.</a:t>
+            </a:r>
+          </a:p>
+          <a:p>
+            <a:r>
+              <a:rPr lang="en-GB"/>
+              <a:t>R · Recovery: The corrective action that follows a red flag, for the individuals and for the organisational conditions.</a:t>
+            </a:r>
+          </a:p>
+          <a:p>
+            <a:r>
+              <a:rPr lang="en-GB"/>
+              <a:t>D · Decider: The executive who decides on the recovery and sees it through.</a:t>
+            </a:r>
+          </a:p>
+          <a:p>
+            <a:endParaRPr lang="en-GB"/>
+          </a:p>
+          <a:p>
+            <a:r>
+              <a:rPr lang="en-GB"/>
+              <a:t>3. Take the worked example through WARD.</a:t>
+            </a:r>
+          </a:p>
+          <a:p>
+            <a:r>
+              <a:rPr lang="en-GB"/>
+              <a:t>Enterprise Key Result from part 4.1: Increase customer enquiries resolved within 48 hours from 65% to 90% by year-end.</a:t>
+            </a:r>
+          </a:p>
+          <a:p>
+            <a:r>
+              <a:rPr lang="en-GB"/>
+              <a:t>W · Waypoints: 72% by the end of March, 80% by the end of June and 85% by the end of September, on the way to 90% at year-end.</a:t>
+            </a:r>
+          </a:p>
+          <a:p>
+            <a:r>
+              <a:rPr lang="en-GB"/>
+              <a:t>A · Alert: More than three percentage points below a waypoint at a monthly review.</a:t>
+            </a:r>
+          </a:p>
+          <a:p>
+            <a:r>
+              <a:rPr lang="en-GB"/>
+              <a:t>R · Recovery · individuals: Team leaders review every open enquiry with its owner each morning, and agents with repeated follow-through gaps are coached.</a:t>
+            </a:r>
+          </a:p>
+          <a:p>
+            <a:r>
+              <a:rPr lang="en-GB"/>
+              <a:t>R · Recovery · organisational conditions: The owner of the condition named in the Contribution Map restores it: IT for system availability, Workforce Planning for staffing coverage, Operations for approval delays.</a:t>
+            </a:r>
+          </a:p>
+          <a:p>
+            <a:r>
+              <a:rPr lang="en-GB"/>
+              <a:t>D · Decider: The Customer Service Executive.</a:t>
+            </a:r>
+          </a:p>
+          <a:p>
+            <a:r>
+              <a:rPr lang="en-GB"/>
+              <a:t>Ask: "At the end of June the result is 74%. What happens on Monday morning, and who decides?"</a:t>
+            </a:r>
+          </a:p>
+          <a:p>
+            <a:r>
+              <a:rPr lang="en-GB"/>
+              <a:t>Guide the groups to see that the waypoint, the alert and the recovery answer the question before the review takes place.</a:t>
+            </a:r>
+          </a:p>
+          <a:p>
+            <a:endParaRPr lang="en-GB"/>
+          </a:p>
+          <a:p>
+            <a:r>
+              <a:rPr lang="en-GB"/>
+              <a:t>4. Read the completion check.</a:t>
+            </a:r>
+          </a:p>
+          <a:p>
+            <a:r>
+              <a:rPr lang="en-GB"/>
+              <a:t>1. Each waypoint has a date and a level, and the waypoints lead to the target by the deadline.</a:t>
+            </a:r>
+          </a:p>
+          <a:p>
+            <a:r>
+              <a:rPr lang="en-GB"/>
+              <a:t>2. The alert is specific enough that every member reads the same result the same way.</a:t>
+            </a:r>
+          </a:p>
+          <a:p>
+            <a:r>
+              <a:rPr lang="en-GB"/>
+              <a:t>3. The recovery covers the individuals and the organisational conditions named in the Contribution Map.</a:t>
+            </a:r>
+          </a:p>
+          <a:p>
+            <a:r>
+              <a:rPr lang="en-GB"/>
+              <a:t>4. One executive is named as the decider.</a:t>
+            </a:r>
+          </a:p>
+          <a:p>
+            <a:r>
+              <a:rPr lang="en-GB"/>
+              <a:t>Say: "In Unit 8 your group tests its WARD: the alert fires, and you run the recovery."</a:t>
+            </a:r>
+          </a:p>
+          <a:p>
+            <a:endParaRPr lang="en-GB"/>
+          </a:p>
+          <a:p>
+            <a:r>
+              <a:rPr lang="en-GB"/>
+              <a:t>ON THE PORTAL, AFTER THE TEACHING:</a:t>
+            </a:r>
+          </a:p>
+          <a:p>
+            <a:r>
+              <a:rPr lang="en-GB"/>
+              <a:t>Participants work as a group in Activity 3 of Section 5 of the participant file. This is Capstone work. The group chooses its scribe for this work. The scribe types what the group agrees, and the entries appear on every member’s page.</a:t>
+            </a:r>
+          </a:p>
+          <a:p>
+            <a:r>
+              <a:rPr lang="en-GB"/>
+              <a:t>1. The group sets two or three waypoints for its enterprise Key Result: a date and a level for each.</a:t>
+            </a:r>
+          </a:p>
+          <a:p>
+            <a:r>
+              <a:rPr lang="en-GB"/>
+              <a:t>2. The group sets the alert, the recovery for the individuals and for the organisational conditions, and the decider.</a:t>
+            </a:r>
+          </a:p>
+          <a:p>
+            <a:r>
+              <a:rPr lang="en-GB"/>
+              <a:t>3. The group reads the completion check.</a:t>
+            </a:r>
+          </a:p>
+          <a:p>
+            <a:r>
+              <a:rPr lang="en-GB"/>
+              <a:t>4. Each participant reads the record and selects Agree. Print gives a copy.</a:t>
+            </a:r>
+          </a:p>
+          <a:p>
+            <a:r>
+              <a:rPr lang="en-GB"/>
+              <a:t>The agreed record feeds the team’s Capstone Blueprint.</a:t>
+            </a:r>
+          </a:p>
+          <a:p>
+            <a:endParaRPr lang="en-GB"/>
+          </a:p>
+          <a:p>
+            <a:r>
+              <a:rPr lang="en-GB"/>
               <a:t>AFTER THE SESSION:</a:t>
             </a:r>
           </a:p>
           <a:p>
             <a:r>
-              <a:rPr lang="en-GB" dirty="0"/>
-              <a:t>The record reaches you with each participant’s submission, under the heading of Section 5. The confirmed record feeds the Unit 6 boxes of the team’s Capstone Blueprint: the Contribution Map and the FACES application.</a:t>
+              <a:rPr lang="en-GB"/>
+              <a:t>The record reaches you with each participant’s submission, under the heading of Section 5. The agreed record feeds the Unit 6 boxes of the team’s Capstone Blueprint: the Contribution Map in 6A, the FACES application in 6B and the WARD check-up in 6C.</a:t>
             </a:r>
           </a:p>
         </p:txBody>
@@ -21154,6 +21423,495 @@
 </file>
 
 <file path=ppt/slides/slide33.xml><?xml version="1.0" encoding="utf-8"?>
+<p:sld xmlns:a="http://schemas.openxmlformats.org/drawingml/2006/main" xmlns:p="http://schemas.openxmlformats.org/presentationml/2006/main" xmlns:r="http://schemas.openxmlformats.org/officeDocument/2006/relationships">
+  <p:cSld>
+    <p:bg>
+      <p:bgPr>
+        <a:solidFill>
+          <a:srgbClr val="FFFFFF"/>
+        </a:solidFill>
+        <a:effectLst/>
+      </p:bgPr>
+    </p:bg>
+    <p:spTree>
+      <p:nvGrpSpPr>
+        <p:cNvPr id="1" name=""/>
+        <p:cNvGrpSpPr/>
+        <p:nvPr/>
+      </p:nvGrpSpPr>
+      <p:grpSpPr/>
+      <p:sp>
+        <p:nvSpPr>
+          <p:cNvPr id="2" name="Text 0"/>
+          <p:cNvSpPr txBox="1"/>
+          <p:nvPr/>
+        </p:nvSpPr>
+        <p:spPr>
+          <a:xfrm>
+            <a:off x="548640" y="411480"/>
+            <a:ext cx="11064240" cy="868680"/>
+          </a:xfrm>
+          <a:prstGeom prst="rect">
+            <a:avLst/>
+          </a:prstGeom>
+          <a:noFill/>
+          <a:ln/>
+        </p:spPr>
+        <p:txBody>
+          <a:bodyPr wrap="square" lIns="0" tIns="0" rIns="0" bIns="0" rtlCol="0" anchor="ctr"/>
+          <a:lstStyle/>
+          <a:p>
+            <a:pPr marL="0" indent="0">
+              <a:buNone/>
+            </a:pPr>
+            <a:r>
+              <a:rPr lang="en-US" sz="3600" b="1" dirty="0">
+                <a:solidFill>
+                  <a:srgbClr val="1A5C2C"/>
+                </a:solidFill>
+                <a:latin typeface="Cambria" pitchFamily="34" charset="0"/>
+                <a:ea typeface="Cambria" pitchFamily="34" charset="-122"/>
+                <a:cs typeface="Cambria" pitchFamily="34" charset="-120"/>
+              </a:rPr>
+              <a:t>5.3 · Activity 3: WARD check-up</a:t>
+            </a:r>
+            <a:endParaRPr lang="en-US" sz="3600" dirty="0"/>
+          </a:p>
+        </p:txBody>
+      </p:sp>
+      <p:sp>
+        <p:nvSpPr>
+          <p:cNvPr id="3" name="Shape 1"/>
+          <p:cNvSpPr/>
+          <p:nvPr/>
+        </p:nvSpPr>
+        <p:spPr>
+          <a:xfrm>
+            <a:off x="548640" y="1677924"/>
+            <a:ext cx="640080" cy="640080"/>
+          </a:xfrm>
+          <a:prstGeom prst="ellipse">
+            <a:avLst/>
+          </a:prstGeom>
+          <a:solidFill>
+            <a:srgbClr val="1A5C2C"/>
+          </a:solidFill>
+          <a:ln w="12700">
+            <a:solidFill>
+              <a:srgbClr val="1A5C2C"/>
+            </a:solidFill>
+            <a:prstDash val="solid"/>
+          </a:ln>
+        </p:spPr>
+        <p:txBody>
+          <a:bodyPr/>
+          <a:lstStyle/>
+          <a:p>
+            <a:endParaRPr lang="en-ZA"/>
+          </a:p>
+        </p:txBody>
+      </p:sp>
+      <p:pic>
+        <p:nvPicPr>
+          <p:cNvPr id="4" name="Image 0" descr="preencoded.png"/>
+          <p:cNvPicPr>
+            <a:picLocks noChangeAspect="1"/>
+          </p:cNvPicPr>
+          <p:nvPr/>
+        </p:nvPicPr>
+        <p:blipFill>
+          <a:blip r:embed="rId8"/>
+          <a:stretch>
+            <a:fillRect/>
+          </a:stretch>
+        </p:blipFill>
+        <p:spPr>
+          <a:xfrm>
+            <a:off x="708660" y="1837944"/>
+            <a:ext cx="320040" cy="320040"/>
+          </a:xfrm>
+          <a:prstGeom prst="rect">
+            <a:avLst/>
+          </a:prstGeom>
+        </p:spPr>
+      </p:pic>
+      <p:sp>
+        <p:nvSpPr>
+          <p:cNvPr id="5" name="Text 2"/>
+          <p:cNvSpPr txBox="1"/>
+          <p:nvPr/>
+        </p:nvSpPr>
+        <p:spPr>
+          <a:xfrm>
+            <a:off x="1508760" y="1508760"/>
+            <a:ext cx="10131552" cy="978408"/>
+          </a:xfrm>
+          <a:prstGeom prst="rect">
+            <a:avLst/>
+          </a:prstGeom>
+          <a:noFill/>
+          <a:ln/>
+        </p:spPr>
+        <p:txBody>
+          <a:bodyPr wrap="square" lIns="0" tIns="0" rIns="0" bIns="0" rtlCol="0" anchor="ctr"/>
+          <a:lstStyle/>
+          <a:p>
+            <a:pPr marL="0" indent="0">
+              <a:buNone/>
+            </a:pPr>
+            <a:r>
+              <a:rPr lang="en-US" sz="2600" b="1" dirty="0">
+                <a:solidFill>
+                  <a:srgbClr val="1A5C2C"/>
+                </a:solidFill>
+                <a:latin typeface="Cambria" pitchFamily="34" charset="0"/>
+                <a:ea typeface="Cambria" pitchFamily="34" charset="-122"/>
+                <a:cs typeface="Cambria" pitchFamily="34" charset="-120"/>
+              </a:rPr>
+              <a:t>W  </a:t>
+            </a:r>
+            <a:r>
+              <a:rPr lang="en-US" sz="2600" dirty="0">
+                <a:solidFill>
+                  <a:srgbClr val="1F2A22"/>
+                </a:solidFill>
+                <a:latin typeface="Calibri" pitchFamily="34" charset="0"/>
+                <a:ea typeface="Calibri" pitchFamily="34" charset="-122"/>
+                <a:cs typeface="Calibri" pitchFamily="34" charset="-120"/>
+              </a:rPr>
+              <a:t>Waypoints: when the Key Result is checked</a:t>
+            </a:r>
+            <a:endParaRPr lang="en-US" sz="2600" dirty="0"/>
+          </a:p>
+        </p:txBody>
+      </p:sp>
+      <p:sp>
+        <p:nvSpPr>
+          <p:cNvPr id="6" name="Shape 3"/>
+          <p:cNvSpPr/>
+          <p:nvPr/>
+        </p:nvSpPr>
+        <p:spPr>
+          <a:xfrm>
+            <a:off x="548640" y="2656332"/>
+            <a:ext cx="640080" cy="640080"/>
+          </a:xfrm>
+          <a:prstGeom prst="ellipse">
+            <a:avLst/>
+          </a:prstGeom>
+          <a:solidFill>
+            <a:srgbClr val="1A5C2C"/>
+          </a:solidFill>
+          <a:ln w="12700">
+            <a:solidFill>
+              <a:srgbClr val="1A5C2C"/>
+            </a:solidFill>
+            <a:prstDash val="solid"/>
+          </a:ln>
+        </p:spPr>
+        <p:txBody>
+          <a:bodyPr/>
+          <a:lstStyle/>
+          <a:p>
+            <a:endParaRPr lang="en-ZA"/>
+          </a:p>
+        </p:txBody>
+      </p:sp>
+      <p:pic>
+        <p:nvPicPr>
+          <p:cNvPr id="7" name="Image 1" descr="preencoded.png"/>
+          <p:cNvPicPr>
+            <a:picLocks noChangeAspect="1"/>
+          </p:cNvPicPr>
+          <p:nvPr/>
+        </p:nvPicPr>
+        <p:blipFill>
+          <a:blip r:embed="rId9"/>
+          <a:stretch>
+            <a:fillRect/>
+          </a:stretch>
+        </p:blipFill>
+        <p:spPr>
+          <a:xfrm>
+            <a:off x="708660" y="2816352"/>
+            <a:ext cx="320040" cy="320040"/>
+          </a:xfrm>
+          <a:prstGeom prst="rect">
+            <a:avLst/>
+          </a:prstGeom>
+        </p:spPr>
+      </p:pic>
+      <p:sp>
+        <p:nvSpPr>
+          <p:cNvPr id="8" name="Text 4"/>
+          <p:cNvSpPr txBox="1"/>
+          <p:nvPr/>
+        </p:nvSpPr>
+        <p:spPr>
+          <a:xfrm>
+            <a:off x="1508760" y="2487168"/>
+            <a:ext cx="10131552" cy="978408"/>
+          </a:xfrm>
+          <a:prstGeom prst="rect">
+            <a:avLst/>
+          </a:prstGeom>
+          <a:noFill/>
+          <a:ln/>
+        </p:spPr>
+        <p:txBody>
+          <a:bodyPr wrap="square" lIns="0" tIns="0" rIns="0" bIns="0" rtlCol="0" anchor="ctr"/>
+          <a:lstStyle/>
+          <a:p>
+            <a:pPr marL="0" indent="0">
+              <a:buNone/>
+            </a:pPr>
+            <a:r>
+              <a:rPr lang="en-US" sz="2600" b="1" dirty="0">
+                <a:solidFill>
+                  <a:srgbClr val="1A5C2C"/>
+                </a:solidFill>
+                <a:latin typeface="Cambria" pitchFamily="34" charset="0"/>
+                <a:ea typeface="Cambria" pitchFamily="34" charset="-122"/>
+                <a:cs typeface="Cambria" pitchFamily="34" charset="-120"/>
+              </a:rPr>
+              <a:t>A  </a:t>
+            </a:r>
+            <a:r>
+              <a:rPr lang="en-US" sz="2600" dirty="0">
+                <a:solidFill>
+                  <a:srgbClr val="1F2A22"/>
+                </a:solidFill>
+                <a:latin typeface="Calibri" pitchFamily="34" charset="0"/>
+                <a:ea typeface="Calibri" pitchFamily="34" charset="-122"/>
+                <a:cs typeface="Calibri" pitchFamily="34" charset="-120"/>
+              </a:rPr>
+              <a:t>Alert: how far off raises a red flag</a:t>
+            </a:r>
+            <a:endParaRPr lang="en-US" sz="2600" dirty="0"/>
+          </a:p>
+        </p:txBody>
+      </p:sp>
+      <p:sp>
+        <p:nvSpPr>
+          <p:cNvPr id="9" name="Shape 5"/>
+          <p:cNvSpPr/>
+          <p:nvPr/>
+        </p:nvSpPr>
+        <p:spPr>
+          <a:xfrm>
+            <a:off x="548640" y="3634740"/>
+            <a:ext cx="640080" cy="640080"/>
+          </a:xfrm>
+          <a:prstGeom prst="ellipse">
+            <a:avLst/>
+          </a:prstGeom>
+          <a:solidFill>
+            <a:srgbClr val="1A5C2C"/>
+          </a:solidFill>
+          <a:ln w="12700">
+            <a:solidFill>
+              <a:srgbClr val="1A5C2C"/>
+            </a:solidFill>
+            <a:prstDash val="solid"/>
+          </a:ln>
+        </p:spPr>
+        <p:txBody>
+          <a:bodyPr/>
+          <a:lstStyle/>
+          <a:p>
+            <a:endParaRPr lang="en-ZA"/>
+          </a:p>
+        </p:txBody>
+      </p:sp>
+      <p:pic>
+        <p:nvPicPr>
+          <p:cNvPr id="10" name="Image 2" descr="preencoded.png"/>
+          <p:cNvPicPr>
+            <a:picLocks noChangeAspect="1"/>
+          </p:cNvPicPr>
+          <p:nvPr/>
+        </p:nvPicPr>
+        <p:blipFill>
+          <a:blip r:embed="rId10"/>
+          <a:stretch>
+            <a:fillRect/>
+          </a:stretch>
+        </p:blipFill>
+        <p:spPr>
+          <a:xfrm>
+            <a:off x="708660" y="3794760"/>
+            <a:ext cx="320040" cy="320040"/>
+          </a:xfrm>
+          <a:prstGeom prst="rect">
+            <a:avLst/>
+          </a:prstGeom>
+        </p:spPr>
+      </p:pic>
+      <p:sp>
+        <p:nvSpPr>
+          <p:cNvPr id="11" name="Text 6"/>
+          <p:cNvSpPr txBox="1"/>
+          <p:nvPr/>
+        </p:nvSpPr>
+        <p:spPr>
+          <a:xfrm>
+            <a:off x="1508760" y="3465576"/>
+            <a:ext cx="10131552" cy="978408"/>
+          </a:xfrm>
+          <a:prstGeom prst="rect">
+            <a:avLst/>
+          </a:prstGeom>
+          <a:noFill/>
+          <a:ln/>
+        </p:spPr>
+        <p:txBody>
+          <a:bodyPr wrap="square" lIns="0" tIns="0" rIns="0" bIns="0" rtlCol="0" anchor="ctr"/>
+          <a:lstStyle/>
+          <a:p>
+            <a:pPr marL="0" indent="0">
+              <a:buNone/>
+            </a:pPr>
+            <a:r>
+              <a:rPr lang="en-US" sz="2600" b="1" dirty="0">
+                <a:solidFill>
+                  <a:srgbClr val="1A5C2C"/>
+                </a:solidFill>
+                <a:latin typeface="Cambria" pitchFamily="34" charset="0"/>
+                <a:ea typeface="Cambria" pitchFamily="34" charset="-122"/>
+                <a:cs typeface="Cambria" pitchFamily="34" charset="-120"/>
+              </a:rPr>
+              <a:t>R  </a:t>
+            </a:r>
+            <a:r>
+              <a:rPr lang="en-US" sz="2600" dirty="0">
+                <a:solidFill>
+                  <a:srgbClr val="1F2A22"/>
+                </a:solidFill>
+                <a:latin typeface="Calibri" pitchFamily="34" charset="0"/>
+                <a:ea typeface="Calibri" pitchFamily="34" charset="-122"/>
+                <a:cs typeface="Calibri" pitchFamily="34" charset="-120"/>
+              </a:rPr>
+              <a:t>Recovery: for individuals and conditions</a:t>
+            </a:r>
+            <a:endParaRPr lang="en-US" sz="2600" dirty="0"/>
+          </a:p>
+        </p:txBody>
+      </p:sp>
+      <p:sp>
+        <p:nvSpPr>
+          <p:cNvPr id="12" name="Shape 7"/>
+          <p:cNvSpPr/>
+          <p:nvPr/>
+        </p:nvSpPr>
+        <p:spPr>
+          <a:xfrm>
+            <a:off x="548640" y="4613148"/>
+            <a:ext cx="640080" cy="640080"/>
+          </a:xfrm>
+          <a:prstGeom prst="ellipse">
+            <a:avLst/>
+          </a:prstGeom>
+          <a:solidFill>
+            <a:srgbClr val="1A5C2C"/>
+          </a:solidFill>
+          <a:ln w="12700">
+            <a:solidFill>
+              <a:srgbClr val="1A5C2C"/>
+            </a:solidFill>
+            <a:prstDash val="solid"/>
+          </a:ln>
+        </p:spPr>
+        <p:txBody>
+          <a:bodyPr/>
+          <a:lstStyle/>
+          <a:p>
+            <a:endParaRPr lang="en-ZA"/>
+          </a:p>
+        </p:txBody>
+      </p:sp>
+      <p:pic>
+        <p:nvPicPr>
+          <p:cNvPr id="13" name="Image 3" descr="preencoded.png"/>
+          <p:cNvPicPr>
+            <a:picLocks noChangeAspect="1"/>
+          </p:cNvPicPr>
+          <p:nvPr/>
+        </p:nvPicPr>
+        <p:blipFill>
+          <a:blip r:embed="rId4"/>
+          <a:stretch>
+            <a:fillRect/>
+          </a:stretch>
+        </p:blipFill>
+        <p:spPr>
+          <a:xfrm>
+            <a:off x="708660" y="4773168"/>
+            <a:ext cx="320040" cy="320040"/>
+          </a:xfrm>
+          <a:prstGeom prst="rect">
+            <a:avLst/>
+          </a:prstGeom>
+        </p:spPr>
+      </p:pic>
+      <p:sp>
+        <p:nvSpPr>
+          <p:cNvPr id="14" name="Text 8"/>
+          <p:cNvSpPr txBox="1"/>
+          <p:nvPr/>
+        </p:nvSpPr>
+        <p:spPr>
+          <a:xfrm>
+            <a:off x="1508760" y="4443984"/>
+            <a:ext cx="10131552" cy="978408"/>
+          </a:xfrm>
+          <a:prstGeom prst="rect">
+            <a:avLst/>
+          </a:prstGeom>
+          <a:noFill/>
+          <a:ln/>
+        </p:spPr>
+        <p:txBody>
+          <a:bodyPr wrap="square" lIns="0" tIns="0" rIns="0" bIns="0" rtlCol="0" anchor="ctr"/>
+          <a:lstStyle/>
+          <a:p>
+            <a:pPr marL="0" indent="0">
+              <a:buNone/>
+            </a:pPr>
+            <a:r>
+              <a:rPr lang="en-US" sz="2600" b="1" dirty="0">
+                <a:solidFill>
+                  <a:srgbClr val="1A5C2C"/>
+                </a:solidFill>
+                <a:latin typeface="Cambria" pitchFamily="34" charset="0"/>
+                <a:ea typeface="Cambria" pitchFamily="34" charset="-122"/>
+                <a:cs typeface="Cambria" pitchFamily="34" charset="-120"/>
+              </a:rPr>
+              <a:t>D  </a:t>
+            </a:r>
+            <a:r>
+              <a:rPr lang="en-US" sz="2600" dirty="0">
+                <a:solidFill>
+                  <a:srgbClr val="1F2A22"/>
+                </a:solidFill>
+                <a:latin typeface="Calibri" pitchFamily="34" charset="0"/>
+                <a:ea typeface="Calibri" pitchFamily="34" charset="-122"/>
+                <a:cs typeface="Calibri" pitchFamily="34" charset="-120"/>
+              </a:rPr>
+              <a:t>Decider: who decides and acts</a:t>
+            </a:r>
+            <a:endParaRPr lang="en-US" sz="2600" dirty="0"/>
+          </a:p>
+        </p:txBody>
+      </p:sp>
+    </p:spTree>
+  </p:cSld>
+  <p:clrMapOvr>
+    <a:masterClrMapping/>
+  </p:clrMapOvr>
+</p:sld>
+</file>
+
+<file path=ppt/slides/slide34.xml><?xml version="1.0" encoding="utf-8"?>
 <p:sld xmlns:a="http://schemas.openxmlformats.org/drawingml/2006/main" xmlns:r="http://schemas.openxmlformats.org/officeDocument/2006/relationships" xmlns:p="http://schemas.openxmlformats.org/presentationml/2006/main">
   <p:cSld name="Slide 28">
     <p:bg>

</xml_diff>